<commit_message>
Add Detaild of EDA Process in PPT
</commit_message>
<xml_diff>
--- a/Report/Amazon Sales Report.pptx
+++ b/Report/Amazon Sales Report.pptx
@@ -8,8 +8,15 @@
     <p:sldId id="256" r:id="rId2"/>
     <p:sldId id="259" r:id="rId3"/>
     <p:sldId id="257" r:id="rId4"/>
-    <p:sldId id="258" r:id="rId5"/>
-    <p:sldId id="260" r:id="rId6"/>
+    <p:sldId id="262" r:id="rId5"/>
+    <p:sldId id="258" r:id="rId6"/>
+    <p:sldId id="260" r:id="rId7"/>
+    <p:sldId id="261" r:id="rId8"/>
+    <p:sldId id="263" r:id="rId9"/>
+    <p:sldId id="265" r:id="rId10"/>
+    <p:sldId id="266" r:id="rId11"/>
+    <p:sldId id="268" r:id="rId12"/>
+    <p:sldId id="267" r:id="rId13"/>
   </p:sldIdLst>
   <p:sldSz cx="12192000" cy="6858000"/>
   <p:notesSz cx="6858000" cy="9144000"/>
@@ -265,7 +272,7 @@
           <a:p>
             <a:fld id="{5AC7F747-7299-4C92-9E5D-38C4C5A79C2C}" type="datetimeFigureOut">
               <a:rPr lang="en-IN" smtClean="0"/>
-              <a:t>08-11-2025</a:t>
+              <a:t>09-11-2025</a:t>
             </a:fld>
             <a:endParaRPr lang="en-IN"/>
           </a:p>
@@ -465,7 +472,7 @@
           <a:p>
             <a:fld id="{5AC7F747-7299-4C92-9E5D-38C4C5A79C2C}" type="datetimeFigureOut">
               <a:rPr lang="en-IN" smtClean="0"/>
-              <a:t>08-11-2025</a:t>
+              <a:t>09-11-2025</a:t>
             </a:fld>
             <a:endParaRPr lang="en-IN"/>
           </a:p>
@@ -675,7 +682,7 @@
           <a:p>
             <a:fld id="{5AC7F747-7299-4C92-9E5D-38C4C5A79C2C}" type="datetimeFigureOut">
               <a:rPr lang="en-IN" smtClean="0"/>
-              <a:t>08-11-2025</a:t>
+              <a:t>09-11-2025</a:t>
             </a:fld>
             <a:endParaRPr lang="en-IN"/>
           </a:p>
@@ -875,7 +882,7 @@
           <a:p>
             <a:fld id="{5AC7F747-7299-4C92-9E5D-38C4C5A79C2C}" type="datetimeFigureOut">
               <a:rPr lang="en-IN" smtClean="0"/>
-              <a:t>08-11-2025</a:t>
+              <a:t>09-11-2025</a:t>
             </a:fld>
             <a:endParaRPr lang="en-IN"/>
           </a:p>
@@ -1151,7 +1158,7 @@
           <a:p>
             <a:fld id="{5AC7F747-7299-4C92-9E5D-38C4C5A79C2C}" type="datetimeFigureOut">
               <a:rPr lang="en-IN" smtClean="0"/>
-              <a:t>08-11-2025</a:t>
+              <a:t>09-11-2025</a:t>
             </a:fld>
             <a:endParaRPr lang="en-IN"/>
           </a:p>
@@ -1419,7 +1426,7 @@
           <a:p>
             <a:fld id="{5AC7F747-7299-4C92-9E5D-38C4C5A79C2C}" type="datetimeFigureOut">
               <a:rPr lang="en-IN" smtClean="0"/>
-              <a:t>08-11-2025</a:t>
+              <a:t>09-11-2025</a:t>
             </a:fld>
             <a:endParaRPr lang="en-IN"/>
           </a:p>
@@ -1834,7 +1841,7 @@
           <a:p>
             <a:fld id="{5AC7F747-7299-4C92-9E5D-38C4C5A79C2C}" type="datetimeFigureOut">
               <a:rPr lang="en-IN" smtClean="0"/>
-              <a:t>08-11-2025</a:t>
+              <a:t>09-11-2025</a:t>
             </a:fld>
             <a:endParaRPr lang="en-IN"/>
           </a:p>
@@ -1976,7 +1983,7 @@
           <a:p>
             <a:fld id="{5AC7F747-7299-4C92-9E5D-38C4C5A79C2C}" type="datetimeFigureOut">
               <a:rPr lang="en-IN" smtClean="0"/>
-              <a:t>08-11-2025</a:t>
+              <a:t>09-11-2025</a:t>
             </a:fld>
             <a:endParaRPr lang="en-IN"/>
           </a:p>
@@ -2089,7 +2096,7 @@
           <a:p>
             <a:fld id="{5AC7F747-7299-4C92-9E5D-38C4C5A79C2C}" type="datetimeFigureOut">
               <a:rPr lang="en-IN" smtClean="0"/>
-              <a:t>08-11-2025</a:t>
+              <a:t>09-11-2025</a:t>
             </a:fld>
             <a:endParaRPr lang="en-IN"/>
           </a:p>
@@ -2402,7 +2409,7 @@
           <a:p>
             <a:fld id="{5AC7F747-7299-4C92-9E5D-38C4C5A79C2C}" type="datetimeFigureOut">
               <a:rPr lang="en-IN" smtClean="0"/>
-              <a:t>08-11-2025</a:t>
+              <a:t>09-11-2025</a:t>
             </a:fld>
             <a:endParaRPr lang="en-IN"/>
           </a:p>
@@ -2691,7 +2698,7 @@
           <a:p>
             <a:fld id="{5AC7F747-7299-4C92-9E5D-38C4C5A79C2C}" type="datetimeFigureOut">
               <a:rPr lang="en-IN" smtClean="0"/>
-              <a:t>08-11-2025</a:t>
+              <a:t>09-11-2025</a:t>
             </a:fld>
             <a:endParaRPr lang="en-IN"/>
           </a:p>
@@ -2934,7 +2941,7 @@
           <a:p>
             <a:fld id="{5AC7F747-7299-4C92-9E5D-38C4C5A79C2C}" type="datetimeFigureOut">
               <a:rPr lang="en-IN" smtClean="0"/>
-              <a:t>08-11-2025</a:t>
+              <a:t>09-11-2025</a:t>
             </a:fld>
             <a:endParaRPr lang="en-IN"/>
           </a:p>
@@ -3406,7 +3413,7 @@
         <p:spPr>
           <a:xfrm>
             <a:off x="0" y="457200"/>
-            <a:ext cx="9144000" cy="1289304"/>
+            <a:ext cx="9144000" cy="1508760"/>
           </a:xfrm>
         </p:spPr>
         <p:txBody>
@@ -3420,7 +3427,7 @@
                 <a:solidFill>
                   <a:schemeClr val="accent4"/>
                 </a:solidFill>
-                <a:latin typeface="Comic Sans MS" panose="030F0702030302020204" pitchFamily="66" charset="0"/>
+                <a:latin typeface="Bookman Old Style" panose="02050604050505020204" pitchFamily="18" charset="0"/>
               </a:rPr>
               <a:t>Amazon Sales Dashboard </a:t>
             </a:r>
@@ -3429,7 +3436,7 @@
                 <a:solidFill>
                   <a:schemeClr val="bg1"/>
                 </a:solidFill>
-                <a:latin typeface="Comic Sans MS" panose="030F0702030302020204" pitchFamily="66" charset="0"/>
+                <a:latin typeface="Bookman Old Style" panose="02050604050505020204" pitchFamily="18" charset="0"/>
               </a:rPr>
               <a:t>– </a:t>
             </a:r>
@@ -3438,7 +3445,7 @@
                 <a:solidFill>
                   <a:schemeClr val="bg1"/>
                 </a:solidFill>
-                <a:latin typeface="Comic Sans MS" panose="030F0702030302020204" pitchFamily="66" charset="0"/>
+                <a:latin typeface="Bookman Old Style" panose="02050604050505020204" pitchFamily="18" charset="0"/>
               </a:rPr>
               <a:t>Power BI Project</a:t>
             </a:r>
@@ -3453,7 +3460,7 @@
                   </a:srgbClr>
                 </a:outerShdw>
               </a:effectLst>
-              <a:latin typeface="Comic Sans MS" panose="030F0702030302020204" pitchFamily="66" charset="0"/>
+              <a:latin typeface="Bookman Old Style" panose="02050604050505020204" pitchFamily="18" charset="0"/>
             </a:endParaRPr>
           </a:p>
         </p:txBody>
@@ -3492,7 +3499,7 @@
                 <a:solidFill>
                   <a:schemeClr val="bg1"/>
                 </a:solidFill>
-                <a:latin typeface="Comic Sans MS" panose="030F0702030302020204" pitchFamily="66" charset="0"/>
+                <a:latin typeface="Bookman Old Style" panose="02050604050505020204" pitchFamily="18" charset="0"/>
               </a:rPr>
               <a:t>Guided By: Abhishek </a:t>
             </a:r>
@@ -3501,7 +3508,7 @@
                 <a:solidFill>
                   <a:schemeClr val="bg1"/>
                 </a:solidFill>
-                <a:latin typeface="Comic Sans MS" panose="030F0702030302020204" pitchFamily="66" charset="0"/>
+                <a:latin typeface="Bookman Old Style" panose="02050604050505020204" pitchFamily="18" charset="0"/>
               </a:rPr>
               <a:t>Wahaval</a:t>
             </a:r>
@@ -3509,7 +3516,7 @@
               <a:solidFill>
                 <a:schemeClr val="bg1"/>
               </a:solidFill>
-              <a:latin typeface="Comic Sans MS" panose="030F0702030302020204" pitchFamily="66" charset="0"/>
+              <a:latin typeface="Bookman Old Style" panose="02050604050505020204" pitchFamily="18" charset="0"/>
             </a:endParaRPr>
           </a:p>
         </p:txBody>
@@ -3518,6 +3525,839 @@
     <p:extLst>
       <p:ext uri="{BB962C8B-B14F-4D97-AF65-F5344CB8AC3E}">
         <p14:creationId xmlns:p14="http://schemas.microsoft.com/office/powerpoint/2010/main" val="148870643"/>
+      </p:ext>
+    </p:extLst>
+  </p:cSld>
+  <p:clrMapOvr>
+    <a:masterClrMapping/>
+  </p:clrMapOvr>
+</p:sld>
+</file>
+
+<file path=ppt/slides/slide10.xml><?xml version="1.0" encoding="utf-8"?>
+<p:sld xmlns:a="http://schemas.openxmlformats.org/drawingml/2006/main" xmlns:r="http://schemas.openxmlformats.org/officeDocument/2006/relationships" xmlns:p="http://schemas.openxmlformats.org/presentationml/2006/main">
+  <p:cSld>
+    <p:spTree>
+      <p:nvGrpSpPr>
+        <p:cNvPr id="1" name="">
+          <a:extLst>
+            <a:ext uri="{FF2B5EF4-FFF2-40B4-BE49-F238E27FC236}">
+              <a16:creationId xmlns:a16="http://schemas.microsoft.com/office/drawing/2014/main" id="{50FF9B61-0403-6A12-5DDD-0610BA4CADB5}"/>
+            </a:ext>
+          </a:extLst>
+        </p:cNvPr>
+        <p:cNvGrpSpPr/>
+        <p:nvPr/>
+      </p:nvGrpSpPr>
+      <p:grpSpPr>
+        <a:xfrm>
+          <a:off x="0" y="0"/>
+          <a:ext cx="0" cy="0"/>
+          <a:chOff x="0" y="0"/>
+          <a:chExt cx="0" cy="0"/>
+        </a:xfrm>
+      </p:grpSpPr>
+      <p:pic>
+        <p:nvPicPr>
+          <p:cNvPr id="4" name="Picture 3">
+            <a:extLst>
+              <a:ext uri="{FF2B5EF4-FFF2-40B4-BE49-F238E27FC236}">
+                <a16:creationId xmlns:a16="http://schemas.microsoft.com/office/drawing/2014/main" id="{E6D4575D-812C-AB9E-FAC6-B52E60813497}"/>
+              </a:ext>
+            </a:extLst>
+          </p:cNvPr>
+          <p:cNvPicPr>
+            <a:picLocks noChangeAspect="1"/>
+          </p:cNvPicPr>
+          <p:nvPr/>
+        </p:nvPicPr>
+        <p:blipFill>
+          <a:blip r:embed="rId2">
+            <a:extLst>
+              <a:ext uri="{28A0092B-C50C-407E-A947-70E740481C1C}">
+                <a14:useLocalDpi xmlns:a14="http://schemas.microsoft.com/office/drawing/2010/main" val="0"/>
+              </a:ext>
+            </a:extLst>
+          </a:blip>
+          <a:stretch>
+            <a:fillRect/>
+          </a:stretch>
+        </p:blipFill>
+        <p:spPr>
+          <a:xfrm>
+            <a:off x="0" y="0"/>
+            <a:ext cx="12192000" cy="6858000"/>
+          </a:xfrm>
+          <a:prstGeom prst="rect">
+            <a:avLst/>
+          </a:prstGeom>
+          <a:ln>
+            <a:noFill/>
+          </a:ln>
+          <a:effectLst>
+            <a:softEdge rad="112500"/>
+          </a:effectLst>
+        </p:spPr>
+      </p:pic>
+      <p:sp>
+        <p:nvSpPr>
+          <p:cNvPr id="5" name="TextBox 4">
+            <a:extLst>
+              <a:ext uri="{FF2B5EF4-FFF2-40B4-BE49-F238E27FC236}">
+                <a16:creationId xmlns:a16="http://schemas.microsoft.com/office/drawing/2014/main" id="{69F38AD9-1B22-A88A-3377-DCF974FE80C8}"/>
+              </a:ext>
+            </a:extLst>
+          </p:cNvPr>
+          <p:cNvSpPr txBox="1"/>
+          <p:nvPr/>
+        </p:nvSpPr>
+        <p:spPr>
+          <a:xfrm>
+            <a:off x="6096000" y="1929152"/>
+            <a:ext cx="5916167" cy="2862322"/>
+          </a:xfrm>
+          <a:prstGeom prst="rect">
+            <a:avLst/>
+          </a:prstGeom>
+          <a:noFill/>
+        </p:spPr>
+        <p:txBody>
+          <a:bodyPr wrap="square" rtlCol="0">
+            <a:spAutoFit/>
+          </a:bodyPr>
+          <a:lstStyle/>
+          <a:p>
+            <a:r>
+              <a:rPr lang="en-IN" sz="6000" dirty="0">
+                <a:solidFill>
+                  <a:schemeClr val="bg1"/>
+                </a:solidFill>
+                <a:latin typeface="Bookman Old Style" panose="02050604050505020204" pitchFamily="18" charset="0"/>
+              </a:rPr>
+              <a:t>Exploratory Data Analysis (EDA)</a:t>
+            </a:r>
+          </a:p>
+        </p:txBody>
+      </p:sp>
+      <p:sp>
+        <p:nvSpPr>
+          <p:cNvPr id="7" name="Flowchart: Connector 6">
+            <a:extLst>
+              <a:ext uri="{FF2B5EF4-FFF2-40B4-BE49-F238E27FC236}">
+                <a16:creationId xmlns:a16="http://schemas.microsoft.com/office/drawing/2014/main" id="{4B65826D-14B7-716A-DE19-0CE800D9F167}"/>
+              </a:ext>
+            </a:extLst>
+          </p:cNvPr>
+          <p:cNvSpPr/>
+          <p:nvPr/>
+        </p:nvSpPr>
+        <p:spPr>
+          <a:xfrm>
+            <a:off x="8207764" y="795769"/>
+            <a:ext cx="1080000" cy="1080000"/>
+          </a:xfrm>
+          <a:prstGeom prst="flowChartConnector">
+            <a:avLst/>
+          </a:prstGeom>
+          <a:noFill/>
+          <a:ln>
+            <a:solidFill>
+              <a:schemeClr val="accent4"/>
+            </a:solidFill>
+          </a:ln>
+        </p:spPr>
+        <p:style>
+          <a:lnRef idx="2">
+            <a:schemeClr val="accent1">
+              <a:shade val="15000"/>
+            </a:schemeClr>
+          </a:lnRef>
+          <a:fillRef idx="1">
+            <a:schemeClr val="accent1"/>
+          </a:fillRef>
+          <a:effectRef idx="0">
+            <a:schemeClr val="accent1"/>
+          </a:effectRef>
+          <a:fontRef idx="minor">
+            <a:schemeClr val="lt1"/>
+          </a:fontRef>
+        </p:style>
+        <p:txBody>
+          <a:bodyPr rtlCol="0" anchor="ctr"/>
+          <a:lstStyle/>
+          <a:p>
+            <a:pPr algn="ctr"/>
+            <a:r>
+              <a:rPr lang="en-IN" sz="3600" dirty="0">
+                <a:solidFill>
+                  <a:schemeClr val="accent4"/>
+                </a:solidFill>
+                <a:effectLst>
+                  <a:outerShdw blurRad="50800" dist="38100" dir="2700000" algn="tl" rotWithShape="0">
+                    <a:prstClr val="black">
+                      <a:alpha val="40000"/>
+                    </a:prstClr>
+                  </a:outerShdw>
+                </a:effectLst>
+                <a:latin typeface="Bookman Old Style" panose="02050604050505020204" pitchFamily="18" charset="0"/>
+              </a:rPr>
+              <a:t>02</a:t>
+            </a:r>
+          </a:p>
+        </p:txBody>
+      </p:sp>
+      <p:pic>
+        <p:nvPicPr>
+          <p:cNvPr id="9" name="Picture 8">
+            <a:extLst>
+              <a:ext uri="{FF2B5EF4-FFF2-40B4-BE49-F238E27FC236}">
+                <a16:creationId xmlns:a16="http://schemas.microsoft.com/office/drawing/2014/main" id="{BD49623C-80C3-F518-8288-EAFAF3709D45}"/>
+              </a:ext>
+            </a:extLst>
+          </p:cNvPr>
+          <p:cNvPicPr>
+            <a:picLocks noChangeAspect="1"/>
+          </p:cNvPicPr>
+          <p:nvPr/>
+        </p:nvPicPr>
+        <p:blipFill>
+          <a:blip r:embed="rId3">
+            <a:extLst>
+              <a:ext uri="{28A0092B-C50C-407E-A947-70E740481C1C}">
+                <a14:useLocalDpi xmlns:a14="http://schemas.microsoft.com/office/drawing/2010/main" val="0"/>
+              </a:ext>
+            </a:extLst>
+          </a:blip>
+          <a:srcRect/>
+          <a:stretch/>
+        </p:blipFill>
+        <p:spPr>
+          <a:xfrm>
+            <a:off x="1010522" y="1247758"/>
+            <a:ext cx="4362483" cy="4362483"/>
+          </a:xfrm>
+          <a:prstGeom prst="roundRect">
+            <a:avLst>
+              <a:gd name="adj" fmla="val 16667"/>
+            </a:avLst>
+          </a:prstGeom>
+          <a:ln>
+            <a:solidFill>
+              <a:schemeClr val="accent4"/>
+            </a:solidFill>
+          </a:ln>
+          <a:effectLst>
+            <a:outerShdw blurRad="152400" dist="12000" dir="900000" sy="98000" kx="110000" ky="200000" algn="tl" rotWithShape="0">
+              <a:srgbClr val="000000">
+                <a:alpha val="30000"/>
+              </a:srgbClr>
+            </a:outerShdw>
+          </a:effectLst>
+          <a:scene3d>
+            <a:camera prst="perspectiveRelaxed">
+              <a:rot lat="19800000" lon="1200000" rev="20820000"/>
+            </a:camera>
+            <a:lightRig rig="threePt" dir="t"/>
+          </a:scene3d>
+          <a:sp3d contourW="6350" prstMaterial="matte">
+            <a:bevelT w="101600" h="101600"/>
+            <a:contourClr>
+              <a:srgbClr val="969696"/>
+            </a:contourClr>
+          </a:sp3d>
+        </p:spPr>
+      </p:pic>
+    </p:spTree>
+    <p:extLst>
+      <p:ext uri="{BB962C8B-B14F-4D97-AF65-F5344CB8AC3E}">
+        <p14:creationId xmlns:p14="http://schemas.microsoft.com/office/powerpoint/2010/main" val="4036346845"/>
+      </p:ext>
+    </p:extLst>
+  </p:cSld>
+  <p:clrMapOvr>
+    <a:masterClrMapping/>
+  </p:clrMapOvr>
+</p:sld>
+</file>
+
+<file path=ppt/slides/slide11.xml><?xml version="1.0" encoding="utf-8"?>
+<p:sld xmlns:a="http://schemas.openxmlformats.org/drawingml/2006/main" xmlns:r="http://schemas.openxmlformats.org/officeDocument/2006/relationships" xmlns:p="http://schemas.openxmlformats.org/presentationml/2006/main">
+  <p:cSld>
+    <p:bg>
+      <p:bgPr>
+        <a:solidFill>
+          <a:schemeClr val="bg1"/>
+        </a:solidFill>
+        <a:effectLst/>
+      </p:bgPr>
+    </p:bg>
+    <p:spTree>
+      <p:nvGrpSpPr>
+        <p:cNvPr id="1" name=""/>
+        <p:cNvGrpSpPr/>
+        <p:nvPr/>
+      </p:nvGrpSpPr>
+      <p:grpSpPr>
+        <a:xfrm>
+          <a:off x="0" y="0"/>
+          <a:ext cx="0" cy="0"/>
+          <a:chOff x="0" y="0"/>
+          <a:chExt cx="0" cy="0"/>
+        </a:xfrm>
+      </p:grpSpPr>
+      <p:pic>
+        <p:nvPicPr>
+          <p:cNvPr id="3" name="Picture 2">
+            <a:extLst>
+              <a:ext uri="{FF2B5EF4-FFF2-40B4-BE49-F238E27FC236}">
+                <a16:creationId xmlns:a16="http://schemas.microsoft.com/office/drawing/2014/main" id="{971B5CDD-5DCF-C5FE-2E73-549DC3C49BBD}"/>
+              </a:ext>
+            </a:extLst>
+          </p:cNvPr>
+          <p:cNvPicPr>
+            <a:picLocks noChangeAspect="1"/>
+          </p:cNvPicPr>
+          <p:nvPr/>
+        </p:nvPicPr>
+        <p:blipFill>
+          <a:blip r:embed="rId2">
+            <a:extLst>
+              <a:ext uri="{28A0092B-C50C-407E-A947-70E740481C1C}">
+                <a14:useLocalDpi xmlns:a14="http://schemas.microsoft.com/office/drawing/2010/main" val="0"/>
+              </a:ext>
+            </a:extLst>
+          </a:blip>
+          <a:stretch>
+            <a:fillRect/>
+          </a:stretch>
+        </p:blipFill>
+        <p:spPr>
+          <a:xfrm>
+            <a:off x="0" y="0"/>
+            <a:ext cx="12192000" cy="6858000"/>
+          </a:xfrm>
+          <a:prstGeom prst="rect">
+            <a:avLst/>
+          </a:prstGeom>
+          <a:ln>
+            <a:noFill/>
+          </a:ln>
+          <a:effectLst>
+            <a:softEdge rad="112500"/>
+          </a:effectLst>
+        </p:spPr>
+      </p:pic>
+      <p:pic>
+        <p:nvPicPr>
+          <p:cNvPr id="5" name="Picture 4">
+            <a:extLst>
+              <a:ext uri="{FF2B5EF4-FFF2-40B4-BE49-F238E27FC236}">
+                <a16:creationId xmlns:a16="http://schemas.microsoft.com/office/drawing/2014/main" id="{C7C6C067-8CE0-A59C-0957-03D1774F26F5}"/>
+              </a:ext>
+            </a:extLst>
+          </p:cNvPr>
+          <p:cNvPicPr>
+            <a:picLocks noChangeAspect="1"/>
+          </p:cNvPicPr>
+          <p:nvPr/>
+        </p:nvPicPr>
+        <p:blipFill>
+          <a:blip r:embed="rId3">
+            <a:extLst>
+              <a:ext uri="{28A0092B-C50C-407E-A947-70E740481C1C}">
+                <a14:useLocalDpi xmlns:a14="http://schemas.microsoft.com/office/drawing/2010/main" val="0"/>
+              </a:ext>
+            </a:extLst>
+          </a:blip>
+          <a:srcRect l="42112"/>
+          <a:stretch>
+            <a:fillRect/>
+          </a:stretch>
+        </p:blipFill>
+        <p:spPr>
+          <a:xfrm>
+            <a:off x="5769864" y="155448"/>
+            <a:ext cx="6245352" cy="6528816"/>
+          </a:xfrm>
+          <a:prstGeom prst="rect">
+            <a:avLst/>
+          </a:prstGeom>
+          <a:noFill/>
+          <a:effectLst>
+            <a:softEdge rad="1270000"/>
+          </a:effectLst>
+        </p:spPr>
+      </p:pic>
+      <p:sp>
+        <p:nvSpPr>
+          <p:cNvPr id="6" name="TextBox 5">
+            <a:extLst>
+              <a:ext uri="{FF2B5EF4-FFF2-40B4-BE49-F238E27FC236}">
+                <a16:creationId xmlns:a16="http://schemas.microsoft.com/office/drawing/2014/main" id="{0FDF103C-A860-2366-D5E7-19006505EB89}"/>
+              </a:ext>
+            </a:extLst>
+          </p:cNvPr>
+          <p:cNvSpPr txBox="1"/>
+          <p:nvPr/>
+        </p:nvSpPr>
+        <p:spPr>
+          <a:xfrm>
+            <a:off x="348234" y="780961"/>
+            <a:ext cx="6245352" cy="1323439"/>
+          </a:xfrm>
+          <a:prstGeom prst="rect">
+            <a:avLst/>
+          </a:prstGeom>
+          <a:noFill/>
+        </p:spPr>
+        <p:txBody>
+          <a:bodyPr wrap="square">
+            <a:spAutoFit/>
+          </a:bodyPr>
+          <a:lstStyle/>
+          <a:p>
+            <a:r>
+              <a:rPr lang="en-US" sz="2000" dirty="0">
+                <a:solidFill>
+                  <a:schemeClr val="bg1"/>
+                </a:solidFill>
+                <a:latin typeface="Bookman Old Style" panose="02050604050505020204" pitchFamily="18" charset="0"/>
+              </a:rPr>
+              <a:t>The EDA phase focused on understanding, cleaning, and preparing the Amazon sales data for visualization and insights.</a:t>
+            </a:r>
+            <a:br>
+              <a:rPr lang="en-US" sz="2000" dirty="0">
+                <a:solidFill>
+                  <a:schemeClr val="bg1"/>
+                </a:solidFill>
+                <a:latin typeface="Bookman Old Style" panose="02050604050505020204" pitchFamily="18" charset="0"/>
+              </a:rPr>
+            </a:br>
+            <a:r>
+              <a:rPr lang="en-US" sz="2000" dirty="0">
+                <a:solidFill>
+                  <a:schemeClr val="bg1"/>
+                </a:solidFill>
+                <a:latin typeface="Bookman Old Style" panose="02050604050505020204" pitchFamily="18" charset="0"/>
+              </a:rPr>
+              <a:t>Key steps performed:</a:t>
+            </a:r>
+          </a:p>
+        </p:txBody>
+      </p:sp>
+      <p:sp>
+        <p:nvSpPr>
+          <p:cNvPr id="8" name="TextBox 7">
+            <a:extLst>
+              <a:ext uri="{FF2B5EF4-FFF2-40B4-BE49-F238E27FC236}">
+                <a16:creationId xmlns:a16="http://schemas.microsoft.com/office/drawing/2014/main" id="{8043DE3D-EFC0-BE6A-2343-0EF193CC68ED}"/>
+              </a:ext>
+            </a:extLst>
+          </p:cNvPr>
+          <p:cNvSpPr txBox="1"/>
+          <p:nvPr/>
+        </p:nvSpPr>
+        <p:spPr>
+          <a:xfrm>
+            <a:off x="422910" y="2259848"/>
+            <a:ext cx="6096000" cy="3477875"/>
+          </a:xfrm>
+          <a:prstGeom prst="rect">
+            <a:avLst/>
+          </a:prstGeom>
+          <a:noFill/>
+        </p:spPr>
+        <p:txBody>
+          <a:bodyPr wrap="square">
+            <a:spAutoFit/>
+          </a:bodyPr>
+          <a:lstStyle/>
+          <a:p>
+            <a:pPr marL="285750" indent="-285750">
+              <a:buClr>
+                <a:schemeClr val="bg1"/>
+              </a:buClr>
+              <a:buFont typeface="Wingdings" panose="05000000000000000000" pitchFamily="2" charset="2"/>
+              <a:buChar char="v"/>
+            </a:pPr>
+            <a:r>
+              <a:rPr lang="en-US" sz="2000" dirty="0">
+                <a:solidFill>
+                  <a:schemeClr val="bg1"/>
+                </a:solidFill>
+                <a:latin typeface="Bookman Old Style" panose="02050604050505020204" pitchFamily="18" charset="0"/>
+              </a:rPr>
+              <a:t>Data Profiling: Checked data types, null values, duplicates, and inconsistent entries.</a:t>
+            </a:r>
+          </a:p>
+          <a:p>
+            <a:pPr>
+              <a:buClr>
+                <a:schemeClr val="bg1"/>
+              </a:buClr>
+            </a:pPr>
+            <a:endParaRPr lang="en-US" sz="2000" dirty="0">
+              <a:solidFill>
+                <a:schemeClr val="bg1"/>
+              </a:solidFill>
+              <a:latin typeface="Bookman Old Style" panose="02050604050505020204" pitchFamily="18" charset="0"/>
+            </a:endParaRPr>
+          </a:p>
+          <a:p>
+            <a:pPr marL="285750" indent="-285750">
+              <a:buClr>
+                <a:schemeClr val="bg1"/>
+              </a:buClr>
+              <a:buFont typeface="Wingdings" panose="05000000000000000000" pitchFamily="2" charset="2"/>
+              <a:buChar char="v"/>
+            </a:pPr>
+            <a:r>
+              <a:rPr lang="en-US" sz="2000" dirty="0">
+                <a:solidFill>
+                  <a:schemeClr val="bg1"/>
+                </a:solidFill>
+                <a:latin typeface="Bookman Old Style" panose="02050604050505020204" pitchFamily="18" charset="0"/>
+              </a:rPr>
+              <a:t>Column Standardization: Renamed and formatted columns for better readability (e.g., Order Date, Total Amount, Fulfilment Type).</a:t>
+            </a:r>
+          </a:p>
+          <a:p>
+            <a:pPr>
+              <a:buClr>
+                <a:schemeClr val="bg1"/>
+              </a:buClr>
+            </a:pPr>
+            <a:endParaRPr lang="en-US" sz="2000" dirty="0">
+              <a:solidFill>
+                <a:schemeClr val="bg1"/>
+              </a:solidFill>
+              <a:latin typeface="Bookman Old Style" panose="02050604050505020204" pitchFamily="18" charset="0"/>
+            </a:endParaRPr>
+          </a:p>
+          <a:p>
+            <a:pPr marL="285750" indent="-285750">
+              <a:buClr>
+                <a:schemeClr val="bg1"/>
+              </a:buClr>
+              <a:buFont typeface="Wingdings" panose="05000000000000000000" pitchFamily="2" charset="2"/>
+              <a:buChar char="v"/>
+            </a:pPr>
+            <a:r>
+              <a:rPr lang="en-US" sz="2000" dirty="0">
+                <a:solidFill>
+                  <a:schemeClr val="bg1"/>
+                </a:solidFill>
+                <a:latin typeface="Bookman Old Style" panose="02050604050505020204" pitchFamily="18" charset="0"/>
+              </a:rPr>
+              <a:t>Missing Value Handling: Cleaned or replaced missing and invalid entries (like blank cities or order statuses).</a:t>
+            </a:r>
+          </a:p>
+        </p:txBody>
+      </p:sp>
+    </p:spTree>
+    <p:extLst>
+      <p:ext uri="{BB962C8B-B14F-4D97-AF65-F5344CB8AC3E}">
+        <p14:creationId xmlns:p14="http://schemas.microsoft.com/office/powerpoint/2010/main" val="2837048034"/>
+      </p:ext>
+    </p:extLst>
+  </p:cSld>
+  <p:clrMapOvr>
+    <a:masterClrMapping/>
+  </p:clrMapOvr>
+</p:sld>
+</file>
+
+<file path=ppt/slides/slide12.xml><?xml version="1.0" encoding="utf-8"?>
+<p:sld xmlns:a="http://schemas.openxmlformats.org/drawingml/2006/main" xmlns:r="http://schemas.openxmlformats.org/officeDocument/2006/relationships" xmlns:p="http://schemas.openxmlformats.org/presentationml/2006/main">
+  <p:cSld>
+    <p:spTree>
+      <p:nvGrpSpPr>
+        <p:cNvPr id="1" name=""/>
+        <p:cNvGrpSpPr/>
+        <p:nvPr/>
+      </p:nvGrpSpPr>
+      <p:grpSpPr>
+        <a:xfrm>
+          <a:off x="0" y="0"/>
+          <a:ext cx="0" cy="0"/>
+          <a:chOff x="0" y="0"/>
+          <a:chExt cx="0" cy="0"/>
+        </a:xfrm>
+      </p:grpSpPr>
+      <p:pic>
+        <p:nvPicPr>
+          <p:cNvPr id="3" name="Picture 2">
+            <a:extLst>
+              <a:ext uri="{FF2B5EF4-FFF2-40B4-BE49-F238E27FC236}">
+                <a16:creationId xmlns:a16="http://schemas.microsoft.com/office/drawing/2014/main" id="{DE8D9DD3-9AD0-7ABD-4166-B64AF60650AE}"/>
+              </a:ext>
+            </a:extLst>
+          </p:cNvPr>
+          <p:cNvPicPr>
+            <a:picLocks noChangeAspect="1"/>
+          </p:cNvPicPr>
+          <p:nvPr/>
+        </p:nvPicPr>
+        <p:blipFill>
+          <a:blip r:embed="rId2">
+            <a:extLst>
+              <a:ext uri="{28A0092B-C50C-407E-A947-70E740481C1C}">
+                <a14:useLocalDpi xmlns:a14="http://schemas.microsoft.com/office/drawing/2010/main" val="0"/>
+              </a:ext>
+            </a:extLst>
+          </a:blip>
+          <a:stretch>
+            <a:fillRect/>
+          </a:stretch>
+        </p:blipFill>
+        <p:spPr>
+          <a:xfrm>
+            <a:off x="0" y="0"/>
+            <a:ext cx="12192000" cy="6858000"/>
+          </a:xfrm>
+          <a:prstGeom prst="rect">
+            <a:avLst/>
+          </a:prstGeom>
+          <a:ln>
+            <a:noFill/>
+          </a:ln>
+          <a:effectLst>
+            <a:softEdge rad="112500"/>
+          </a:effectLst>
+        </p:spPr>
+      </p:pic>
+      <p:sp>
+        <p:nvSpPr>
+          <p:cNvPr id="4" name="TextBox 3">
+            <a:extLst>
+              <a:ext uri="{FF2B5EF4-FFF2-40B4-BE49-F238E27FC236}">
+                <a16:creationId xmlns:a16="http://schemas.microsoft.com/office/drawing/2014/main" id="{5038E35C-6E79-35DA-E71D-5BE4419B1A39}"/>
+              </a:ext>
+            </a:extLst>
+          </p:cNvPr>
+          <p:cNvSpPr txBox="1"/>
+          <p:nvPr/>
+        </p:nvSpPr>
+        <p:spPr>
+          <a:xfrm>
+            <a:off x="5953125" y="766732"/>
+            <a:ext cx="5751946" cy="5324535"/>
+          </a:xfrm>
+          <a:prstGeom prst="rect">
+            <a:avLst/>
+          </a:prstGeom>
+          <a:noFill/>
+        </p:spPr>
+        <p:txBody>
+          <a:bodyPr wrap="square">
+            <a:spAutoFit/>
+          </a:bodyPr>
+          <a:lstStyle/>
+          <a:p>
+            <a:pPr>
+              <a:buClr>
+                <a:schemeClr val="bg1"/>
+              </a:buClr>
+            </a:pPr>
+            <a:endParaRPr lang="en-US" sz="2000" dirty="0">
+              <a:solidFill>
+                <a:schemeClr val="bg1"/>
+              </a:solidFill>
+              <a:latin typeface="Bookman Old Style" panose="02050604050505020204" pitchFamily="18" charset="0"/>
+            </a:endParaRPr>
+          </a:p>
+          <a:p>
+            <a:pPr marL="285750" indent="-285750">
+              <a:buClr>
+                <a:schemeClr val="bg1"/>
+              </a:buClr>
+              <a:buFont typeface="Wingdings" panose="05000000000000000000" pitchFamily="2" charset="2"/>
+              <a:buChar char="v"/>
+            </a:pPr>
+            <a:r>
+              <a:rPr lang="en-US" sz="2000" dirty="0">
+                <a:solidFill>
+                  <a:schemeClr val="bg1"/>
+                </a:solidFill>
+                <a:latin typeface="Bookman Old Style" panose="02050604050505020204" pitchFamily="18" charset="0"/>
+              </a:rPr>
+              <a:t>Outlier Detection: Identified unusual sales values or quantities to ensure accurate analysis.</a:t>
+            </a:r>
+          </a:p>
+          <a:p>
+            <a:pPr>
+              <a:buClr>
+                <a:schemeClr val="bg1"/>
+              </a:buClr>
+            </a:pPr>
+            <a:endParaRPr lang="en-US" sz="2000" dirty="0">
+              <a:solidFill>
+                <a:schemeClr val="bg1"/>
+              </a:solidFill>
+              <a:latin typeface="Bookman Old Style" panose="02050604050505020204" pitchFamily="18" charset="0"/>
+            </a:endParaRPr>
+          </a:p>
+          <a:p>
+            <a:pPr marL="285750" indent="-285750">
+              <a:buClr>
+                <a:schemeClr val="bg1"/>
+              </a:buClr>
+              <a:buFont typeface="Wingdings" panose="05000000000000000000" pitchFamily="2" charset="2"/>
+              <a:buChar char="v"/>
+            </a:pPr>
+            <a:r>
+              <a:rPr lang="en-US" sz="2000" dirty="0">
+                <a:solidFill>
+                  <a:schemeClr val="bg1"/>
+                </a:solidFill>
+                <a:latin typeface="Bookman Old Style" panose="02050604050505020204" pitchFamily="18" charset="0"/>
+              </a:rPr>
+              <a:t>Derived Columns Creation: Added new columns such as Month, Year, Category Group, Order Status Group, and B2B flag for trend analysis.</a:t>
+            </a:r>
+          </a:p>
+          <a:p>
+            <a:pPr>
+              <a:buClr>
+                <a:schemeClr val="bg1"/>
+              </a:buClr>
+            </a:pPr>
+            <a:endParaRPr lang="en-US" sz="2000" dirty="0">
+              <a:solidFill>
+                <a:schemeClr val="bg1"/>
+              </a:solidFill>
+              <a:latin typeface="Bookman Old Style" panose="02050604050505020204" pitchFamily="18" charset="0"/>
+            </a:endParaRPr>
+          </a:p>
+          <a:p>
+            <a:pPr marL="285750" indent="-285750">
+              <a:buClr>
+                <a:schemeClr val="bg1"/>
+              </a:buClr>
+              <a:buFont typeface="Wingdings" panose="05000000000000000000" pitchFamily="2" charset="2"/>
+              <a:buChar char="v"/>
+            </a:pPr>
+            <a:r>
+              <a:rPr lang="en-US" sz="2000" dirty="0">
+                <a:solidFill>
+                  <a:schemeClr val="bg1"/>
+                </a:solidFill>
+                <a:latin typeface="Bookman Old Style" panose="02050604050505020204" pitchFamily="18" charset="0"/>
+              </a:rPr>
+              <a:t>Data Validation: Verified total order counts, total sales, and category totals to ensure data consistency.</a:t>
+            </a:r>
+          </a:p>
+          <a:p>
+            <a:pPr>
+              <a:buClr>
+                <a:schemeClr val="bg1"/>
+              </a:buClr>
+            </a:pPr>
+            <a:endParaRPr lang="en-US" sz="2000" dirty="0">
+              <a:solidFill>
+                <a:schemeClr val="bg1"/>
+              </a:solidFill>
+              <a:latin typeface="Bookman Old Style" panose="02050604050505020204" pitchFamily="18" charset="0"/>
+            </a:endParaRPr>
+          </a:p>
+          <a:p>
+            <a:pPr marL="342900" indent="-342900">
+              <a:buClr>
+                <a:schemeClr val="accent6"/>
+              </a:buClr>
+              <a:buFont typeface="Wingdings" panose="05000000000000000000" pitchFamily="2" charset="2"/>
+              <a:buChar char="ü"/>
+            </a:pPr>
+            <a:r>
+              <a:rPr lang="en-US" sz="2000" dirty="0">
+                <a:solidFill>
+                  <a:schemeClr val="bg1"/>
+                </a:solidFill>
+                <a:latin typeface="Bookman Old Style" panose="02050604050505020204" pitchFamily="18" charset="0"/>
+              </a:rPr>
+              <a:t>All transformations were performed within Power Query Editor before loading data into Power BI for reporting.</a:t>
+            </a:r>
+            <a:endParaRPr lang="en-IN" sz="2000" dirty="0">
+              <a:solidFill>
+                <a:schemeClr val="bg1"/>
+              </a:solidFill>
+              <a:latin typeface="Bookman Old Style" panose="02050604050505020204" pitchFamily="18" charset="0"/>
+            </a:endParaRPr>
+          </a:p>
+        </p:txBody>
+      </p:sp>
+      <p:pic>
+        <p:nvPicPr>
+          <p:cNvPr id="5" name="Picture 4">
+            <a:extLst>
+              <a:ext uri="{FF2B5EF4-FFF2-40B4-BE49-F238E27FC236}">
+                <a16:creationId xmlns:a16="http://schemas.microsoft.com/office/drawing/2014/main" id="{616D1A66-ECF6-81C6-2ECC-C85194A9910D}"/>
+              </a:ext>
+            </a:extLst>
+          </p:cNvPr>
+          <p:cNvPicPr>
+            <a:picLocks noChangeAspect="1"/>
+          </p:cNvPicPr>
+          <p:nvPr/>
+        </p:nvPicPr>
+        <p:blipFill>
+          <a:blip r:embed="rId3">
+            <a:extLst>
+              <a:ext uri="{28A0092B-C50C-407E-A947-70E740481C1C}">
+                <a14:useLocalDpi xmlns:a14="http://schemas.microsoft.com/office/drawing/2010/main" val="0"/>
+              </a:ext>
+            </a:extLst>
+          </a:blip>
+          <a:srcRect l="36381"/>
+          <a:stretch>
+            <a:fillRect/>
+          </a:stretch>
+        </p:blipFill>
+        <p:spPr>
+          <a:xfrm>
+            <a:off x="771525" y="1404936"/>
+            <a:ext cx="4578446" cy="4048125"/>
+          </a:xfrm>
+          <a:prstGeom prst="rect">
+            <a:avLst/>
+          </a:prstGeom>
+          <a:solidFill>
+            <a:srgbClr val="FFFFFF">
+              <a:shade val="85000"/>
+            </a:srgbClr>
+          </a:solidFill>
+          <a:ln w="190500" cap="sq">
+            <a:solidFill>
+              <a:srgbClr val="FFFFFF"/>
+            </a:solidFill>
+            <a:miter lim="800000"/>
+          </a:ln>
+          <a:effectLst>
+            <a:outerShdw blurRad="65000" dist="50800" dir="12900000" kx="195000" ky="145000" algn="tl" rotWithShape="0">
+              <a:srgbClr val="000000">
+                <a:alpha val="30000"/>
+              </a:srgbClr>
+            </a:outerShdw>
+          </a:effectLst>
+          <a:scene3d>
+            <a:camera prst="orthographicFront">
+              <a:rot lat="0" lon="0" rev="360000"/>
+            </a:camera>
+            <a:lightRig rig="twoPt" dir="t">
+              <a:rot lat="0" lon="0" rev="7200000"/>
+            </a:lightRig>
+          </a:scene3d>
+          <a:sp3d contourW="12700">
+            <a:bevelT w="25400" h="19050"/>
+            <a:contourClr>
+              <a:srgbClr val="969696"/>
+            </a:contourClr>
+          </a:sp3d>
+        </p:spPr>
+      </p:pic>
+    </p:spTree>
+    <p:extLst>
+      <p:ext uri="{BB962C8B-B14F-4D97-AF65-F5344CB8AC3E}">
+        <p14:creationId xmlns:p14="http://schemas.microsoft.com/office/powerpoint/2010/main" val="3403265246"/>
       </p:ext>
     </p:extLst>
   </p:cSld>
@@ -4090,6 +4930,212 @@
 </file>
 
 <file path=ppt/slides/slide4.xml><?xml version="1.0" encoding="utf-8"?>
+<p:sld xmlns:a="http://schemas.openxmlformats.org/drawingml/2006/main" xmlns:r="http://schemas.openxmlformats.org/officeDocument/2006/relationships" xmlns:p="http://schemas.openxmlformats.org/presentationml/2006/main">
+  <p:cSld>
+    <p:spTree>
+      <p:nvGrpSpPr>
+        <p:cNvPr id="1" name=""/>
+        <p:cNvGrpSpPr/>
+        <p:nvPr/>
+      </p:nvGrpSpPr>
+      <p:grpSpPr>
+        <a:xfrm>
+          <a:off x="0" y="0"/>
+          <a:ext cx="0" cy="0"/>
+          <a:chOff x="0" y="0"/>
+          <a:chExt cx="0" cy="0"/>
+        </a:xfrm>
+      </p:grpSpPr>
+      <p:pic>
+        <p:nvPicPr>
+          <p:cNvPr id="3" name="Picture 2">
+            <a:extLst>
+              <a:ext uri="{FF2B5EF4-FFF2-40B4-BE49-F238E27FC236}">
+                <a16:creationId xmlns:a16="http://schemas.microsoft.com/office/drawing/2014/main" id="{EC0CC2D1-926C-CBA7-65EC-C86CDCFD333D}"/>
+              </a:ext>
+            </a:extLst>
+          </p:cNvPr>
+          <p:cNvPicPr>
+            <a:picLocks noChangeAspect="1"/>
+          </p:cNvPicPr>
+          <p:nvPr/>
+        </p:nvPicPr>
+        <p:blipFill>
+          <a:blip r:embed="rId2">
+            <a:extLst>
+              <a:ext uri="{28A0092B-C50C-407E-A947-70E740481C1C}">
+                <a14:useLocalDpi xmlns:a14="http://schemas.microsoft.com/office/drawing/2010/main" val="0"/>
+              </a:ext>
+            </a:extLst>
+          </a:blip>
+          <a:stretch>
+            <a:fillRect/>
+          </a:stretch>
+        </p:blipFill>
+        <p:spPr>
+          <a:xfrm>
+            <a:off x="0" y="0"/>
+            <a:ext cx="12192000" cy="6858000"/>
+          </a:xfrm>
+          <a:prstGeom prst="rect">
+            <a:avLst/>
+          </a:prstGeom>
+          <a:ln>
+            <a:noFill/>
+          </a:ln>
+          <a:effectLst>
+            <a:softEdge rad="112500"/>
+          </a:effectLst>
+        </p:spPr>
+      </p:pic>
+      <p:sp>
+        <p:nvSpPr>
+          <p:cNvPr id="4" name="TextBox 3">
+            <a:extLst>
+              <a:ext uri="{FF2B5EF4-FFF2-40B4-BE49-F238E27FC236}">
+                <a16:creationId xmlns:a16="http://schemas.microsoft.com/office/drawing/2014/main" id="{DE61EBFC-D4B2-8F05-684E-66DE68B82C43}"/>
+              </a:ext>
+            </a:extLst>
+          </p:cNvPr>
+          <p:cNvSpPr txBox="1"/>
+          <p:nvPr/>
+        </p:nvSpPr>
+        <p:spPr>
+          <a:xfrm>
+            <a:off x="2209800" y="155448"/>
+            <a:ext cx="7772399" cy="1938992"/>
+          </a:xfrm>
+          <a:prstGeom prst="rect">
+            <a:avLst/>
+          </a:prstGeom>
+          <a:noFill/>
+        </p:spPr>
+        <p:txBody>
+          <a:bodyPr wrap="square" rtlCol="0">
+            <a:spAutoFit/>
+          </a:bodyPr>
+          <a:lstStyle/>
+          <a:p>
+            <a:pPr algn="ctr"/>
+            <a:r>
+              <a:rPr lang="en-IN" sz="6000" dirty="0">
+                <a:solidFill>
+                  <a:schemeClr val="bg1"/>
+                </a:solidFill>
+                <a:latin typeface="Book Antiqua" panose="02040602050305030304" pitchFamily="18" charset="0"/>
+              </a:rPr>
+              <a:t>Project</a:t>
+            </a:r>
+          </a:p>
+          <a:p>
+            <a:pPr algn="ctr"/>
+            <a:r>
+              <a:rPr lang="en-IN" sz="6000" dirty="0">
+                <a:solidFill>
+                  <a:schemeClr val="accent4"/>
+                </a:solidFill>
+                <a:latin typeface="Book Antiqua" panose="02040602050305030304" pitchFamily="18" charset="0"/>
+              </a:rPr>
+              <a:t>Problem Statement</a:t>
+            </a:r>
+          </a:p>
+        </p:txBody>
+      </p:sp>
+      <p:sp>
+        <p:nvSpPr>
+          <p:cNvPr id="6" name="TextBox 5">
+            <a:extLst>
+              <a:ext uri="{FF2B5EF4-FFF2-40B4-BE49-F238E27FC236}">
+                <a16:creationId xmlns:a16="http://schemas.microsoft.com/office/drawing/2014/main" id="{1A616C76-CEBF-5A5C-74AD-2AF7AC921D05}"/>
+              </a:ext>
+            </a:extLst>
+          </p:cNvPr>
+          <p:cNvSpPr txBox="1"/>
+          <p:nvPr/>
+        </p:nvSpPr>
+        <p:spPr>
+          <a:xfrm>
+            <a:off x="1846325" y="2249888"/>
+            <a:ext cx="8135874" cy="2554545"/>
+          </a:xfrm>
+          <a:prstGeom prst="rect">
+            <a:avLst/>
+          </a:prstGeom>
+          <a:noFill/>
+        </p:spPr>
+        <p:txBody>
+          <a:bodyPr wrap="square">
+            <a:spAutoFit/>
+          </a:bodyPr>
+          <a:lstStyle/>
+          <a:p>
+            <a:pPr algn="ctr"/>
+            <a:r>
+              <a:rPr lang="en-US" sz="2000" dirty="0">
+                <a:solidFill>
+                  <a:schemeClr val="bg1"/>
+                </a:solidFill>
+                <a:latin typeface="Bookman Old Style" panose="02050604050505020204" pitchFamily="18" charset="0"/>
+              </a:rPr>
+              <a:t>Businesses often struggle to track and analyze large amounts of sales data across multiple parameters such as products, regions, fulfilment types, and promotions.</a:t>
+            </a:r>
+            <a:br>
+              <a:rPr lang="en-US" sz="2000" dirty="0">
+                <a:solidFill>
+                  <a:schemeClr val="bg1"/>
+                </a:solidFill>
+                <a:latin typeface="Bookman Old Style" panose="02050604050505020204" pitchFamily="18" charset="0"/>
+              </a:rPr>
+            </a:br>
+            <a:r>
+              <a:rPr lang="en-US" sz="2000" dirty="0">
+                <a:solidFill>
+                  <a:schemeClr val="bg1"/>
+                </a:solidFill>
+                <a:latin typeface="Bookman Old Style" panose="02050604050505020204" pitchFamily="18" charset="0"/>
+              </a:rPr>
+              <a:t>Manual reporting methods are slow and prone to errors, making it difficult to gain timely insights.</a:t>
+            </a:r>
+            <a:br>
+              <a:rPr lang="en-US" sz="2000" dirty="0">
+                <a:solidFill>
+                  <a:schemeClr val="bg1"/>
+                </a:solidFill>
+                <a:latin typeface="Bookman Old Style" panose="02050604050505020204" pitchFamily="18" charset="0"/>
+              </a:rPr>
+            </a:br>
+            <a:r>
+              <a:rPr lang="en-US" sz="2000" dirty="0">
+                <a:solidFill>
+                  <a:schemeClr val="bg1"/>
+                </a:solidFill>
+                <a:latin typeface="Bookman Old Style" panose="02050604050505020204" pitchFamily="18" charset="0"/>
+              </a:rPr>
+              <a:t>Due to the lack of an interactive and centralized dashboard, decision-makers face challenges in identifying trends, monitoring KPIs, and making accurate data-driven decisions.</a:t>
+            </a:r>
+            <a:endParaRPr lang="en-IN" sz="2000" dirty="0">
+              <a:solidFill>
+                <a:schemeClr val="bg1"/>
+              </a:solidFill>
+              <a:latin typeface="Bookman Old Style" panose="02050604050505020204" pitchFamily="18" charset="0"/>
+            </a:endParaRPr>
+          </a:p>
+        </p:txBody>
+      </p:sp>
+    </p:spTree>
+    <p:extLst>
+      <p:ext uri="{BB962C8B-B14F-4D97-AF65-F5344CB8AC3E}">
+        <p14:creationId xmlns:p14="http://schemas.microsoft.com/office/powerpoint/2010/main" val="2088329048"/>
+      </p:ext>
+    </p:extLst>
+  </p:cSld>
+  <p:clrMapOvr>
+    <a:masterClrMapping/>
+  </p:clrMapOvr>
+</p:sld>
+</file>
+
+<file path=ppt/slides/slide5.xml><?xml version="1.0" encoding="utf-8"?>
 <p:sld xmlns:a="http://schemas.openxmlformats.org/drawingml/2006/main" xmlns:r="http://schemas.openxmlformats.org/officeDocument/2006/relationships" xmlns:p="http://schemas.openxmlformats.org/presentationml/2006/main">
   <p:cSld>
     <p:spTree>
@@ -4537,7 +5583,7 @@
 </p:sld>
 </file>
 
-<file path=ppt/slides/slide5.xml><?xml version="1.0" encoding="utf-8"?>
+<file path=ppt/slides/slide6.xml><?xml version="1.0" encoding="utf-8"?>
 <p:sld xmlns:a="http://schemas.openxmlformats.org/drawingml/2006/main" xmlns:r="http://schemas.openxmlformats.org/officeDocument/2006/relationships" xmlns:p="http://schemas.openxmlformats.org/presentationml/2006/main">
   <p:cSld>
     <p:spTree>
@@ -4630,7 +5676,7 @@
                 <a:solidFill>
                   <a:schemeClr val="bg1"/>
                 </a:solidFill>
-                <a:latin typeface="Book Antiqua" panose="02040602050305030304" pitchFamily="18" charset="0"/>
+                <a:latin typeface="Bookman Old Style" panose="02050604050505020204" pitchFamily="18" charset="0"/>
               </a:rPr>
               <a:t>Project</a:t>
             </a:r>
@@ -4642,7 +5688,7 @@
                 <a:solidFill>
                   <a:schemeClr val="accent4"/>
                 </a:solidFill>
-                <a:latin typeface="Book Antiqua" panose="02040602050305030304" pitchFamily="18" charset="0"/>
+                <a:latin typeface="Bookman Old Style" panose="02050604050505020204" pitchFamily="18" charset="0"/>
               </a:rPr>
               <a:t>Outcome</a:t>
             </a:r>
@@ -4663,10 +5709,10 @@
         </p:nvGrpSpPr>
         <p:grpSpPr>
           <a:xfrm>
-            <a:off x="1302638" y="2234627"/>
-            <a:ext cx="9586722" cy="3850582"/>
+            <a:off x="1302638" y="2326067"/>
+            <a:ext cx="9586722" cy="2894787"/>
             <a:chOff x="1533525" y="2079179"/>
-            <a:chExt cx="9586722" cy="3850582"/>
+            <a:chExt cx="9586722" cy="2894787"/>
           </a:xfrm>
         </p:grpSpPr>
         <p:sp>
@@ -4748,77 +5794,7 @@
           <p:spPr>
             <a:xfrm>
               <a:off x="1533525" y="3650527"/>
-              <a:ext cx="4121658" cy="1015663"/>
-            </a:xfrm>
-            <a:prstGeom prst="rect">
-              <a:avLst/>
-            </a:prstGeom>
-            <a:noFill/>
-          </p:spPr>
-          <p:txBody>
-            <a:bodyPr wrap="square">
-              <a:spAutoFit/>
-            </a:bodyPr>
-            <a:lstStyle/>
-            <a:p>
-              <a:r>
-                <a:rPr lang="en-US" sz="2000" dirty="0">
-                  <a:solidFill>
-                    <a:schemeClr val="bg1"/>
-                  </a:solidFill>
-                </a:rPr>
-                <a:t>Improved </a:t>
-              </a:r>
-              <a:r>
-                <a:rPr lang="en-US" sz="2000" b="1" dirty="0">
-                  <a:solidFill>
-                    <a:schemeClr val="bg1"/>
-                  </a:solidFill>
-                  <a:latin typeface="Bookman Old Style" panose="02050604050505020204" pitchFamily="18" charset="0"/>
-                </a:rPr>
-                <a:t>marketing</a:t>
-              </a:r>
-              <a:r>
-                <a:rPr lang="en-US" sz="2000" b="1" dirty="0">
-                  <a:solidFill>
-                    <a:schemeClr val="bg1"/>
-                  </a:solidFill>
-                </a:rPr>
-                <a:t> and inventory strategies</a:t>
-              </a:r>
-              <a:r>
-                <a:rPr lang="en-US" sz="2000" dirty="0">
-                  <a:solidFill>
-                    <a:schemeClr val="bg1"/>
-                  </a:solidFill>
-                </a:rPr>
-                <a:t> using promotional and category insights.</a:t>
-              </a:r>
-              <a:endParaRPr lang="en-IN" sz="2000" dirty="0">
-                <a:solidFill>
-                  <a:schemeClr val="bg1"/>
-                </a:solidFill>
-                <a:latin typeface="Bookman Old Style" panose="02050604050505020204" pitchFamily="18" charset="0"/>
-              </a:endParaRPr>
-            </a:p>
-          </p:txBody>
-        </p:sp>
-        <p:sp>
-          <p:nvSpPr>
-            <p:cNvPr id="9" name="TextBox 8">
-              <a:extLst>
-                <a:ext uri="{FF2B5EF4-FFF2-40B4-BE49-F238E27FC236}">
-                  <a16:creationId xmlns:a16="http://schemas.microsoft.com/office/drawing/2014/main" id="{DBE8B182-3A2C-DBC1-429A-FB1FB4105C98}"/>
-                </a:ext>
-              </a:extLst>
-            </p:cNvPr>
-            <p:cNvSpPr txBox="1"/>
-            <p:nvPr/>
-          </p:nvSpPr>
-          <p:spPr>
-            <a:xfrm>
-              <a:off x="3943730" y="4914098"/>
-              <a:ext cx="4441318" cy="1015663"/>
+              <a:ext cx="4121658" cy="1323439"/>
             </a:xfrm>
             <a:prstGeom prst="rect">
               <a:avLst/>
@@ -4838,7 +5814,7 @@
                   </a:solidFill>
                   <a:latin typeface="Bookman Old Style" panose="02050604050505020204" pitchFamily="18" charset="0"/>
                 </a:rPr>
-                <a:t>Enabled </a:t>
+                <a:t>Improved </a:t>
               </a:r>
               <a:r>
                 <a:rPr lang="en-US" sz="2000" b="1" dirty="0">
@@ -4847,7 +5823,7 @@
                   </a:solidFill>
                   <a:latin typeface="Bookman Old Style" panose="02050604050505020204" pitchFamily="18" charset="0"/>
                 </a:rPr>
-                <a:t>data-driven forecasting</a:t>
+                <a:t>marketing and inventory strategies</a:t>
               </a:r>
               <a:r>
                 <a:rPr lang="en-US" sz="2000" dirty="0">
@@ -4856,7 +5832,7 @@
                   </a:solidFill>
                   <a:latin typeface="Bookman Old Style" panose="02050604050505020204" pitchFamily="18" charset="0"/>
                 </a:rPr>
-                <a:t> to plan future sales, operations, and demand effectively.</a:t>
+                <a:t> using promotional and category insights.</a:t>
               </a:r>
               <a:endParaRPr lang="en-IN" sz="2000" dirty="0">
                 <a:solidFill>
@@ -5000,6 +5976,1364 @@
     <p:extLst>
       <p:ext uri="{BB962C8B-B14F-4D97-AF65-F5344CB8AC3E}">
         <p14:creationId xmlns:p14="http://schemas.microsoft.com/office/powerpoint/2010/main" val="948624543"/>
+      </p:ext>
+    </p:extLst>
+  </p:cSld>
+  <p:clrMapOvr>
+    <a:masterClrMapping/>
+  </p:clrMapOvr>
+</p:sld>
+</file>
+
+<file path=ppt/slides/slide7.xml><?xml version="1.0" encoding="utf-8"?>
+<p:sld xmlns:a="http://schemas.openxmlformats.org/drawingml/2006/main" xmlns:r="http://schemas.openxmlformats.org/officeDocument/2006/relationships" xmlns:p="http://schemas.openxmlformats.org/presentationml/2006/main">
+  <p:cSld>
+    <p:spTree>
+      <p:nvGrpSpPr>
+        <p:cNvPr id="1" name="">
+          <a:extLst>
+            <a:ext uri="{FF2B5EF4-FFF2-40B4-BE49-F238E27FC236}">
+              <a16:creationId xmlns:a16="http://schemas.microsoft.com/office/drawing/2014/main" id="{A80466A6-672B-EA6E-8976-458EC5E3557B}"/>
+            </a:ext>
+          </a:extLst>
+        </p:cNvPr>
+        <p:cNvGrpSpPr/>
+        <p:nvPr/>
+      </p:nvGrpSpPr>
+      <p:grpSpPr>
+        <a:xfrm>
+          <a:off x="0" y="0"/>
+          <a:ext cx="0" cy="0"/>
+          <a:chOff x="0" y="0"/>
+          <a:chExt cx="0" cy="0"/>
+        </a:xfrm>
+      </p:grpSpPr>
+      <p:pic>
+        <p:nvPicPr>
+          <p:cNvPr id="4" name="Picture 3">
+            <a:extLst>
+              <a:ext uri="{FF2B5EF4-FFF2-40B4-BE49-F238E27FC236}">
+                <a16:creationId xmlns:a16="http://schemas.microsoft.com/office/drawing/2014/main" id="{74C17C16-9A53-4B89-9470-8C555EC1C57F}"/>
+              </a:ext>
+            </a:extLst>
+          </p:cNvPr>
+          <p:cNvPicPr>
+            <a:picLocks noChangeAspect="1"/>
+          </p:cNvPicPr>
+          <p:nvPr/>
+        </p:nvPicPr>
+        <p:blipFill>
+          <a:blip r:embed="rId2">
+            <a:extLst>
+              <a:ext uri="{28A0092B-C50C-407E-A947-70E740481C1C}">
+                <a14:useLocalDpi xmlns:a14="http://schemas.microsoft.com/office/drawing/2010/main" val="0"/>
+              </a:ext>
+            </a:extLst>
+          </a:blip>
+          <a:stretch>
+            <a:fillRect/>
+          </a:stretch>
+        </p:blipFill>
+        <p:spPr>
+          <a:xfrm>
+            <a:off x="0" y="0"/>
+            <a:ext cx="12192000" cy="6858000"/>
+          </a:xfrm>
+          <a:prstGeom prst="rect">
+            <a:avLst/>
+          </a:prstGeom>
+          <a:ln>
+            <a:noFill/>
+          </a:ln>
+          <a:effectLst>
+            <a:softEdge rad="112500"/>
+          </a:effectLst>
+        </p:spPr>
+      </p:pic>
+      <p:sp>
+        <p:nvSpPr>
+          <p:cNvPr id="5" name="TextBox 4">
+            <a:extLst>
+              <a:ext uri="{FF2B5EF4-FFF2-40B4-BE49-F238E27FC236}">
+                <a16:creationId xmlns:a16="http://schemas.microsoft.com/office/drawing/2014/main" id="{CC6A3CF1-BD11-356F-D360-056F93DC9C88}"/>
+              </a:ext>
+            </a:extLst>
+          </p:cNvPr>
+          <p:cNvSpPr txBox="1"/>
+          <p:nvPr/>
+        </p:nvSpPr>
+        <p:spPr>
+          <a:xfrm>
+            <a:off x="4149089" y="140187"/>
+            <a:ext cx="3893821" cy="1938992"/>
+          </a:xfrm>
+          <a:prstGeom prst="rect">
+            <a:avLst/>
+          </a:prstGeom>
+          <a:noFill/>
+        </p:spPr>
+        <p:txBody>
+          <a:bodyPr wrap="square" rtlCol="0">
+            <a:spAutoFit/>
+          </a:bodyPr>
+          <a:lstStyle/>
+          <a:p>
+            <a:pPr algn="ctr"/>
+            <a:r>
+              <a:rPr lang="en-IN" sz="6000" dirty="0">
+                <a:solidFill>
+                  <a:schemeClr val="bg1"/>
+                </a:solidFill>
+                <a:latin typeface="Bookman Old Style" panose="02050604050505020204" pitchFamily="18" charset="0"/>
+              </a:rPr>
+              <a:t>Content</a:t>
+            </a:r>
+          </a:p>
+          <a:p>
+            <a:pPr algn="ctr"/>
+            <a:r>
+              <a:rPr lang="en-IN" sz="6000" dirty="0">
+                <a:solidFill>
+                  <a:schemeClr val="accent4"/>
+                </a:solidFill>
+                <a:latin typeface="Bookman Old Style" panose="02050604050505020204" pitchFamily="18" charset="0"/>
+              </a:rPr>
+              <a:t>Table</a:t>
+            </a:r>
+          </a:p>
+        </p:txBody>
+      </p:sp>
+      <p:grpSp>
+        <p:nvGrpSpPr>
+          <p:cNvPr id="37" name="Group 36">
+            <a:extLst>
+              <a:ext uri="{FF2B5EF4-FFF2-40B4-BE49-F238E27FC236}">
+                <a16:creationId xmlns:a16="http://schemas.microsoft.com/office/drawing/2014/main" id="{E8697BA6-D058-D1B0-4A07-60347AF34083}"/>
+              </a:ext>
+            </a:extLst>
+          </p:cNvPr>
+          <p:cNvGrpSpPr/>
+          <p:nvPr/>
+        </p:nvGrpSpPr>
+        <p:grpSpPr>
+          <a:xfrm>
+            <a:off x="1702688" y="2207195"/>
+            <a:ext cx="8786622" cy="3775449"/>
+            <a:chOff x="1307591" y="2079179"/>
+            <a:chExt cx="8786622" cy="3775449"/>
+          </a:xfrm>
+        </p:grpSpPr>
+        <p:grpSp>
+          <p:nvGrpSpPr>
+            <p:cNvPr id="20" name="Group 19">
+              <a:extLst>
+                <a:ext uri="{FF2B5EF4-FFF2-40B4-BE49-F238E27FC236}">
+                  <a16:creationId xmlns:a16="http://schemas.microsoft.com/office/drawing/2014/main" id="{FB27D6A9-E03D-B90F-7AEE-BD64AD1E60DB}"/>
+                </a:ext>
+              </a:extLst>
+            </p:cNvPr>
+            <p:cNvGrpSpPr/>
+            <p:nvPr/>
+          </p:nvGrpSpPr>
+          <p:grpSpPr>
+            <a:xfrm>
+              <a:off x="2097785" y="2079179"/>
+              <a:ext cx="7996428" cy="3775449"/>
+              <a:chOff x="1577340" y="2181955"/>
+              <a:chExt cx="9027333" cy="3775449"/>
+            </a:xfrm>
+          </p:grpSpPr>
+          <p:sp>
+            <p:nvSpPr>
+              <p:cNvPr id="2" name="TextBox 1">
+                <a:extLst>
+                  <a:ext uri="{FF2B5EF4-FFF2-40B4-BE49-F238E27FC236}">
+                    <a16:creationId xmlns:a16="http://schemas.microsoft.com/office/drawing/2014/main" id="{8737DEA2-BDD9-AC11-172A-07A054154BDE}"/>
+                  </a:ext>
+                </a:extLst>
+              </p:cNvPr>
+              <p:cNvSpPr txBox="1"/>
+              <p:nvPr/>
+            </p:nvSpPr>
+            <p:spPr>
+              <a:xfrm>
+                <a:off x="1577340" y="2183686"/>
+                <a:ext cx="2715768" cy="830997"/>
+              </a:xfrm>
+              <a:prstGeom prst="rect">
+                <a:avLst/>
+              </a:prstGeom>
+              <a:noFill/>
+            </p:spPr>
+            <p:txBody>
+              <a:bodyPr wrap="square" rtlCol="0">
+                <a:spAutoFit/>
+              </a:bodyPr>
+              <a:lstStyle/>
+              <a:p>
+                <a:r>
+                  <a:rPr lang="en-IN" sz="2400" dirty="0">
+                    <a:solidFill>
+                      <a:schemeClr val="bg1"/>
+                    </a:solidFill>
+                    <a:latin typeface="Bookman Old Style" panose="02050604050505020204" pitchFamily="18" charset="0"/>
+                  </a:rPr>
+                  <a:t>Data Source &amp; Description</a:t>
+                </a:r>
+              </a:p>
+            </p:txBody>
+          </p:sp>
+          <p:sp>
+            <p:nvSpPr>
+              <p:cNvPr id="3" name="TextBox 2">
+                <a:extLst>
+                  <a:ext uri="{FF2B5EF4-FFF2-40B4-BE49-F238E27FC236}">
+                    <a16:creationId xmlns:a16="http://schemas.microsoft.com/office/drawing/2014/main" id="{D20BDB78-464A-21D0-6257-CE317B571ABE}"/>
+                  </a:ext>
+                </a:extLst>
+              </p:cNvPr>
+              <p:cNvSpPr txBox="1"/>
+              <p:nvPr/>
+            </p:nvSpPr>
+            <p:spPr>
+              <a:xfrm>
+                <a:off x="1577340" y="4402248"/>
+                <a:ext cx="2514600" cy="830997"/>
+              </a:xfrm>
+              <a:prstGeom prst="rect">
+                <a:avLst/>
+              </a:prstGeom>
+              <a:noFill/>
+            </p:spPr>
+            <p:txBody>
+              <a:bodyPr wrap="square" rtlCol="0">
+                <a:spAutoFit/>
+              </a:bodyPr>
+              <a:lstStyle/>
+              <a:p>
+                <a:r>
+                  <a:rPr lang="en-IN" sz="2400" dirty="0">
+                    <a:solidFill>
+                      <a:schemeClr val="bg1"/>
+                    </a:solidFill>
+                    <a:latin typeface="Bookman Old Style" panose="02050604050505020204" pitchFamily="18" charset="0"/>
+                  </a:rPr>
+                  <a:t>Key Insights &amp; Findings</a:t>
+                </a:r>
+              </a:p>
+            </p:txBody>
+          </p:sp>
+          <p:sp>
+            <p:nvSpPr>
+              <p:cNvPr id="14" name="TextBox 13">
+                <a:extLst>
+                  <a:ext uri="{FF2B5EF4-FFF2-40B4-BE49-F238E27FC236}">
+                    <a16:creationId xmlns:a16="http://schemas.microsoft.com/office/drawing/2014/main" id="{371DD1AA-C8CA-6090-C0B2-A43397EFFA98}"/>
+                  </a:ext>
+                </a:extLst>
+              </p:cNvPr>
+              <p:cNvSpPr txBox="1"/>
+              <p:nvPr/>
+            </p:nvSpPr>
+            <p:spPr>
+              <a:xfrm>
+                <a:off x="6690360" y="3307027"/>
+                <a:ext cx="3914313" cy="830997"/>
+              </a:xfrm>
+              <a:prstGeom prst="rect">
+                <a:avLst/>
+              </a:prstGeom>
+              <a:noFill/>
+            </p:spPr>
+            <p:txBody>
+              <a:bodyPr wrap="square" rtlCol="0">
+                <a:spAutoFit/>
+              </a:bodyPr>
+              <a:lstStyle>
+                <a:defPPr>
+                  <a:defRPr lang="en-US"/>
+                </a:defPPr>
+                <a:lvl1pPr>
+                  <a:defRPr sz="2800">
+                    <a:solidFill>
+                      <a:schemeClr val="bg1"/>
+                    </a:solidFill>
+                    <a:latin typeface="Bookman Old Style" panose="02050604050505020204" pitchFamily="18" charset="0"/>
+                  </a:defRPr>
+                </a:lvl1pPr>
+              </a:lstStyle>
+              <a:p>
+                <a:r>
+                  <a:rPr lang="en-IN" sz="2400" dirty="0"/>
+                  <a:t>Dashboard Design &amp; Visualization</a:t>
+                </a:r>
+              </a:p>
+            </p:txBody>
+          </p:sp>
+          <p:sp>
+            <p:nvSpPr>
+              <p:cNvPr id="15" name="TextBox 14">
+                <a:extLst>
+                  <a:ext uri="{FF2B5EF4-FFF2-40B4-BE49-F238E27FC236}">
+                    <a16:creationId xmlns:a16="http://schemas.microsoft.com/office/drawing/2014/main" id="{06C77E13-B460-465C-AB06-9A79A590C518}"/>
+                  </a:ext>
+                </a:extLst>
+              </p:cNvPr>
+              <p:cNvSpPr txBox="1"/>
+              <p:nvPr/>
+            </p:nvSpPr>
+            <p:spPr>
+              <a:xfrm>
+                <a:off x="6690360" y="2181955"/>
+                <a:ext cx="3550920" cy="830997"/>
+              </a:xfrm>
+              <a:prstGeom prst="rect">
+                <a:avLst/>
+              </a:prstGeom>
+              <a:noFill/>
+            </p:spPr>
+            <p:txBody>
+              <a:bodyPr wrap="square" rtlCol="0">
+                <a:spAutoFit/>
+              </a:bodyPr>
+              <a:lstStyle>
+                <a:defPPr>
+                  <a:defRPr lang="en-US"/>
+                </a:defPPr>
+                <a:lvl1pPr>
+                  <a:defRPr sz="2800">
+                    <a:solidFill>
+                      <a:schemeClr val="bg1"/>
+                    </a:solidFill>
+                    <a:latin typeface="Bookman Old Style" panose="02050604050505020204" pitchFamily="18" charset="0"/>
+                  </a:defRPr>
+                </a:lvl1pPr>
+              </a:lstStyle>
+              <a:p>
+                <a:r>
+                  <a:rPr lang="en-IN" sz="2400" dirty="0"/>
+                  <a:t>Exploratory Data Analysis (EDA)</a:t>
+                </a:r>
+              </a:p>
+            </p:txBody>
+          </p:sp>
+          <p:sp>
+            <p:nvSpPr>
+              <p:cNvPr id="16" name="TextBox 15">
+                <a:extLst>
+                  <a:ext uri="{FF2B5EF4-FFF2-40B4-BE49-F238E27FC236}">
+                    <a16:creationId xmlns:a16="http://schemas.microsoft.com/office/drawing/2014/main" id="{C0037660-0769-F723-553E-E084539B4D6B}"/>
+                  </a:ext>
+                </a:extLst>
+              </p:cNvPr>
+              <p:cNvSpPr txBox="1"/>
+              <p:nvPr/>
+            </p:nvSpPr>
+            <p:spPr>
+              <a:xfrm>
+                <a:off x="1577340" y="3308758"/>
+                <a:ext cx="3289132" cy="830997"/>
+              </a:xfrm>
+              <a:prstGeom prst="rect">
+                <a:avLst/>
+              </a:prstGeom>
+              <a:noFill/>
+            </p:spPr>
+            <p:txBody>
+              <a:bodyPr wrap="square" rtlCol="0">
+                <a:spAutoFit/>
+              </a:bodyPr>
+              <a:lstStyle>
+                <a:defPPr>
+                  <a:defRPr lang="en-US"/>
+                </a:defPPr>
+                <a:lvl1pPr>
+                  <a:defRPr sz="2800">
+                    <a:solidFill>
+                      <a:schemeClr val="bg1"/>
+                    </a:solidFill>
+                    <a:latin typeface="Bookman Old Style" panose="02050604050505020204" pitchFamily="18" charset="0"/>
+                  </a:defRPr>
+                </a:lvl1pPr>
+              </a:lstStyle>
+              <a:p>
+                <a:r>
+                  <a:rPr lang="en-IN" sz="2400" dirty="0"/>
+                  <a:t>Data Cleaning &amp; Transformation</a:t>
+                </a:r>
+              </a:p>
+            </p:txBody>
+          </p:sp>
+          <p:sp>
+            <p:nvSpPr>
+              <p:cNvPr id="17" name="TextBox 16">
+                <a:extLst>
+                  <a:ext uri="{FF2B5EF4-FFF2-40B4-BE49-F238E27FC236}">
+                    <a16:creationId xmlns:a16="http://schemas.microsoft.com/office/drawing/2014/main" id="{593EED0B-172D-0B52-11FA-671738C19475}"/>
+                  </a:ext>
+                </a:extLst>
+              </p:cNvPr>
+              <p:cNvSpPr txBox="1"/>
+              <p:nvPr/>
+            </p:nvSpPr>
+            <p:spPr>
+              <a:xfrm>
+                <a:off x="6690360" y="4401383"/>
+                <a:ext cx="3550920" cy="830997"/>
+              </a:xfrm>
+              <a:prstGeom prst="rect">
+                <a:avLst/>
+              </a:prstGeom>
+              <a:noFill/>
+            </p:spPr>
+            <p:txBody>
+              <a:bodyPr wrap="square" rtlCol="0">
+                <a:spAutoFit/>
+              </a:bodyPr>
+              <a:lstStyle>
+                <a:defPPr>
+                  <a:defRPr lang="en-US"/>
+                </a:defPPr>
+                <a:lvl1pPr>
+                  <a:defRPr sz="2800">
+                    <a:solidFill>
+                      <a:schemeClr val="bg1"/>
+                    </a:solidFill>
+                    <a:latin typeface="Bookman Old Style" panose="02050604050505020204" pitchFamily="18" charset="0"/>
+                  </a:defRPr>
+                </a:lvl1pPr>
+              </a:lstStyle>
+              <a:p>
+                <a:r>
+                  <a:rPr lang="en-IN" sz="2400" dirty="0"/>
+                  <a:t>Tools &amp; Technologies Used</a:t>
+                </a:r>
+              </a:p>
+            </p:txBody>
+          </p:sp>
+          <p:sp>
+            <p:nvSpPr>
+              <p:cNvPr id="18" name="TextBox 17">
+                <a:extLst>
+                  <a:ext uri="{FF2B5EF4-FFF2-40B4-BE49-F238E27FC236}">
+                    <a16:creationId xmlns:a16="http://schemas.microsoft.com/office/drawing/2014/main" id="{38D6B1B7-2601-9E4F-0C43-FBB88CD76FDA}"/>
+                  </a:ext>
+                </a:extLst>
+              </p:cNvPr>
+              <p:cNvSpPr txBox="1"/>
+              <p:nvPr/>
+            </p:nvSpPr>
+            <p:spPr>
+              <a:xfrm>
+                <a:off x="1577340" y="5495739"/>
+                <a:ext cx="2514600" cy="461665"/>
+              </a:xfrm>
+              <a:prstGeom prst="rect">
+                <a:avLst/>
+              </a:prstGeom>
+              <a:noFill/>
+            </p:spPr>
+            <p:txBody>
+              <a:bodyPr wrap="square" rtlCol="0">
+                <a:spAutoFit/>
+              </a:bodyPr>
+              <a:lstStyle>
+                <a:defPPr>
+                  <a:defRPr lang="en-US"/>
+                </a:defPPr>
+                <a:lvl1pPr>
+                  <a:defRPr sz="2800">
+                    <a:solidFill>
+                      <a:schemeClr val="bg1"/>
+                    </a:solidFill>
+                    <a:latin typeface="Bookman Old Style" panose="02050604050505020204" pitchFamily="18" charset="0"/>
+                  </a:defRPr>
+                </a:lvl1pPr>
+              </a:lstStyle>
+              <a:p>
+                <a:r>
+                  <a:rPr lang="en-IN" sz="2400" dirty="0"/>
+                  <a:t>Future Scope</a:t>
+                </a:r>
+              </a:p>
+            </p:txBody>
+          </p:sp>
+          <p:sp>
+            <p:nvSpPr>
+              <p:cNvPr id="19" name="TextBox 18">
+                <a:extLst>
+                  <a:ext uri="{FF2B5EF4-FFF2-40B4-BE49-F238E27FC236}">
+                    <a16:creationId xmlns:a16="http://schemas.microsoft.com/office/drawing/2014/main" id="{7493B2B9-BED8-DC61-A72F-B53B8B2A5E7C}"/>
+                  </a:ext>
+                </a:extLst>
+              </p:cNvPr>
+              <p:cNvSpPr txBox="1"/>
+              <p:nvPr/>
+            </p:nvSpPr>
+            <p:spPr>
+              <a:xfrm>
+                <a:off x="6690360" y="5495739"/>
+                <a:ext cx="2514600" cy="461665"/>
+              </a:xfrm>
+              <a:prstGeom prst="rect">
+                <a:avLst/>
+              </a:prstGeom>
+              <a:noFill/>
+            </p:spPr>
+            <p:txBody>
+              <a:bodyPr wrap="square" rtlCol="0">
+                <a:spAutoFit/>
+              </a:bodyPr>
+              <a:lstStyle>
+                <a:defPPr>
+                  <a:defRPr lang="en-US"/>
+                </a:defPPr>
+                <a:lvl1pPr>
+                  <a:defRPr sz="2800">
+                    <a:solidFill>
+                      <a:schemeClr val="bg1"/>
+                    </a:solidFill>
+                    <a:latin typeface="Bookman Old Style" panose="02050604050505020204" pitchFamily="18" charset="0"/>
+                  </a:defRPr>
+                </a:lvl1pPr>
+              </a:lstStyle>
+              <a:p>
+                <a:r>
+                  <a:rPr lang="en-IN" sz="2400" dirty="0"/>
+                  <a:t>Conclusion</a:t>
+                </a:r>
+              </a:p>
+            </p:txBody>
+          </p:sp>
+        </p:grpSp>
+        <p:sp>
+          <p:nvSpPr>
+            <p:cNvPr id="21" name="TextBox 20">
+              <a:extLst>
+                <a:ext uri="{FF2B5EF4-FFF2-40B4-BE49-F238E27FC236}">
+                  <a16:creationId xmlns:a16="http://schemas.microsoft.com/office/drawing/2014/main" id="{84F15FAF-3F37-9305-6AB8-7A9CE2E02C94}"/>
+                </a:ext>
+              </a:extLst>
+            </p:cNvPr>
+            <p:cNvSpPr txBox="1"/>
+            <p:nvPr/>
+          </p:nvSpPr>
+          <p:spPr>
+            <a:xfrm>
+              <a:off x="1307592" y="2171511"/>
+              <a:ext cx="790193" cy="461665"/>
+            </a:xfrm>
+            <a:prstGeom prst="rect">
+              <a:avLst/>
+            </a:prstGeom>
+            <a:noFill/>
+          </p:spPr>
+          <p:txBody>
+            <a:bodyPr wrap="square" rtlCol="0">
+              <a:spAutoFit/>
+            </a:bodyPr>
+            <a:lstStyle/>
+            <a:p>
+              <a:r>
+                <a:rPr lang="en-IN" sz="2400" dirty="0">
+                  <a:solidFill>
+                    <a:schemeClr val="accent4"/>
+                  </a:solidFill>
+                  <a:latin typeface="Bookman Old Style" panose="02050604050505020204" pitchFamily="18" charset="0"/>
+                </a:rPr>
+                <a:t>01</a:t>
+              </a:r>
+            </a:p>
+          </p:txBody>
+        </p:sp>
+        <p:sp>
+          <p:nvSpPr>
+            <p:cNvPr id="22" name="TextBox 21">
+              <a:extLst>
+                <a:ext uri="{FF2B5EF4-FFF2-40B4-BE49-F238E27FC236}">
+                  <a16:creationId xmlns:a16="http://schemas.microsoft.com/office/drawing/2014/main" id="{0C020218-BE27-2699-0E7D-569866C3D149}"/>
+                </a:ext>
+              </a:extLst>
+            </p:cNvPr>
+            <p:cNvSpPr txBox="1"/>
+            <p:nvPr/>
+          </p:nvSpPr>
+          <p:spPr>
+            <a:xfrm>
+              <a:off x="1307591" y="3296100"/>
+              <a:ext cx="790193" cy="461665"/>
+            </a:xfrm>
+            <a:prstGeom prst="rect">
+              <a:avLst/>
+            </a:prstGeom>
+            <a:noFill/>
+          </p:spPr>
+          <p:txBody>
+            <a:bodyPr wrap="square" rtlCol="0">
+              <a:spAutoFit/>
+            </a:bodyPr>
+            <a:lstStyle/>
+            <a:p>
+              <a:r>
+                <a:rPr lang="en-IN" sz="2400" dirty="0">
+                  <a:solidFill>
+                    <a:schemeClr val="accent4"/>
+                  </a:solidFill>
+                  <a:latin typeface="Bookman Old Style" panose="02050604050505020204" pitchFamily="18" charset="0"/>
+                </a:rPr>
+                <a:t>03</a:t>
+              </a:r>
+            </a:p>
+          </p:txBody>
+        </p:sp>
+        <p:sp>
+          <p:nvSpPr>
+            <p:cNvPr id="23" name="TextBox 22">
+              <a:extLst>
+                <a:ext uri="{FF2B5EF4-FFF2-40B4-BE49-F238E27FC236}">
+                  <a16:creationId xmlns:a16="http://schemas.microsoft.com/office/drawing/2014/main" id="{45C7745D-F54C-D471-9592-8A01921BECE5}"/>
+                </a:ext>
+              </a:extLst>
+            </p:cNvPr>
+            <p:cNvSpPr txBox="1"/>
+            <p:nvPr/>
+          </p:nvSpPr>
+          <p:spPr>
+            <a:xfrm>
+              <a:off x="1307591" y="5300628"/>
+              <a:ext cx="790193" cy="461665"/>
+            </a:xfrm>
+            <a:prstGeom prst="rect">
+              <a:avLst/>
+            </a:prstGeom>
+            <a:noFill/>
+          </p:spPr>
+          <p:txBody>
+            <a:bodyPr wrap="square" rtlCol="0">
+              <a:spAutoFit/>
+            </a:bodyPr>
+            <a:lstStyle/>
+            <a:p>
+              <a:r>
+                <a:rPr lang="en-IN" sz="2400" dirty="0">
+                  <a:solidFill>
+                    <a:schemeClr val="accent4"/>
+                  </a:solidFill>
+                  <a:latin typeface="Bookman Old Style" panose="02050604050505020204" pitchFamily="18" charset="0"/>
+                </a:rPr>
+                <a:t>07</a:t>
+              </a:r>
+            </a:p>
+          </p:txBody>
+        </p:sp>
+        <p:sp>
+          <p:nvSpPr>
+            <p:cNvPr id="24" name="TextBox 23">
+              <a:extLst>
+                <a:ext uri="{FF2B5EF4-FFF2-40B4-BE49-F238E27FC236}">
+                  <a16:creationId xmlns:a16="http://schemas.microsoft.com/office/drawing/2014/main" id="{4032CDF5-25D8-9EDA-3277-00CA94DC2BB5}"/>
+                </a:ext>
+              </a:extLst>
+            </p:cNvPr>
+            <p:cNvSpPr txBox="1"/>
+            <p:nvPr/>
+          </p:nvSpPr>
+          <p:spPr>
+            <a:xfrm>
+              <a:off x="1307591" y="4389591"/>
+              <a:ext cx="790193" cy="461665"/>
+            </a:xfrm>
+            <a:prstGeom prst="rect">
+              <a:avLst/>
+            </a:prstGeom>
+            <a:noFill/>
+          </p:spPr>
+          <p:txBody>
+            <a:bodyPr wrap="square" rtlCol="0">
+              <a:spAutoFit/>
+            </a:bodyPr>
+            <a:lstStyle/>
+            <a:p>
+              <a:r>
+                <a:rPr lang="en-IN" sz="2400" dirty="0">
+                  <a:solidFill>
+                    <a:schemeClr val="accent4"/>
+                  </a:solidFill>
+                  <a:latin typeface="Bookman Old Style" panose="02050604050505020204" pitchFamily="18" charset="0"/>
+                </a:rPr>
+                <a:t>05</a:t>
+              </a:r>
+            </a:p>
+          </p:txBody>
+        </p:sp>
+        <p:sp>
+          <p:nvSpPr>
+            <p:cNvPr id="25" name="TextBox 24">
+              <a:extLst>
+                <a:ext uri="{FF2B5EF4-FFF2-40B4-BE49-F238E27FC236}">
+                  <a16:creationId xmlns:a16="http://schemas.microsoft.com/office/drawing/2014/main" id="{E9F74634-2905-CC99-8914-A4EEF44EC1F8}"/>
+                </a:ext>
+              </a:extLst>
+            </p:cNvPr>
+            <p:cNvSpPr txBox="1"/>
+            <p:nvPr/>
+          </p:nvSpPr>
+          <p:spPr>
+            <a:xfrm>
+              <a:off x="5827015" y="5300629"/>
+              <a:ext cx="790193" cy="461665"/>
+            </a:xfrm>
+            <a:prstGeom prst="rect">
+              <a:avLst/>
+            </a:prstGeom>
+            <a:noFill/>
+          </p:spPr>
+          <p:txBody>
+            <a:bodyPr wrap="square" rtlCol="0">
+              <a:spAutoFit/>
+            </a:bodyPr>
+            <a:lstStyle/>
+            <a:p>
+              <a:r>
+                <a:rPr lang="en-IN" sz="2400" dirty="0">
+                  <a:solidFill>
+                    <a:schemeClr val="accent4"/>
+                  </a:solidFill>
+                  <a:latin typeface="Bookman Old Style" panose="02050604050505020204" pitchFamily="18" charset="0"/>
+                </a:rPr>
+                <a:t>08</a:t>
+              </a:r>
+            </a:p>
+          </p:txBody>
+        </p:sp>
+        <p:sp>
+          <p:nvSpPr>
+            <p:cNvPr id="26" name="TextBox 25">
+              <a:extLst>
+                <a:ext uri="{FF2B5EF4-FFF2-40B4-BE49-F238E27FC236}">
+                  <a16:creationId xmlns:a16="http://schemas.microsoft.com/office/drawing/2014/main" id="{D4E32ADA-8EBD-597A-CF29-D95671C5F7B1}"/>
+                </a:ext>
+              </a:extLst>
+            </p:cNvPr>
+            <p:cNvSpPr txBox="1"/>
+            <p:nvPr/>
+          </p:nvSpPr>
+          <p:spPr>
+            <a:xfrm>
+              <a:off x="5827015" y="4389591"/>
+              <a:ext cx="790193" cy="461665"/>
+            </a:xfrm>
+            <a:prstGeom prst="rect">
+              <a:avLst/>
+            </a:prstGeom>
+            <a:noFill/>
+          </p:spPr>
+          <p:txBody>
+            <a:bodyPr wrap="square" rtlCol="0">
+              <a:spAutoFit/>
+            </a:bodyPr>
+            <a:lstStyle/>
+            <a:p>
+              <a:r>
+                <a:rPr lang="en-IN" sz="2400" dirty="0">
+                  <a:solidFill>
+                    <a:schemeClr val="accent4"/>
+                  </a:solidFill>
+                  <a:latin typeface="Bookman Old Style" panose="02050604050505020204" pitchFamily="18" charset="0"/>
+                </a:rPr>
+                <a:t>06</a:t>
+              </a:r>
+            </a:p>
+          </p:txBody>
+        </p:sp>
+        <p:sp>
+          <p:nvSpPr>
+            <p:cNvPr id="27" name="TextBox 26">
+              <a:extLst>
+                <a:ext uri="{FF2B5EF4-FFF2-40B4-BE49-F238E27FC236}">
+                  <a16:creationId xmlns:a16="http://schemas.microsoft.com/office/drawing/2014/main" id="{0D37565D-4DBD-EAB1-7170-F922331F0E83}"/>
+                </a:ext>
+              </a:extLst>
+            </p:cNvPr>
+            <p:cNvSpPr txBox="1"/>
+            <p:nvPr/>
+          </p:nvSpPr>
+          <p:spPr>
+            <a:xfrm>
+              <a:off x="5827015" y="3301494"/>
+              <a:ext cx="790193" cy="461665"/>
+            </a:xfrm>
+            <a:prstGeom prst="rect">
+              <a:avLst/>
+            </a:prstGeom>
+            <a:noFill/>
+          </p:spPr>
+          <p:txBody>
+            <a:bodyPr wrap="square" rtlCol="0">
+              <a:spAutoFit/>
+            </a:bodyPr>
+            <a:lstStyle/>
+            <a:p>
+              <a:r>
+                <a:rPr lang="en-IN" sz="2400" dirty="0">
+                  <a:solidFill>
+                    <a:schemeClr val="accent4"/>
+                  </a:solidFill>
+                  <a:latin typeface="Bookman Old Style" panose="02050604050505020204" pitchFamily="18" charset="0"/>
+                </a:rPr>
+                <a:t>04</a:t>
+              </a:r>
+            </a:p>
+          </p:txBody>
+        </p:sp>
+        <p:sp>
+          <p:nvSpPr>
+            <p:cNvPr id="28" name="TextBox 27">
+              <a:extLst>
+                <a:ext uri="{FF2B5EF4-FFF2-40B4-BE49-F238E27FC236}">
+                  <a16:creationId xmlns:a16="http://schemas.microsoft.com/office/drawing/2014/main" id="{8D9F7B88-4A97-95C5-0E56-022FE9A55B6D}"/>
+                </a:ext>
+              </a:extLst>
+            </p:cNvPr>
+            <p:cNvSpPr txBox="1"/>
+            <p:nvPr/>
+          </p:nvSpPr>
+          <p:spPr>
+            <a:xfrm>
+              <a:off x="5827015" y="2166218"/>
+              <a:ext cx="790193" cy="461665"/>
+            </a:xfrm>
+            <a:prstGeom prst="rect">
+              <a:avLst/>
+            </a:prstGeom>
+            <a:noFill/>
+          </p:spPr>
+          <p:txBody>
+            <a:bodyPr wrap="square" rtlCol="0">
+              <a:spAutoFit/>
+            </a:bodyPr>
+            <a:lstStyle/>
+            <a:p>
+              <a:r>
+                <a:rPr lang="en-IN" sz="2400" dirty="0">
+                  <a:solidFill>
+                    <a:schemeClr val="accent4"/>
+                  </a:solidFill>
+                  <a:latin typeface="Bookman Old Style" panose="02050604050505020204" pitchFamily="18" charset="0"/>
+                </a:rPr>
+                <a:t>02</a:t>
+              </a:r>
+            </a:p>
+          </p:txBody>
+        </p:sp>
+      </p:grpSp>
+    </p:spTree>
+    <p:extLst>
+      <p:ext uri="{BB962C8B-B14F-4D97-AF65-F5344CB8AC3E}">
+        <p14:creationId xmlns:p14="http://schemas.microsoft.com/office/powerpoint/2010/main" val="3734823867"/>
+      </p:ext>
+    </p:extLst>
+  </p:cSld>
+  <p:clrMapOvr>
+    <a:masterClrMapping/>
+  </p:clrMapOvr>
+</p:sld>
+</file>
+
+<file path=ppt/slides/slide8.xml><?xml version="1.0" encoding="utf-8"?>
+<p:sld xmlns:a="http://schemas.openxmlformats.org/drawingml/2006/main" xmlns:r="http://schemas.openxmlformats.org/officeDocument/2006/relationships" xmlns:p="http://schemas.openxmlformats.org/presentationml/2006/main">
+  <p:cSld>
+    <p:spTree>
+      <p:nvGrpSpPr>
+        <p:cNvPr id="1" name="">
+          <a:extLst>
+            <a:ext uri="{FF2B5EF4-FFF2-40B4-BE49-F238E27FC236}">
+              <a16:creationId xmlns:a16="http://schemas.microsoft.com/office/drawing/2014/main" id="{D63B3B53-7689-A7EA-122C-A0DB73F3245D}"/>
+            </a:ext>
+          </a:extLst>
+        </p:cNvPr>
+        <p:cNvGrpSpPr/>
+        <p:nvPr/>
+      </p:nvGrpSpPr>
+      <p:grpSpPr>
+        <a:xfrm>
+          <a:off x="0" y="0"/>
+          <a:ext cx="0" cy="0"/>
+          <a:chOff x="0" y="0"/>
+          <a:chExt cx="0" cy="0"/>
+        </a:xfrm>
+      </p:grpSpPr>
+      <p:pic>
+        <p:nvPicPr>
+          <p:cNvPr id="4" name="Picture 3">
+            <a:extLst>
+              <a:ext uri="{FF2B5EF4-FFF2-40B4-BE49-F238E27FC236}">
+                <a16:creationId xmlns:a16="http://schemas.microsoft.com/office/drawing/2014/main" id="{302E4952-92A7-9E95-5723-BDA774D5B75E}"/>
+              </a:ext>
+            </a:extLst>
+          </p:cNvPr>
+          <p:cNvPicPr>
+            <a:picLocks noChangeAspect="1"/>
+          </p:cNvPicPr>
+          <p:nvPr/>
+        </p:nvPicPr>
+        <p:blipFill>
+          <a:blip r:embed="rId2">
+            <a:extLst>
+              <a:ext uri="{28A0092B-C50C-407E-A947-70E740481C1C}">
+                <a14:useLocalDpi xmlns:a14="http://schemas.microsoft.com/office/drawing/2010/main" val="0"/>
+              </a:ext>
+            </a:extLst>
+          </a:blip>
+          <a:stretch>
+            <a:fillRect/>
+          </a:stretch>
+        </p:blipFill>
+        <p:spPr>
+          <a:xfrm>
+            <a:off x="0" y="0"/>
+            <a:ext cx="12192000" cy="6858000"/>
+          </a:xfrm>
+          <a:prstGeom prst="rect">
+            <a:avLst/>
+          </a:prstGeom>
+          <a:ln>
+            <a:noFill/>
+          </a:ln>
+          <a:effectLst>
+            <a:softEdge rad="112500"/>
+          </a:effectLst>
+        </p:spPr>
+      </p:pic>
+      <p:sp>
+        <p:nvSpPr>
+          <p:cNvPr id="5" name="TextBox 4">
+            <a:extLst>
+              <a:ext uri="{FF2B5EF4-FFF2-40B4-BE49-F238E27FC236}">
+                <a16:creationId xmlns:a16="http://schemas.microsoft.com/office/drawing/2014/main" id="{DD4EA929-C825-AF7E-8E0B-723DC4A18666}"/>
+              </a:ext>
+            </a:extLst>
+          </p:cNvPr>
+          <p:cNvSpPr txBox="1"/>
+          <p:nvPr/>
+        </p:nvSpPr>
+        <p:spPr>
+          <a:xfrm>
+            <a:off x="6096000" y="2459504"/>
+            <a:ext cx="5916167" cy="1938992"/>
+          </a:xfrm>
+          <a:prstGeom prst="rect">
+            <a:avLst/>
+          </a:prstGeom>
+          <a:noFill/>
+        </p:spPr>
+        <p:txBody>
+          <a:bodyPr wrap="square" rtlCol="0">
+            <a:spAutoFit/>
+          </a:bodyPr>
+          <a:lstStyle/>
+          <a:p>
+            <a:r>
+              <a:rPr lang="en-IN" sz="6000" dirty="0">
+                <a:solidFill>
+                  <a:schemeClr val="bg1"/>
+                </a:solidFill>
+                <a:latin typeface="Bookman Old Style" panose="02050604050505020204" pitchFamily="18" charset="0"/>
+              </a:rPr>
+              <a:t>Data Source &amp; Description</a:t>
+            </a:r>
+          </a:p>
+        </p:txBody>
+      </p:sp>
+      <p:sp>
+        <p:nvSpPr>
+          <p:cNvPr id="7" name="Flowchart: Connector 6">
+            <a:extLst>
+              <a:ext uri="{FF2B5EF4-FFF2-40B4-BE49-F238E27FC236}">
+                <a16:creationId xmlns:a16="http://schemas.microsoft.com/office/drawing/2014/main" id="{FF533B4D-1568-EAC4-69A6-8967656B06F7}"/>
+              </a:ext>
+            </a:extLst>
+          </p:cNvPr>
+          <p:cNvSpPr/>
+          <p:nvPr/>
+        </p:nvSpPr>
+        <p:spPr>
+          <a:xfrm>
+            <a:off x="8207764" y="1280401"/>
+            <a:ext cx="1080000" cy="1080000"/>
+          </a:xfrm>
+          <a:prstGeom prst="flowChartConnector">
+            <a:avLst/>
+          </a:prstGeom>
+          <a:noFill/>
+          <a:ln>
+            <a:solidFill>
+              <a:schemeClr val="accent4"/>
+            </a:solidFill>
+          </a:ln>
+        </p:spPr>
+        <p:style>
+          <a:lnRef idx="2">
+            <a:schemeClr val="accent1">
+              <a:shade val="15000"/>
+            </a:schemeClr>
+          </a:lnRef>
+          <a:fillRef idx="1">
+            <a:schemeClr val="accent1"/>
+          </a:fillRef>
+          <a:effectRef idx="0">
+            <a:schemeClr val="accent1"/>
+          </a:effectRef>
+          <a:fontRef idx="minor">
+            <a:schemeClr val="lt1"/>
+          </a:fontRef>
+        </p:style>
+        <p:txBody>
+          <a:bodyPr rtlCol="0" anchor="ctr"/>
+          <a:lstStyle/>
+          <a:p>
+            <a:pPr algn="ctr"/>
+            <a:r>
+              <a:rPr lang="en-IN" sz="3600" dirty="0">
+                <a:solidFill>
+                  <a:schemeClr val="accent4"/>
+                </a:solidFill>
+                <a:effectLst>
+                  <a:outerShdw blurRad="50800" dist="38100" dir="2700000" algn="tl" rotWithShape="0">
+                    <a:prstClr val="black">
+                      <a:alpha val="40000"/>
+                    </a:prstClr>
+                  </a:outerShdw>
+                </a:effectLst>
+                <a:latin typeface="Bookman Old Style" panose="02050604050505020204" pitchFamily="18" charset="0"/>
+              </a:rPr>
+              <a:t>01</a:t>
+            </a:r>
+          </a:p>
+        </p:txBody>
+      </p:sp>
+      <p:pic>
+        <p:nvPicPr>
+          <p:cNvPr id="9" name="Picture 8">
+            <a:extLst>
+              <a:ext uri="{FF2B5EF4-FFF2-40B4-BE49-F238E27FC236}">
+                <a16:creationId xmlns:a16="http://schemas.microsoft.com/office/drawing/2014/main" id="{5631A25B-DFD9-A54C-1FC6-A1F7466FB5EB}"/>
+              </a:ext>
+            </a:extLst>
+          </p:cNvPr>
+          <p:cNvPicPr>
+            <a:picLocks noChangeAspect="1"/>
+          </p:cNvPicPr>
+          <p:nvPr/>
+        </p:nvPicPr>
+        <p:blipFill>
+          <a:blip r:embed="rId3">
+            <a:extLst>
+              <a:ext uri="{28A0092B-C50C-407E-A947-70E740481C1C}">
+                <a14:useLocalDpi xmlns:a14="http://schemas.microsoft.com/office/drawing/2010/main" val="0"/>
+              </a:ext>
+            </a:extLst>
+          </a:blip>
+          <a:stretch>
+            <a:fillRect/>
+          </a:stretch>
+        </p:blipFill>
+        <p:spPr>
+          <a:xfrm>
+            <a:off x="505837" y="934146"/>
+            <a:ext cx="4989708" cy="4989708"/>
+          </a:xfrm>
+          <a:prstGeom prst="rect">
+            <a:avLst/>
+          </a:prstGeom>
+        </p:spPr>
+      </p:pic>
+    </p:spTree>
+    <p:extLst>
+      <p:ext uri="{BB962C8B-B14F-4D97-AF65-F5344CB8AC3E}">
+        <p14:creationId xmlns:p14="http://schemas.microsoft.com/office/powerpoint/2010/main" val="1222497699"/>
+      </p:ext>
+    </p:extLst>
+  </p:cSld>
+  <p:clrMapOvr>
+    <a:masterClrMapping/>
+  </p:clrMapOvr>
+</p:sld>
+</file>
+
+<file path=ppt/slides/slide9.xml><?xml version="1.0" encoding="utf-8"?>
+<p:sld xmlns:a="http://schemas.openxmlformats.org/drawingml/2006/main" xmlns:r="http://schemas.openxmlformats.org/officeDocument/2006/relationships" xmlns:p="http://schemas.openxmlformats.org/presentationml/2006/main">
+  <p:cSld>
+    <p:spTree>
+      <p:nvGrpSpPr>
+        <p:cNvPr id="1" name="">
+          <a:extLst>
+            <a:ext uri="{FF2B5EF4-FFF2-40B4-BE49-F238E27FC236}">
+              <a16:creationId xmlns:a16="http://schemas.microsoft.com/office/drawing/2014/main" id="{DEEE7AAC-F85C-ED65-57FA-40E2D1F93443}"/>
+            </a:ext>
+          </a:extLst>
+        </p:cNvPr>
+        <p:cNvGrpSpPr/>
+        <p:nvPr/>
+      </p:nvGrpSpPr>
+      <p:grpSpPr>
+        <a:xfrm>
+          <a:off x="0" y="0"/>
+          <a:ext cx="0" cy="0"/>
+          <a:chOff x="0" y="0"/>
+          <a:chExt cx="0" cy="0"/>
+        </a:xfrm>
+      </p:grpSpPr>
+      <p:pic>
+        <p:nvPicPr>
+          <p:cNvPr id="4" name="Picture 3">
+            <a:extLst>
+              <a:ext uri="{FF2B5EF4-FFF2-40B4-BE49-F238E27FC236}">
+                <a16:creationId xmlns:a16="http://schemas.microsoft.com/office/drawing/2014/main" id="{BE6D5147-C421-F000-8FDB-B0714E880510}"/>
+              </a:ext>
+            </a:extLst>
+          </p:cNvPr>
+          <p:cNvPicPr>
+            <a:picLocks noChangeAspect="1"/>
+          </p:cNvPicPr>
+          <p:nvPr/>
+        </p:nvPicPr>
+        <p:blipFill>
+          <a:blip r:embed="rId2">
+            <a:extLst>
+              <a:ext uri="{28A0092B-C50C-407E-A947-70E740481C1C}">
+                <a14:useLocalDpi xmlns:a14="http://schemas.microsoft.com/office/drawing/2010/main" val="0"/>
+              </a:ext>
+            </a:extLst>
+          </a:blip>
+          <a:stretch>
+            <a:fillRect/>
+          </a:stretch>
+        </p:blipFill>
+        <p:spPr>
+          <a:xfrm>
+            <a:off x="0" y="0"/>
+            <a:ext cx="12192000" cy="6858000"/>
+          </a:xfrm>
+          <a:prstGeom prst="rect">
+            <a:avLst/>
+          </a:prstGeom>
+          <a:ln>
+            <a:noFill/>
+          </a:ln>
+          <a:effectLst>
+            <a:softEdge rad="112500"/>
+          </a:effectLst>
+        </p:spPr>
+      </p:pic>
+      <p:sp>
+        <p:nvSpPr>
+          <p:cNvPr id="3" name="TextBox 2">
+            <a:extLst>
+              <a:ext uri="{FF2B5EF4-FFF2-40B4-BE49-F238E27FC236}">
+                <a16:creationId xmlns:a16="http://schemas.microsoft.com/office/drawing/2014/main" id="{FBAE44CD-3726-E2AB-8AB1-CE57A691D8B9}"/>
+              </a:ext>
+            </a:extLst>
+          </p:cNvPr>
+          <p:cNvSpPr txBox="1"/>
+          <p:nvPr/>
+        </p:nvSpPr>
+        <p:spPr>
+          <a:xfrm>
+            <a:off x="469392" y="920620"/>
+            <a:ext cx="5626608" cy="5016758"/>
+          </a:xfrm>
+          <a:prstGeom prst="rect">
+            <a:avLst/>
+          </a:prstGeom>
+          <a:noFill/>
+          <a:ln w="12700">
+            <a:noFill/>
+          </a:ln>
+        </p:spPr>
+        <p:txBody>
+          <a:bodyPr wrap="square">
+            <a:spAutoFit/>
+          </a:bodyPr>
+          <a:lstStyle/>
+          <a:p>
+            <a:pPr marL="285750" indent="-285750">
+              <a:buClr>
+                <a:srgbClr val="00B050"/>
+              </a:buClr>
+              <a:buFont typeface="Wingdings" panose="05000000000000000000" pitchFamily="2" charset="2"/>
+              <a:buChar char="ü"/>
+            </a:pPr>
+            <a:r>
+              <a:rPr lang="en-US" sz="2000" dirty="0">
+                <a:solidFill>
+                  <a:schemeClr val="bg1"/>
+                </a:solidFill>
+                <a:latin typeface="Bookman Old Style" panose="02050604050505020204" pitchFamily="18" charset="0"/>
+              </a:rPr>
+              <a:t>The dataset used for this project is a Retail Sales (Amazon Orders) dataset.</a:t>
+            </a:r>
+          </a:p>
+          <a:p>
+            <a:pPr>
+              <a:buClr>
+                <a:srgbClr val="00B050"/>
+              </a:buClr>
+            </a:pPr>
+            <a:endParaRPr lang="en-US" sz="2000" dirty="0">
+              <a:solidFill>
+                <a:schemeClr val="bg1"/>
+              </a:solidFill>
+              <a:latin typeface="Bookman Old Style" panose="02050604050505020204" pitchFamily="18" charset="0"/>
+            </a:endParaRPr>
+          </a:p>
+          <a:p>
+            <a:pPr marL="285750" indent="-285750">
+              <a:buClr>
+                <a:srgbClr val="00B050"/>
+              </a:buClr>
+              <a:buFont typeface="Wingdings" panose="05000000000000000000" pitchFamily="2" charset="2"/>
+              <a:buChar char="ü"/>
+            </a:pPr>
+            <a:r>
+              <a:rPr lang="en-US" sz="2000" dirty="0">
+                <a:solidFill>
+                  <a:schemeClr val="bg1"/>
+                </a:solidFill>
+                <a:latin typeface="Bookman Old Style" panose="02050604050505020204" pitchFamily="18" charset="0"/>
+              </a:rPr>
+              <a:t>It contains detailed information about customer orders, products, fulfilment types, cities, quantities, prices, and delivery status.</a:t>
+            </a:r>
+          </a:p>
+          <a:p>
+            <a:pPr>
+              <a:buClr>
+                <a:srgbClr val="00B050"/>
+              </a:buClr>
+            </a:pPr>
+            <a:endParaRPr lang="en-US" sz="2000" dirty="0">
+              <a:solidFill>
+                <a:schemeClr val="bg1"/>
+              </a:solidFill>
+              <a:latin typeface="Bookman Old Style" panose="02050604050505020204" pitchFamily="18" charset="0"/>
+            </a:endParaRPr>
+          </a:p>
+          <a:p>
+            <a:pPr marL="285750" indent="-285750">
+              <a:buClr>
+                <a:srgbClr val="00B050"/>
+              </a:buClr>
+              <a:buFont typeface="Wingdings" panose="05000000000000000000" pitchFamily="2" charset="2"/>
+              <a:buChar char="ü"/>
+            </a:pPr>
+            <a:r>
+              <a:rPr lang="en-US" sz="2000" dirty="0">
+                <a:solidFill>
+                  <a:schemeClr val="bg1"/>
+                </a:solidFill>
+                <a:latin typeface="Bookman Old Style" panose="02050604050505020204" pitchFamily="18" charset="0"/>
+              </a:rPr>
+              <a:t>The data was provided in CSV/Excel format and imported directly into Power BI Desktop.</a:t>
+            </a:r>
+          </a:p>
+          <a:p>
+            <a:pPr>
+              <a:buClr>
+                <a:srgbClr val="00B050"/>
+              </a:buClr>
+            </a:pPr>
+            <a:endParaRPr lang="en-US" sz="2000" dirty="0">
+              <a:solidFill>
+                <a:schemeClr val="bg1"/>
+              </a:solidFill>
+              <a:latin typeface="Bookman Old Style" panose="02050604050505020204" pitchFamily="18" charset="0"/>
+            </a:endParaRPr>
+          </a:p>
+          <a:p>
+            <a:pPr marL="285750" indent="-285750">
+              <a:buClr>
+                <a:srgbClr val="00B050"/>
+              </a:buClr>
+              <a:buFont typeface="Wingdings" panose="05000000000000000000" pitchFamily="2" charset="2"/>
+              <a:buChar char="ü"/>
+            </a:pPr>
+            <a:r>
+              <a:rPr lang="en-US" sz="2000" dirty="0">
+                <a:solidFill>
+                  <a:schemeClr val="bg1"/>
+                </a:solidFill>
+                <a:latin typeface="Bookman Old Style" panose="02050604050505020204" pitchFamily="18" charset="0"/>
+              </a:rPr>
+              <a:t>Each record represents a single order item with attributes like Order ID, Date, Category, Size, Qty, Total Amount, City, and Status.</a:t>
+            </a:r>
+          </a:p>
+        </p:txBody>
+      </p:sp>
+      <p:pic>
+        <p:nvPicPr>
+          <p:cNvPr id="5" name="Picture 4">
+            <a:extLst>
+              <a:ext uri="{FF2B5EF4-FFF2-40B4-BE49-F238E27FC236}">
+                <a16:creationId xmlns:a16="http://schemas.microsoft.com/office/drawing/2014/main" id="{D307A0F9-5A69-3E14-BAED-A57C9907F892}"/>
+              </a:ext>
+            </a:extLst>
+          </p:cNvPr>
+          <p:cNvPicPr>
+            <a:picLocks noChangeAspect="1"/>
+          </p:cNvPicPr>
+          <p:nvPr/>
+        </p:nvPicPr>
+        <p:blipFill>
+          <a:blip r:embed="rId3">
+            <a:extLst>
+              <a:ext uri="{28A0092B-C50C-407E-A947-70E740481C1C}">
+                <a14:useLocalDpi xmlns:a14="http://schemas.microsoft.com/office/drawing/2010/main" val="0"/>
+              </a:ext>
+            </a:extLst>
+          </a:blip>
+          <a:srcRect l="24552" r="26147"/>
+          <a:stretch>
+            <a:fillRect/>
+          </a:stretch>
+        </p:blipFill>
+        <p:spPr>
+          <a:xfrm>
+            <a:off x="7068312" y="1473707"/>
+            <a:ext cx="3622179" cy="3910585"/>
+          </a:xfrm>
+          <a:prstGeom prst="roundRect">
+            <a:avLst>
+              <a:gd name="adj" fmla="val 16667"/>
+            </a:avLst>
+          </a:prstGeom>
+          <a:ln>
+            <a:noFill/>
+          </a:ln>
+          <a:effectLst>
+            <a:outerShdw blurRad="152400" dist="12000" dir="900000" sy="98000" kx="110000" ky="200000" algn="tl" rotWithShape="0">
+              <a:srgbClr val="000000">
+                <a:alpha val="30000"/>
+              </a:srgbClr>
+            </a:outerShdw>
+          </a:effectLst>
+          <a:scene3d>
+            <a:camera prst="perspectiveRelaxed">
+              <a:rot lat="19800000" lon="1200000" rev="20820000"/>
+            </a:camera>
+            <a:lightRig rig="threePt" dir="t"/>
+          </a:scene3d>
+          <a:sp3d contourW="6350" prstMaterial="matte">
+            <a:bevelT w="101600" h="101600"/>
+            <a:contourClr>
+              <a:srgbClr val="969696"/>
+            </a:contourClr>
+          </a:sp3d>
+        </p:spPr>
+      </p:pic>
+    </p:spTree>
+    <p:extLst>
+      <p:ext uri="{BB962C8B-B14F-4D97-AF65-F5344CB8AC3E}">
+        <p14:creationId xmlns:p14="http://schemas.microsoft.com/office/powerpoint/2010/main" val="2058403362"/>
       </p:ext>
     </p:extLst>
   </p:cSld>

</xml_diff>

<commit_message>
add some point in ppt
</commit_message>
<xml_diff>
--- a/Report/Amazon Sales Report.pptx
+++ b/Report/Amazon Sales Report.pptx
@@ -17,6 +17,19 @@
     <p:sldId id="266" r:id="rId11"/>
     <p:sldId id="268" r:id="rId12"/>
     <p:sldId id="267" r:id="rId13"/>
+    <p:sldId id="269" r:id="rId14"/>
+    <p:sldId id="270" r:id="rId15"/>
+    <p:sldId id="271" r:id="rId16"/>
+    <p:sldId id="272" r:id="rId17"/>
+    <p:sldId id="273" r:id="rId18"/>
+    <p:sldId id="274" r:id="rId19"/>
+    <p:sldId id="275" r:id="rId20"/>
+    <p:sldId id="276" r:id="rId21"/>
+    <p:sldId id="277" r:id="rId22"/>
+    <p:sldId id="278" r:id="rId23"/>
+    <p:sldId id="279" r:id="rId24"/>
+    <p:sldId id="280" r:id="rId25"/>
+    <p:sldId id="281" r:id="rId26"/>
   </p:sldIdLst>
   <p:sldSz cx="12192000" cy="6858000"/>
   <p:notesSz cx="6858000" cy="9144000"/>
@@ -4367,12 +4380,18 @@
 </p:sld>
 </file>
 
-<file path=ppt/slides/slide2.xml><?xml version="1.0" encoding="utf-8"?>
+<file path=ppt/slides/slide13.xml><?xml version="1.0" encoding="utf-8"?>
 <p:sld xmlns:a="http://schemas.openxmlformats.org/drawingml/2006/main" xmlns:r="http://schemas.openxmlformats.org/officeDocument/2006/relationships" xmlns:p="http://schemas.openxmlformats.org/presentationml/2006/main">
   <p:cSld>
     <p:spTree>
       <p:nvGrpSpPr>
-        <p:cNvPr id="1" name=""/>
+        <p:cNvPr id="1" name="">
+          <a:extLst>
+            <a:ext uri="{FF2B5EF4-FFF2-40B4-BE49-F238E27FC236}">
+              <a16:creationId xmlns:a16="http://schemas.microsoft.com/office/drawing/2014/main" id="{F2D74E86-DBDB-127A-0BCE-B036AED9E85A}"/>
+            </a:ext>
+          </a:extLst>
+        </p:cNvPr>
         <p:cNvGrpSpPr/>
         <p:nvPr/>
       </p:nvGrpSpPr>
@@ -4389,7 +4408,7 @@
           <p:cNvPr id="4" name="Picture 3">
             <a:extLst>
               <a:ext uri="{FF2B5EF4-FFF2-40B4-BE49-F238E27FC236}">
-                <a16:creationId xmlns:a16="http://schemas.microsoft.com/office/drawing/2014/main" id="{1B86986A-FBEE-87DB-FF12-E5EF9541EA24}"/>
+                <a16:creationId xmlns:a16="http://schemas.microsoft.com/office/drawing/2014/main" id="{72D27382-C293-AF6B-97F1-7C9E4FFBED6C}"/>
               </a:ext>
             </a:extLst>
           </p:cNvPr>
@@ -4431,6 +4450,979 @@
           <p:cNvPr id="5" name="TextBox 4">
             <a:extLst>
               <a:ext uri="{FF2B5EF4-FFF2-40B4-BE49-F238E27FC236}">
+                <a16:creationId xmlns:a16="http://schemas.microsoft.com/office/drawing/2014/main" id="{3D3BB38B-68D9-AAF3-6DBC-5454B031426F}"/>
+              </a:ext>
+            </a:extLst>
+          </p:cNvPr>
+          <p:cNvSpPr txBox="1"/>
+          <p:nvPr/>
+        </p:nvSpPr>
+        <p:spPr>
+          <a:xfrm>
+            <a:off x="5286447" y="2459504"/>
+            <a:ext cx="6619041" cy="1938992"/>
+          </a:xfrm>
+          <a:prstGeom prst="rect">
+            <a:avLst/>
+          </a:prstGeom>
+          <a:noFill/>
+        </p:spPr>
+        <p:txBody>
+          <a:bodyPr wrap="square" rtlCol="0">
+            <a:spAutoFit/>
+          </a:bodyPr>
+          <a:lstStyle/>
+          <a:p>
+            <a:r>
+              <a:rPr lang="en-IN" sz="6000" dirty="0">
+                <a:solidFill>
+                  <a:schemeClr val="bg1"/>
+                </a:solidFill>
+                <a:latin typeface="Bookman Old Style" panose="02050604050505020204" pitchFamily="18" charset="0"/>
+              </a:rPr>
+              <a:t>Data Cleaning &amp; Transformation</a:t>
+            </a:r>
+          </a:p>
+        </p:txBody>
+      </p:sp>
+      <p:sp>
+        <p:nvSpPr>
+          <p:cNvPr id="7" name="Flowchart: Connector 6">
+            <a:extLst>
+              <a:ext uri="{FF2B5EF4-FFF2-40B4-BE49-F238E27FC236}">
+                <a16:creationId xmlns:a16="http://schemas.microsoft.com/office/drawing/2014/main" id="{2780D173-A3D4-9BAF-8B9F-36656E12F418}"/>
+              </a:ext>
+            </a:extLst>
+          </p:cNvPr>
+          <p:cNvSpPr/>
+          <p:nvPr/>
+        </p:nvSpPr>
+        <p:spPr>
+          <a:xfrm>
+            <a:off x="7777996" y="1224792"/>
+            <a:ext cx="1080000" cy="1080000"/>
+          </a:xfrm>
+          <a:prstGeom prst="flowChartConnector">
+            <a:avLst/>
+          </a:prstGeom>
+          <a:noFill/>
+          <a:ln>
+            <a:solidFill>
+              <a:schemeClr val="accent4"/>
+            </a:solidFill>
+          </a:ln>
+        </p:spPr>
+        <p:style>
+          <a:lnRef idx="2">
+            <a:schemeClr val="accent1">
+              <a:shade val="15000"/>
+            </a:schemeClr>
+          </a:lnRef>
+          <a:fillRef idx="1">
+            <a:schemeClr val="accent1"/>
+          </a:fillRef>
+          <a:effectRef idx="0">
+            <a:schemeClr val="accent1"/>
+          </a:effectRef>
+          <a:fontRef idx="minor">
+            <a:schemeClr val="lt1"/>
+          </a:fontRef>
+        </p:style>
+        <p:txBody>
+          <a:bodyPr rtlCol="0" anchor="ctr"/>
+          <a:lstStyle/>
+          <a:p>
+            <a:pPr algn="ctr"/>
+            <a:r>
+              <a:rPr lang="en-IN" sz="3600" dirty="0">
+                <a:solidFill>
+                  <a:schemeClr val="accent4"/>
+                </a:solidFill>
+                <a:effectLst>
+                  <a:outerShdw blurRad="50800" dist="38100" dir="2700000" algn="tl" rotWithShape="0">
+                    <a:prstClr val="black">
+                      <a:alpha val="40000"/>
+                    </a:prstClr>
+                  </a:outerShdw>
+                </a:effectLst>
+                <a:latin typeface="Bookman Old Style" panose="02050604050505020204" pitchFamily="18" charset="0"/>
+              </a:rPr>
+              <a:t>03</a:t>
+            </a:r>
+          </a:p>
+        </p:txBody>
+      </p:sp>
+      <p:pic>
+        <p:nvPicPr>
+          <p:cNvPr id="11" name="Picture 10">
+            <a:extLst>
+              <a:ext uri="{FF2B5EF4-FFF2-40B4-BE49-F238E27FC236}">
+                <a16:creationId xmlns:a16="http://schemas.microsoft.com/office/drawing/2014/main" id="{2C8161A4-DC5E-14EA-69C5-80ACA57E7EB0}"/>
+              </a:ext>
+            </a:extLst>
+          </p:cNvPr>
+          <p:cNvPicPr>
+            <a:picLocks noChangeAspect="1"/>
+          </p:cNvPicPr>
+          <p:nvPr/>
+        </p:nvPicPr>
+        <p:blipFill>
+          <a:blip r:embed="rId3">
+            <a:extLst>
+              <a:ext uri="{28A0092B-C50C-407E-A947-70E740481C1C}">
+                <a14:useLocalDpi xmlns:a14="http://schemas.microsoft.com/office/drawing/2010/main" val="0"/>
+              </a:ext>
+            </a:extLst>
+          </a:blip>
+          <a:stretch>
+            <a:fillRect/>
+          </a:stretch>
+        </p:blipFill>
+        <p:spPr>
+          <a:xfrm>
+            <a:off x="154567" y="1425960"/>
+            <a:ext cx="7397947" cy="5230872"/>
+          </a:xfrm>
+          <a:prstGeom prst="rect">
+            <a:avLst/>
+          </a:prstGeom>
+          <a:effectLst>
+            <a:glow rad="101600">
+              <a:schemeClr val="accent3">
+                <a:satMod val="175000"/>
+                <a:alpha val="40000"/>
+              </a:schemeClr>
+            </a:glow>
+            <a:outerShdw blurRad="76200" dir="18900000" sy="23000" kx="-1200000" algn="bl" rotWithShape="0">
+              <a:prstClr val="black">
+                <a:alpha val="20000"/>
+              </a:prstClr>
+            </a:outerShdw>
+          </a:effectLst>
+        </p:spPr>
+      </p:pic>
+    </p:spTree>
+    <p:extLst>
+      <p:ext uri="{BB962C8B-B14F-4D97-AF65-F5344CB8AC3E}">
+        <p14:creationId xmlns:p14="http://schemas.microsoft.com/office/powerpoint/2010/main" val="3064719254"/>
+      </p:ext>
+    </p:extLst>
+  </p:cSld>
+  <p:clrMapOvr>
+    <a:masterClrMapping/>
+  </p:clrMapOvr>
+</p:sld>
+</file>
+
+<file path=ppt/slides/slide14.xml><?xml version="1.0" encoding="utf-8"?>
+<p:sld xmlns:a="http://schemas.openxmlformats.org/drawingml/2006/main" xmlns:r="http://schemas.openxmlformats.org/officeDocument/2006/relationships" xmlns:p="http://schemas.openxmlformats.org/presentationml/2006/main">
+  <p:cSld>
+    <p:spTree>
+      <p:nvGrpSpPr>
+        <p:cNvPr id="1" name=""/>
+        <p:cNvGrpSpPr/>
+        <p:nvPr/>
+      </p:nvGrpSpPr>
+      <p:grpSpPr>
+        <a:xfrm>
+          <a:off x="0" y="0"/>
+          <a:ext cx="0" cy="0"/>
+          <a:chOff x="0" y="0"/>
+          <a:chExt cx="0" cy="0"/>
+        </a:xfrm>
+      </p:grpSpPr>
+      <p:pic>
+        <p:nvPicPr>
+          <p:cNvPr id="3" name="Picture 2">
+            <a:extLst>
+              <a:ext uri="{FF2B5EF4-FFF2-40B4-BE49-F238E27FC236}">
+                <a16:creationId xmlns:a16="http://schemas.microsoft.com/office/drawing/2014/main" id="{79E2B8DF-5074-C0AA-0770-79D8A671192A}"/>
+              </a:ext>
+            </a:extLst>
+          </p:cNvPr>
+          <p:cNvPicPr>
+            <a:picLocks noChangeAspect="1"/>
+          </p:cNvPicPr>
+          <p:nvPr/>
+        </p:nvPicPr>
+        <p:blipFill>
+          <a:blip r:embed="rId2">
+            <a:extLst>
+              <a:ext uri="{28A0092B-C50C-407E-A947-70E740481C1C}">
+                <a14:useLocalDpi xmlns:a14="http://schemas.microsoft.com/office/drawing/2010/main" val="0"/>
+              </a:ext>
+            </a:extLst>
+          </a:blip>
+          <a:stretch>
+            <a:fillRect/>
+          </a:stretch>
+        </p:blipFill>
+        <p:spPr>
+          <a:xfrm>
+            <a:off x="0" y="0"/>
+            <a:ext cx="12192000" cy="6858000"/>
+          </a:xfrm>
+          <a:prstGeom prst="rect">
+            <a:avLst/>
+          </a:prstGeom>
+        </p:spPr>
+      </p:pic>
+    </p:spTree>
+    <p:extLst>
+      <p:ext uri="{BB962C8B-B14F-4D97-AF65-F5344CB8AC3E}">
+        <p14:creationId xmlns:p14="http://schemas.microsoft.com/office/powerpoint/2010/main" val="1624174513"/>
+      </p:ext>
+    </p:extLst>
+  </p:cSld>
+  <p:clrMapOvr>
+    <a:masterClrMapping/>
+  </p:clrMapOvr>
+</p:sld>
+</file>
+
+<file path=ppt/slides/slide15.xml><?xml version="1.0" encoding="utf-8"?>
+<p:sld xmlns:a="http://schemas.openxmlformats.org/drawingml/2006/main" xmlns:r="http://schemas.openxmlformats.org/officeDocument/2006/relationships" xmlns:p="http://schemas.openxmlformats.org/presentationml/2006/main">
+  <p:cSld>
+    <p:spTree>
+      <p:nvGrpSpPr>
+        <p:cNvPr id="1" name="">
+          <a:extLst>
+            <a:ext uri="{FF2B5EF4-FFF2-40B4-BE49-F238E27FC236}">
+              <a16:creationId xmlns:a16="http://schemas.microsoft.com/office/drawing/2014/main" id="{6AFB7336-B8EC-0FEC-C582-4102CBC4719B}"/>
+            </a:ext>
+          </a:extLst>
+        </p:cNvPr>
+        <p:cNvGrpSpPr/>
+        <p:nvPr/>
+      </p:nvGrpSpPr>
+      <p:grpSpPr>
+        <a:xfrm>
+          <a:off x="0" y="0"/>
+          <a:ext cx="0" cy="0"/>
+          <a:chOff x="0" y="0"/>
+          <a:chExt cx="0" cy="0"/>
+        </a:xfrm>
+      </p:grpSpPr>
+      <p:pic>
+        <p:nvPicPr>
+          <p:cNvPr id="3" name="Picture 2">
+            <a:extLst>
+              <a:ext uri="{FF2B5EF4-FFF2-40B4-BE49-F238E27FC236}">
+                <a16:creationId xmlns:a16="http://schemas.microsoft.com/office/drawing/2014/main" id="{2AB8E0D5-7B93-9963-C55F-30E1129E1E6C}"/>
+              </a:ext>
+            </a:extLst>
+          </p:cNvPr>
+          <p:cNvPicPr>
+            <a:picLocks noChangeAspect="1"/>
+          </p:cNvPicPr>
+          <p:nvPr/>
+        </p:nvPicPr>
+        <p:blipFill>
+          <a:blip r:embed="rId2">
+            <a:extLst>
+              <a:ext uri="{28A0092B-C50C-407E-A947-70E740481C1C}">
+                <a14:useLocalDpi xmlns:a14="http://schemas.microsoft.com/office/drawing/2010/main" val="0"/>
+              </a:ext>
+            </a:extLst>
+          </a:blip>
+          <a:stretch>
+            <a:fillRect/>
+          </a:stretch>
+        </p:blipFill>
+        <p:spPr>
+          <a:xfrm>
+            <a:off x="0" y="0"/>
+            <a:ext cx="12192000" cy="6858000"/>
+          </a:xfrm>
+          <a:prstGeom prst="rect">
+            <a:avLst/>
+          </a:prstGeom>
+        </p:spPr>
+      </p:pic>
+      <p:sp>
+        <p:nvSpPr>
+          <p:cNvPr id="2" name="TextBox 1">
+            <a:extLst>
+              <a:ext uri="{FF2B5EF4-FFF2-40B4-BE49-F238E27FC236}">
+                <a16:creationId xmlns:a16="http://schemas.microsoft.com/office/drawing/2014/main" id="{D5933D58-6360-F66B-A3B3-A6F2B7E2BD23}"/>
+              </a:ext>
+            </a:extLst>
+          </p:cNvPr>
+          <p:cNvSpPr txBox="1"/>
+          <p:nvPr/>
+        </p:nvSpPr>
+        <p:spPr>
+          <a:xfrm>
+            <a:off x="5286447" y="2459504"/>
+            <a:ext cx="6619041" cy="1938992"/>
+          </a:xfrm>
+          <a:prstGeom prst="rect">
+            <a:avLst/>
+          </a:prstGeom>
+          <a:noFill/>
+        </p:spPr>
+        <p:txBody>
+          <a:bodyPr wrap="square" rtlCol="0">
+            <a:spAutoFit/>
+          </a:bodyPr>
+          <a:lstStyle/>
+          <a:p>
+            <a:r>
+              <a:rPr lang="en-IN" sz="6000" dirty="0">
+                <a:solidFill>
+                  <a:schemeClr val="bg1"/>
+                </a:solidFill>
+              </a:rPr>
+              <a:t>Dashboard Design &amp; Visualization</a:t>
+            </a:r>
+          </a:p>
+        </p:txBody>
+      </p:sp>
+      <p:sp>
+        <p:nvSpPr>
+          <p:cNvPr id="4" name="Flowchart: Connector 3">
+            <a:extLst>
+              <a:ext uri="{FF2B5EF4-FFF2-40B4-BE49-F238E27FC236}">
+                <a16:creationId xmlns:a16="http://schemas.microsoft.com/office/drawing/2014/main" id="{63B5D596-1F52-6A34-9D12-CE45CEECF4C2}"/>
+              </a:ext>
+            </a:extLst>
+          </p:cNvPr>
+          <p:cNvSpPr/>
+          <p:nvPr/>
+        </p:nvSpPr>
+        <p:spPr>
+          <a:xfrm>
+            <a:off x="7777996" y="1224792"/>
+            <a:ext cx="1080000" cy="1080000"/>
+          </a:xfrm>
+          <a:prstGeom prst="flowChartConnector">
+            <a:avLst/>
+          </a:prstGeom>
+          <a:noFill/>
+          <a:ln>
+            <a:solidFill>
+              <a:schemeClr val="accent4"/>
+            </a:solidFill>
+          </a:ln>
+        </p:spPr>
+        <p:style>
+          <a:lnRef idx="2">
+            <a:schemeClr val="accent1">
+              <a:shade val="15000"/>
+            </a:schemeClr>
+          </a:lnRef>
+          <a:fillRef idx="1">
+            <a:schemeClr val="accent1"/>
+          </a:fillRef>
+          <a:effectRef idx="0">
+            <a:schemeClr val="accent1"/>
+          </a:effectRef>
+          <a:fontRef idx="minor">
+            <a:schemeClr val="lt1"/>
+          </a:fontRef>
+        </p:style>
+        <p:txBody>
+          <a:bodyPr rtlCol="0" anchor="ctr"/>
+          <a:lstStyle/>
+          <a:p>
+            <a:pPr algn="ctr"/>
+            <a:r>
+              <a:rPr lang="en-IN" sz="3600" dirty="0">
+                <a:solidFill>
+                  <a:schemeClr val="accent4"/>
+                </a:solidFill>
+                <a:effectLst>
+                  <a:outerShdw blurRad="50800" dist="38100" dir="2700000" algn="tl" rotWithShape="0">
+                    <a:prstClr val="black">
+                      <a:alpha val="40000"/>
+                    </a:prstClr>
+                  </a:outerShdw>
+                </a:effectLst>
+                <a:latin typeface="Bookman Old Style" panose="02050604050505020204" pitchFamily="18" charset="0"/>
+              </a:rPr>
+              <a:t>04</a:t>
+            </a:r>
+          </a:p>
+        </p:txBody>
+      </p:sp>
+    </p:spTree>
+    <p:extLst>
+      <p:ext uri="{BB962C8B-B14F-4D97-AF65-F5344CB8AC3E}">
+        <p14:creationId xmlns:p14="http://schemas.microsoft.com/office/powerpoint/2010/main" val="3157404389"/>
+      </p:ext>
+    </p:extLst>
+  </p:cSld>
+  <p:clrMapOvr>
+    <a:masterClrMapping/>
+  </p:clrMapOvr>
+</p:sld>
+</file>
+
+<file path=ppt/slides/slide16.xml><?xml version="1.0" encoding="utf-8"?>
+<p:sld xmlns:a="http://schemas.openxmlformats.org/drawingml/2006/main" xmlns:r="http://schemas.openxmlformats.org/officeDocument/2006/relationships" xmlns:p="http://schemas.openxmlformats.org/presentationml/2006/main">
+  <p:cSld>
+    <p:spTree>
+      <p:nvGrpSpPr>
+        <p:cNvPr id="1" name="">
+          <a:extLst>
+            <a:ext uri="{FF2B5EF4-FFF2-40B4-BE49-F238E27FC236}">
+              <a16:creationId xmlns:a16="http://schemas.microsoft.com/office/drawing/2014/main" id="{3D8FC0AB-144D-BA5A-E91C-897BCC1E107B}"/>
+            </a:ext>
+          </a:extLst>
+        </p:cNvPr>
+        <p:cNvGrpSpPr/>
+        <p:nvPr/>
+      </p:nvGrpSpPr>
+      <p:grpSpPr>
+        <a:xfrm>
+          <a:off x="0" y="0"/>
+          <a:ext cx="0" cy="0"/>
+          <a:chOff x="0" y="0"/>
+          <a:chExt cx="0" cy="0"/>
+        </a:xfrm>
+      </p:grpSpPr>
+      <p:pic>
+        <p:nvPicPr>
+          <p:cNvPr id="3" name="Picture 2">
+            <a:extLst>
+              <a:ext uri="{FF2B5EF4-FFF2-40B4-BE49-F238E27FC236}">
+                <a16:creationId xmlns:a16="http://schemas.microsoft.com/office/drawing/2014/main" id="{F28942E7-F9D5-E172-6FDA-B98CD4E60B65}"/>
+              </a:ext>
+            </a:extLst>
+          </p:cNvPr>
+          <p:cNvPicPr>
+            <a:picLocks noChangeAspect="1"/>
+          </p:cNvPicPr>
+          <p:nvPr/>
+        </p:nvPicPr>
+        <p:blipFill>
+          <a:blip r:embed="rId2">
+            <a:extLst>
+              <a:ext uri="{28A0092B-C50C-407E-A947-70E740481C1C}">
+                <a14:useLocalDpi xmlns:a14="http://schemas.microsoft.com/office/drawing/2010/main" val="0"/>
+              </a:ext>
+            </a:extLst>
+          </a:blip>
+          <a:stretch>
+            <a:fillRect/>
+          </a:stretch>
+        </p:blipFill>
+        <p:spPr>
+          <a:xfrm>
+            <a:off x="0" y="0"/>
+            <a:ext cx="12192000" cy="6858000"/>
+          </a:xfrm>
+          <a:prstGeom prst="rect">
+            <a:avLst/>
+          </a:prstGeom>
+        </p:spPr>
+      </p:pic>
+    </p:spTree>
+    <p:extLst>
+      <p:ext uri="{BB962C8B-B14F-4D97-AF65-F5344CB8AC3E}">
+        <p14:creationId xmlns:p14="http://schemas.microsoft.com/office/powerpoint/2010/main" val="3393959080"/>
+      </p:ext>
+    </p:extLst>
+  </p:cSld>
+  <p:clrMapOvr>
+    <a:masterClrMapping/>
+  </p:clrMapOvr>
+</p:sld>
+</file>
+
+<file path=ppt/slides/slide17.xml><?xml version="1.0" encoding="utf-8"?>
+<p:sld xmlns:a="http://schemas.openxmlformats.org/drawingml/2006/main" xmlns:r="http://schemas.openxmlformats.org/officeDocument/2006/relationships" xmlns:p="http://schemas.openxmlformats.org/presentationml/2006/main">
+  <p:cSld>
+    <p:spTree>
+      <p:nvGrpSpPr>
+        <p:cNvPr id="1" name="">
+          <a:extLst>
+            <a:ext uri="{FF2B5EF4-FFF2-40B4-BE49-F238E27FC236}">
+              <a16:creationId xmlns:a16="http://schemas.microsoft.com/office/drawing/2014/main" id="{9094FF13-A281-2D32-6962-A7D066308266}"/>
+            </a:ext>
+          </a:extLst>
+        </p:cNvPr>
+        <p:cNvGrpSpPr/>
+        <p:nvPr/>
+      </p:nvGrpSpPr>
+      <p:grpSpPr>
+        <a:xfrm>
+          <a:off x="0" y="0"/>
+          <a:ext cx="0" cy="0"/>
+          <a:chOff x="0" y="0"/>
+          <a:chExt cx="0" cy="0"/>
+        </a:xfrm>
+      </p:grpSpPr>
+      <p:pic>
+        <p:nvPicPr>
+          <p:cNvPr id="3" name="Picture 2">
+            <a:extLst>
+              <a:ext uri="{FF2B5EF4-FFF2-40B4-BE49-F238E27FC236}">
+                <a16:creationId xmlns:a16="http://schemas.microsoft.com/office/drawing/2014/main" id="{41F61AB8-4F67-AA2F-E9A2-FDAA0EA8039E}"/>
+              </a:ext>
+            </a:extLst>
+          </p:cNvPr>
+          <p:cNvPicPr>
+            <a:picLocks noChangeAspect="1"/>
+          </p:cNvPicPr>
+          <p:nvPr/>
+        </p:nvPicPr>
+        <p:blipFill>
+          <a:blip r:embed="rId2">
+            <a:extLst>
+              <a:ext uri="{28A0092B-C50C-407E-A947-70E740481C1C}">
+                <a14:useLocalDpi xmlns:a14="http://schemas.microsoft.com/office/drawing/2010/main" val="0"/>
+              </a:ext>
+            </a:extLst>
+          </a:blip>
+          <a:stretch>
+            <a:fillRect/>
+          </a:stretch>
+        </p:blipFill>
+        <p:spPr>
+          <a:xfrm>
+            <a:off x="0" y="0"/>
+            <a:ext cx="12192000" cy="6858000"/>
+          </a:xfrm>
+          <a:prstGeom prst="rect">
+            <a:avLst/>
+          </a:prstGeom>
+        </p:spPr>
+      </p:pic>
+      <p:sp>
+        <p:nvSpPr>
+          <p:cNvPr id="2" name="TextBox 1">
+            <a:extLst>
+              <a:ext uri="{FF2B5EF4-FFF2-40B4-BE49-F238E27FC236}">
+                <a16:creationId xmlns:a16="http://schemas.microsoft.com/office/drawing/2014/main" id="{D8F10DCE-971B-BC1C-1DA8-B04641021FC1}"/>
+              </a:ext>
+            </a:extLst>
+          </p:cNvPr>
+          <p:cNvSpPr txBox="1"/>
+          <p:nvPr/>
+        </p:nvSpPr>
+        <p:spPr>
+          <a:xfrm>
+            <a:off x="5286447" y="2459504"/>
+            <a:ext cx="6619041" cy="1938992"/>
+          </a:xfrm>
+          <a:prstGeom prst="rect">
+            <a:avLst/>
+          </a:prstGeom>
+          <a:noFill/>
+        </p:spPr>
+        <p:txBody>
+          <a:bodyPr wrap="square" rtlCol="0">
+            <a:spAutoFit/>
+          </a:bodyPr>
+          <a:lstStyle/>
+          <a:p>
+            <a:r>
+              <a:rPr lang="en-IN" sz="6000" dirty="0">
+                <a:solidFill>
+                  <a:schemeClr val="bg1"/>
+                </a:solidFill>
+                <a:latin typeface="Bookman Old Style" panose="02050604050505020204" pitchFamily="18" charset="0"/>
+              </a:rPr>
+              <a:t>Key Insights &amp; Findings</a:t>
+            </a:r>
+          </a:p>
+        </p:txBody>
+      </p:sp>
+      <p:sp>
+        <p:nvSpPr>
+          <p:cNvPr id="4" name="Flowchart: Connector 3">
+            <a:extLst>
+              <a:ext uri="{FF2B5EF4-FFF2-40B4-BE49-F238E27FC236}">
+                <a16:creationId xmlns:a16="http://schemas.microsoft.com/office/drawing/2014/main" id="{E9FC07DD-8E27-EBC5-2BC3-8F66E97BD75B}"/>
+              </a:ext>
+            </a:extLst>
+          </p:cNvPr>
+          <p:cNvSpPr/>
+          <p:nvPr/>
+        </p:nvSpPr>
+        <p:spPr>
+          <a:xfrm>
+            <a:off x="7777996" y="1224792"/>
+            <a:ext cx="1080000" cy="1080000"/>
+          </a:xfrm>
+          <a:prstGeom prst="flowChartConnector">
+            <a:avLst/>
+          </a:prstGeom>
+          <a:noFill/>
+          <a:ln>
+            <a:solidFill>
+              <a:schemeClr val="accent4"/>
+            </a:solidFill>
+          </a:ln>
+        </p:spPr>
+        <p:style>
+          <a:lnRef idx="2">
+            <a:schemeClr val="accent1">
+              <a:shade val="15000"/>
+            </a:schemeClr>
+          </a:lnRef>
+          <a:fillRef idx="1">
+            <a:schemeClr val="accent1"/>
+          </a:fillRef>
+          <a:effectRef idx="0">
+            <a:schemeClr val="accent1"/>
+          </a:effectRef>
+          <a:fontRef idx="minor">
+            <a:schemeClr val="lt1"/>
+          </a:fontRef>
+        </p:style>
+        <p:txBody>
+          <a:bodyPr rtlCol="0" anchor="ctr"/>
+          <a:lstStyle/>
+          <a:p>
+            <a:pPr algn="ctr"/>
+            <a:r>
+              <a:rPr lang="en-IN" sz="3600" dirty="0">
+                <a:solidFill>
+                  <a:schemeClr val="accent4"/>
+                </a:solidFill>
+                <a:effectLst>
+                  <a:outerShdw blurRad="50800" dist="38100" dir="2700000" algn="tl" rotWithShape="0">
+                    <a:prstClr val="black">
+                      <a:alpha val="40000"/>
+                    </a:prstClr>
+                  </a:outerShdw>
+                </a:effectLst>
+                <a:latin typeface="Bookman Old Style" panose="02050604050505020204" pitchFamily="18" charset="0"/>
+              </a:rPr>
+              <a:t>05</a:t>
+            </a:r>
+          </a:p>
+        </p:txBody>
+      </p:sp>
+    </p:spTree>
+    <p:extLst>
+      <p:ext uri="{BB962C8B-B14F-4D97-AF65-F5344CB8AC3E}">
+        <p14:creationId xmlns:p14="http://schemas.microsoft.com/office/powerpoint/2010/main" val="101803682"/>
+      </p:ext>
+    </p:extLst>
+  </p:cSld>
+  <p:clrMapOvr>
+    <a:masterClrMapping/>
+  </p:clrMapOvr>
+</p:sld>
+</file>
+
+<file path=ppt/slides/slide18.xml><?xml version="1.0" encoding="utf-8"?>
+<p:sld xmlns:a="http://schemas.openxmlformats.org/drawingml/2006/main" xmlns:r="http://schemas.openxmlformats.org/officeDocument/2006/relationships" xmlns:p="http://schemas.openxmlformats.org/presentationml/2006/main">
+  <p:cSld>
+    <p:spTree>
+      <p:nvGrpSpPr>
+        <p:cNvPr id="1" name="">
+          <a:extLst>
+            <a:ext uri="{FF2B5EF4-FFF2-40B4-BE49-F238E27FC236}">
+              <a16:creationId xmlns:a16="http://schemas.microsoft.com/office/drawing/2014/main" id="{A8D76B65-3565-5843-5FAA-4DD0549C075A}"/>
+            </a:ext>
+          </a:extLst>
+        </p:cNvPr>
+        <p:cNvGrpSpPr/>
+        <p:nvPr/>
+      </p:nvGrpSpPr>
+      <p:grpSpPr>
+        <a:xfrm>
+          <a:off x="0" y="0"/>
+          <a:ext cx="0" cy="0"/>
+          <a:chOff x="0" y="0"/>
+          <a:chExt cx="0" cy="0"/>
+        </a:xfrm>
+      </p:grpSpPr>
+      <p:pic>
+        <p:nvPicPr>
+          <p:cNvPr id="3" name="Picture 2">
+            <a:extLst>
+              <a:ext uri="{FF2B5EF4-FFF2-40B4-BE49-F238E27FC236}">
+                <a16:creationId xmlns:a16="http://schemas.microsoft.com/office/drawing/2014/main" id="{5B12D6E3-20BE-3532-99A4-F76EBD8893F4}"/>
+              </a:ext>
+            </a:extLst>
+          </p:cNvPr>
+          <p:cNvPicPr>
+            <a:picLocks noChangeAspect="1"/>
+          </p:cNvPicPr>
+          <p:nvPr/>
+        </p:nvPicPr>
+        <p:blipFill>
+          <a:blip r:embed="rId2">
+            <a:extLst>
+              <a:ext uri="{28A0092B-C50C-407E-A947-70E740481C1C}">
+                <a14:useLocalDpi xmlns:a14="http://schemas.microsoft.com/office/drawing/2010/main" val="0"/>
+              </a:ext>
+            </a:extLst>
+          </a:blip>
+          <a:stretch>
+            <a:fillRect/>
+          </a:stretch>
+        </p:blipFill>
+        <p:spPr>
+          <a:xfrm>
+            <a:off x="0" y="0"/>
+            <a:ext cx="12192000" cy="6858000"/>
+          </a:xfrm>
+          <a:prstGeom prst="rect">
+            <a:avLst/>
+          </a:prstGeom>
+        </p:spPr>
+      </p:pic>
+    </p:spTree>
+    <p:extLst>
+      <p:ext uri="{BB962C8B-B14F-4D97-AF65-F5344CB8AC3E}">
+        <p14:creationId xmlns:p14="http://schemas.microsoft.com/office/powerpoint/2010/main" val="317802434"/>
+      </p:ext>
+    </p:extLst>
+  </p:cSld>
+  <p:clrMapOvr>
+    <a:masterClrMapping/>
+  </p:clrMapOvr>
+</p:sld>
+</file>
+
+<file path=ppt/slides/slide19.xml><?xml version="1.0" encoding="utf-8"?>
+<p:sld xmlns:a="http://schemas.openxmlformats.org/drawingml/2006/main" xmlns:r="http://schemas.openxmlformats.org/officeDocument/2006/relationships" xmlns:p="http://schemas.openxmlformats.org/presentationml/2006/main">
+  <p:cSld>
+    <p:spTree>
+      <p:nvGrpSpPr>
+        <p:cNvPr id="1" name="">
+          <a:extLst>
+            <a:ext uri="{FF2B5EF4-FFF2-40B4-BE49-F238E27FC236}">
+              <a16:creationId xmlns:a16="http://schemas.microsoft.com/office/drawing/2014/main" id="{FBF880B8-3D42-B523-C0F5-E4DA1A561094}"/>
+            </a:ext>
+          </a:extLst>
+        </p:cNvPr>
+        <p:cNvGrpSpPr/>
+        <p:nvPr/>
+      </p:nvGrpSpPr>
+      <p:grpSpPr>
+        <a:xfrm>
+          <a:off x="0" y="0"/>
+          <a:ext cx="0" cy="0"/>
+          <a:chOff x="0" y="0"/>
+          <a:chExt cx="0" cy="0"/>
+        </a:xfrm>
+      </p:grpSpPr>
+      <p:pic>
+        <p:nvPicPr>
+          <p:cNvPr id="3" name="Picture 2">
+            <a:extLst>
+              <a:ext uri="{FF2B5EF4-FFF2-40B4-BE49-F238E27FC236}">
+                <a16:creationId xmlns:a16="http://schemas.microsoft.com/office/drawing/2014/main" id="{D70E622A-1412-CB91-236F-6FB894189718}"/>
+              </a:ext>
+            </a:extLst>
+          </p:cNvPr>
+          <p:cNvPicPr>
+            <a:picLocks noChangeAspect="1"/>
+          </p:cNvPicPr>
+          <p:nvPr/>
+        </p:nvPicPr>
+        <p:blipFill>
+          <a:blip r:embed="rId2">
+            <a:extLst>
+              <a:ext uri="{28A0092B-C50C-407E-A947-70E740481C1C}">
+                <a14:useLocalDpi xmlns:a14="http://schemas.microsoft.com/office/drawing/2010/main" val="0"/>
+              </a:ext>
+            </a:extLst>
+          </a:blip>
+          <a:stretch>
+            <a:fillRect/>
+          </a:stretch>
+        </p:blipFill>
+        <p:spPr>
+          <a:xfrm>
+            <a:off x="0" y="0"/>
+            <a:ext cx="12192000" cy="6858000"/>
+          </a:xfrm>
+          <a:prstGeom prst="rect">
+            <a:avLst/>
+          </a:prstGeom>
+        </p:spPr>
+      </p:pic>
+      <p:sp>
+        <p:nvSpPr>
+          <p:cNvPr id="2" name="TextBox 1">
+            <a:extLst>
+              <a:ext uri="{FF2B5EF4-FFF2-40B4-BE49-F238E27FC236}">
+                <a16:creationId xmlns:a16="http://schemas.microsoft.com/office/drawing/2014/main" id="{674C2F60-C38A-EAD9-54CA-BA822FEE44BA}"/>
+              </a:ext>
+            </a:extLst>
+          </p:cNvPr>
+          <p:cNvSpPr txBox="1"/>
+          <p:nvPr/>
+        </p:nvSpPr>
+        <p:spPr>
+          <a:xfrm>
+            <a:off x="5286447" y="2459504"/>
+            <a:ext cx="6619041" cy="1938992"/>
+          </a:xfrm>
+          <a:prstGeom prst="rect">
+            <a:avLst/>
+          </a:prstGeom>
+          <a:noFill/>
+        </p:spPr>
+        <p:txBody>
+          <a:bodyPr wrap="square" rtlCol="0">
+            <a:spAutoFit/>
+          </a:bodyPr>
+          <a:lstStyle/>
+          <a:p>
+            <a:r>
+              <a:rPr lang="en-IN" sz="6000" dirty="0">
+                <a:solidFill>
+                  <a:schemeClr val="bg1"/>
+                </a:solidFill>
+              </a:rPr>
+              <a:t>Tools &amp; Technologies Used</a:t>
+            </a:r>
+          </a:p>
+        </p:txBody>
+      </p:sp>
+      <p:sp>
+        <p:nvSpPr>
+          <p:cNvPr id="4" name="Flowchart: Connector 3">
+            <a:extLst>
+              <a:ext uri="{FF2B5EF4-FFF2-40B4-BE49-F238E27FC236}">
+                <a16:creationId xmlns:a16="http://schemas.microsoft.com/office/drawing/2014/main" id="{B9EB6B21-BE5D-EC3D-495B-4124D5D990EF}"/>
+              </a:ext>
+            </a:extLst>
+          </p:cNvPr>
+          <p:cNvSpPr/>
+          <p:nvPr/>
+        </p:nvSpPr>
+        <p:spPr>
+          <a:xfrm>
+            <a:off x="7777996" y="1224792"/>
+            <a:ext cx="1080000" cy="1080000"/>
+          </a:xfrm>
+          <a:prstGeom prst="flowChartConnector">
+            <a:avLst/>
+          </a:prstGeom>
+          <a:noFill/>
+          <a:ln>
+            <a:solidFill>
+              <a:schemeClr val="accent4"/>
+            </a:solidFill>
+          </a:ln>
+        </p:spPr>
+        <p:style>
+          <a:lnRef idx="2">
+            <a:schemeClr val="accent1">
+              <a:shade val="15000"/>
+            </a:schemeClr>
+          </a:lnRef>
+          <a:fillRef idx="1">
+            <a:schemeClr val="accent1"/>
+          </a:fillRef>
+          <a:effectRef idx="0">
+            <a:schemeClr val="accent1"/>
+          </a:effectRef>
+          <a:fontRef idx="minor">
+            <a:schemeClr val="lt1"/>
+          </a:fontRef>
+        </p:style>
+        <p:txBody>
+          <a:bodyPr rtlCol="0" anchor="ctr"/>
+          <a:lstStyle/>
+          <a:p>
+            <a:pPr algn="ctr"/>
+            <a:r>
+              <a:rPr lang="en-IN" sz="3600" dirty="0">
+                <a:solidFill>
+                  <a:schemeClr val="accent4"/>
+                </a:solidFill>
+                <a:effectLst>
+                  <a:outerShdw blurRad="50800" dist="38100" dir="2700000" algn="tl" rotWithShape="0">
+                    <a:prstClr val="black">
+                      <a:alpha val="40000"/>
+                    </a:prstClr>
+                  </a:outerShdw>
+                </a:effectLst>
+                <a:latin typeface="Bookman Old Style" panose="02050604050505020204" pitchFamily="18" charset="0"/>
+              </a:rPr>
+              <a:t>06</a:t>
+            </a:r>
+          </a:p>
+        </p:txBody>
+      </p:sp>
+    </p:spTree>
+    <p:extLst>
+      <p:ext uri="{BB962C8B-B14F-4D97-AF65-F5344CB8AC3E}">
+        <p14:creationId xmlns:p14="http://schemas.microsoft.com/office/powerpoint/2010/main" val="1186187453"/>
+      </p:ext>
+    </p:extLst>
+  </p:cSld>
+  <p:clrMapOvr>
+    <a:masterClrMapping/>
+  </p:clrMapOvr>
+</p:sld>
+</file>
+
+<file path=ppt/slides/slide2.xml><?xml version="1.0" encoding="utf-8"?>
+<p:sld xmlns:a="http://schemas.openxmlformats.org/drawingml/2006/main" xmlns:r="http://schemas.openxmlformats.org/officeDocument/2006/relationships" xmlns:p="http://schemas.openxmlformats.org/presentationml/2006/main">
+  <p:cSld>
+    <p:spTree>
+      <p:nvGrpSpPr>
+        <p:cNvPr id="1" name=""/>
+        <p:cNvGrpSpPr/>
+        <p:nvPr/>
+      </p:nvGrpSpPr>
+      <p:grpSpPr>
+        <a:xfrm>
+          <a:off x="0" y="0"/>
+          <a:ext cx="0" cy="0"/>
+          <a:chOff x="0" y="0"/>
+          <a:chExt cx="0" cy="0"/>
+        </a:xfrm>
+      </p:grpSpPr>
+      <p:pic>
+        <p:nvPicPr>
+          <p:cNvPr id="4" name="Picture 3">
+            <a:extLst>
+              <a:ext uri="{FF2B5EF4-FFF2-40B4-BE49-F238E27FC236}">
+                <a16:creationId xmlns:a16="http://schemas.microsoft.com/office/drawing/2014/main" id="{1B86986A-FBEE-87DB-FF12-E5EF9541EA24}"/>
+              </a:ext>
+            </a:extLst>
+          </p:cNvPr>
+          <p:cNvPicPr>
+            <a:picLocks noChangeAspect="1"/>
+          </p:cNvPicPr>
+          <p:nvPr/>
+        </p:nvPicPr>
+        <p:blipFill>
+          <a:blip r:embed="rId2">
+            <a:extLst>
+              <a:ext uri="{28A0092B-C50C-407E-A947-70E740481C1C}">
+                <a14:useLocalDpi xmlns:a14="http://schemas.microsoft.com/office/drawing/2010/main" val="0"/>
+              </a:ext>
+            </a:extLst>
+          </a:blip>
+          <a:stretch>
+            <a:fillRect/>
+          </a:stretch>
+        </p:blipFill>
+        <p:spPr>
+          <a:xfrm>
+            <a:off x="0" y="0"/>
+            <a:ext cx="12192000" cy="6858000"/>
+          </a:xfrm>
+          <a:prstGeom prst="rect">
+            <a:avLst/>
+          </a:prstGeom>
+          <a:ln>
+            <a:noFill/>
+          </a:ln>
+          <a:effectLst>
+            <a:softEdge rad="112500"/>
+          </a:effectLst>
+        </p:spPr>
+      </p:pic>
+      <p:sp>
+        <p:nvSpPr>
+          <p:cNvPr id="5" name="TextBox 4">
+            <a:extLst>
+              <a:ext uri="{FF2B5EF4-FFF2-40B4-BE49-F238E27FC236}">
                 <a16:creationId xmlns:a16="http://schemas.microsoft.com/office/drawing/2014/main" id="{9EE76205-8F05-395F-A74B-C70F58E444C7}"/>
               </a:ext>
             </a:extLst>
@@ -4636,6 +5628,650 @@
     <p:extLst>
       <p:ext uri="{BB962C8B-B14F-4D97-AF65-F5344CB8AC3E}">
         <p14:creationId xmlns:p14="http://schemas.microsoft.com/office/powerpoint/2010/main" val="177487879"/>
+      </p:ext>
+    </p:extLst>
+  </p:cSld>
+  <p:clrMapOvr>
+    <a:masterClrMapping/>
+  </p:clrMapOvr>
+</p:sld>
+</file>
+
+<file path=ppt/slides/slide20.xml><?xml version="1.0" encoding="utf-8"?>
+<p:sld xmlns:a="http://schemas.openxmlformats.org/drawingml/2006/main" xmlns:r="http://schemas.openxmlformats.org/officeDocument/2006/relationships" xmlns:p="http://schemas.openxmlformats.org/presentationml/2006/main">
+  <p:cSld>
+    <p:spTree>
+      <p:nvGrpSpPr>
+        <p:cNvPr id="1" name="">
+          <a:extLst>
+            <a:ext uri="{FF2B5EF4-FFF2-40B4-BE49-F238E27FC236}">
+              <a16:creationId xmlns:a16="http://schemas.microsoft.com/office/drawing/2014/main" id="{67D47483-F312-7C73-57AC-33D66AF632C3}"/>
+            </a:ext>
+          </a:extLst>
+        </p:cNvPr>
+        <p:cNvGrpSpPr/>
+        <p:nvPr/>
+      </p:nvGrpSpPr>
+      <p:grpSpPr>
+        <a:xfrm>
+          <a:off x="0" y="0"/>
+          <a:ext cx="0" cy="0"/>
+          <a:chOff x="0" y="0"/>
+          <a:chExt cx="0" cy="0"/>
+        </a:xfrm>
+      </p:grpSpPr>
+      <p:pic>
+        <p:nvPicPr>
+          <p:cNvPr id="3" name="Picture 2">
+            <a:extLst>
+              <a:ext uri="{FF2B5EF4-FFF2-40B4-BE49-F238E27FC236}">
+                <a16:creationId xmlns:a16="http://schemas.microsoft.com/office/drawing/2014/main" id="{665BC302-F552-280C-CF6F-AD15936F350A}"/>
+              </a:ext>
+            </a:extLst>
+          </p:cNvPr>
+          <p:cNvPicPr>
+            <a:picLocks noChangeAspect="1"/>
+          </p:cNvPicPr>
+          <p:nvPr/>
+        </p:nvPicPr>
+        <p:blipFill>
+          <a:blip r:embed="rId2">
+            <a:extLst>
+              <a:ext uri="{28A0092B-C50C-407E-A947-70E740481C1C}">
+                <a14:useLocalDpi xmlns:a14="http://schemas.microsoft.com/office/drawing/2010/main" val="0"/>
+              </a:ext>
+            </a:extLst>
+          </a:blip>
+          <a:stretch>
+            <a:fillRect/>
+          </a:stretch>
+        </p:blipFill>
+        <p:spPr>
+          <a:xfrm>
+            <a:off x="0" y="0"/>
+            <a:ext cx="12192000" cy="6858000"/>
+          </a:xfrm>
+          <a:prstGeom prst="rect">
+            <a:avLst/>
+          </a:prstGeom>
+        </p:spPr>
+      </p:pic>
+    </p:spTree>
+    <p:extLst>
+      <p:ext uri="{BB962C8B-B14F-4D97-AF65-F5344CB8AC3E}">
+        <p14:creationId xmlns:p14="http://schemas.microsoft.com/office/powerpoint/2010/main" val="2517603310"/>
+      </p:ext>
+    </p:extLst>
+  </p:cSld>
+  <p:clrMapOvr>
+    <a:masterClrMapping/>
+  </p:clrMapOvr>
+</p:sld>
+</file>
+
+<file path=ppt/slides/slide21.xml><?xml version="1.0" encoding="utf-8"?>
+<p:sld xmlns:a="http://schemas.openxmlformats.org/drawingml/2006/main" xmlns:r="http://schemas.openxmlformats.org/officeDocument/2006/relationships" xmlns:p="http://schemas.openxmlformats.org/presentationml/2006/main">
+  <p:cSld>
+    <p:spTree>
+      <p:nvGrpSpPr>
+        <p:cNvPr id="1" name="">
+          <a:extLst>
+            <a:ext uri="{FF2B5EF4-FFF2-40B4-BE49-F238E27FC236}">
+              <a16:creationId xmlns:a16="http://schemas.microsoft.com/office/drawing/2014/main" id="{8F82832F-9831-FF55-3DF3-03FE8C47BD02}"/>
+            </a:ext>
+          </a:extLst>
+        </p:cNvPr>
+        <p:cNvGrpSpPr/>
+        <p:nvPr/>
+      </p:nvGrpSpPr>
+      <p:grpSpPr>
+        <a:xfrm>
+          <a:off x="0" y="0"/>
+          <a:ext cx="0" cy="0"/>
+          <a:chOff x="0" y="0"/>
+          <a:chExt cx="0" cy="0"/>
+        </a:xfrm>
+      </p:grpSpPr>
+      <p:pic>
+        <p:nvPicPr>
+          <p:cNvPr id="3" name="Picture 2">
+            <a:extLst>
+              <a:ext uri="{FF2B5EF4-FFF2-40B4-BE49-F238E27FC236}">
+                <a16:creationId xmlns:a16="http://schemas.microsoft.com/office/drawing/2014/main" id="{6B58C83E-899D-D2B2-471C-F2FBB5B65F9B}"/>
+              </a:ext>
+            </a:extLst>
+          </p:cNvPr>
+          <p:cNvPicPr>
+            <a:picLocks noChangeAspect="1"/>
+          </p:cNvPicPr>
+          <p:nvPr/>
+        </p:nvPicPr>
+        <p:blipFill>
+          <a:blip r:embed="rId2">
+            <a:extLst>
+              <a:ext uri="{28A0092B-C50C-407E-A947-70E740481C1C}">
+                <a14:useLocalDpi xmlns:a14="http://schemas.microsoft.com/office/drawing/2010/main" val="0"/>
+              </a:ext>
+            </a:extLst>
+          </a:blip>
+          <a:stretch>
+            <a:fillRect/>
+          </a:stretch>
+        </p:blipFill>
+        <p:spPr>
+          <a:xfrm>
+            <a:off x="0" y="0"/>
+            <a:ext cx="12192000" cy="6858000"/>
+          </a:xfrm>
+          <a:prstGeom prst="rect">
+            <a:avLst/>
+          </a:prstGeom>
+        </p:spPr>
+      </p:pic>
+      <p:sp>
+        <p:nvSpPr>
+          <p:cNvPr id="2" name="TextBox 1">
+            <a:extLst>
+              <a:ext uri="{FF2B5EF4-FFF2-40B4-BE49-F238E27FC236}">
+                <a16:creationId xmlns:a16="http://schemas.microsoft.com/office/drawing/2014/main" id="{F896ECE1-23B7-1A01-C8D2-720A02607E22}"/>
+              </a:ext>
+            </a:extLst>
+          </p:cNvPr>
+          <p:cNvSpPr txBox="1"/>
+          <p:nvPr/>
+        </p:nvSpPr>
+        <p:spPr>
+          <a:xfrm>
+            <a:off x="6096000" y="2921168"/>
+            <a:ext cx="4506777" cy="1015663"/>
+          </a:xfrm>
+          <a:prstGeom prst="rect">
+            <a:avLst/>
+          </a:prstGeom>
+          <a:noFill/>
+        </p:spPr>
+        <p:txBody>
+          <a:bodyPr wrap="square" rtlCol="0">
+            <a:spAutoFit/>
+          </a:bodyPr>
+          <a:lstStyle/>
+          <a:p>
+            <a:r>
+              <a:rPr lang="en-IN" sz="6000" dirty="0">
+                <a:solidFill>
+                  <a:schemeClr val="bg1"/>
+                </a:solidFill>
+              </a:rPr>
+              <a:t>Future Scope</a:t>
+            </a:r>
+          </a:p>
+        </p:txBody>
+      </p:sp>
+      <p:sp>
+        <p:nvSpPr>
+          <p:cNvPr id="4" name="Flowchart: Connector 3">
+            <a:extLst>
+              <a:ext uri="{FF2B5EF4-FFF2-40B4-BE49-F238E27FC236}">
+                <a16:creationId xmlns:a16="http://schemas.microsoft.com/office/drawing/2014/main" id="{024AB9B5-3243-711F-C3D7-D4F78D8CEB1C}"/>
+              </a:ext>
+            </a:extLst>
+          </p:cNvPr>
+          <p:cNvSpPr/>
+          <p:nvPr/>
+        </p:nvSpPr>
+        <p:spPr>
+          <a:xfrm>
+            <a:off x="7809388" y="1700280"/>
+            <a:ext cx="1080000" cy="1080000"/>
+          </a:xfrm>
+          <a:prstGeom prst="flowChartConnector">
+            <a:avLst/>
+          </a:prstGeom>
+          <a:noFill/>
+          <a:ln>
+            <a:solidFill>
+              <a:schemeClr val="accent4"/>
+            </a:solidFill>
+          </a:ln>
+        </p:spPr>
+        <p:style>
+          <a:lnRef idx="2">
+            <a:schemeClr val="accent1">
+              <a:shade val="15000"/>
+            </a:schemeClr>
+          </a:lnRef>
+          <a:fillRef idx="1">
+            <a:schemeClr val="accent1"/>
+          </a:fillRef>
+          <a:effectRef idx="0">
+            <a:schemeClr val="accent1"/>
+          </a:effectRef>
+          <a:fontRef idx="minor">
+            <a:schemeClr val="lt1"/>
+          </a:fontRef>
+        </p:style>
+        <p:txBody>
+          <a:bodyPr rtlCol="0" anchor="ctr"/>
+          <a:lstStyle/>
+          <a:p>
+            <a:pPr algn="ctr"/>
+            <a:r>
+              <a:rPr lang="en-IN" sz="3600" dirty="0">
+                <a:solidFill>
+                  <a:schemeClr val="accent4"/>
+                </a:solidFill>
+                <a:effectLst>
+                  <a:outerShdw blurRad="50800" dist="38100" dir="2700000" algn="tl" rotWithShape="0">
+                    <a:prstClr val="black">
+                      <a:alpha val="40000"/>
+                    </a:prstClr>
+                  </a:outerShdw>
+                </a:effectLst>
+                <a:latin typeface="Bookman Old Style" panose="02050604050505020204" pitchFamily="18" charset="0"/>
+              </a:rPr>
+              <a:t>07</a:t>
+            </a:r>
+          </a:p>
+        </p:txBody>
+      </p:sp>
+    </p:spTree>
+    <p:extLst>
+      <p:ext uri="{BB962C8B-B14F-4D97-AF65-F5344CB8AC3E}">
+        <p14:creationId xmlns:p14="http://schemas.microsoft.com/office/powerpoint/2010/main" val="837435414"/>
+      </p:ext>
+    </p:extLst>
+  </p:cSld>
+  <p:clrMapOvr>
+    <a:masterClrMapping/>
+  </p:clrMapOvr>
+</p:sld>
+</file>
+
+<file path=ppt/slides/slide22.xml><?xml version="1.0" encoding="utf-8"?>
+<p:sld xmlns:a="http://schemas.openxmlformats.org/drawingml/2006/main" xmlns:r="http://schemas.openxmlformats.org/officeDocument/2006/relationships" xmlns:p="http://schemas.openxmlformats.org/presentationml/2006/main">
+  <p:cSld>
+    <p:spTree>
+      <p:nvGrpSpPr>
+        <p:cNvPr id="1" name="">
+          <a:extLst>
+            <a:ext uri="{FF2B5EF4-FFF2-40B4-BE49-F238E27FC236}">
+              <a16:creationId xmlns:a16="http://schemas.microsoft.com/office/drawing/2014/main" id="{DBADDD13-7266-6749-65BD-F83E56713889}"/>
+            </a:ext>
+          </a:extLst>
+        </p:cNvPr>
+        <p:cNvGrpSpPr/>
+        <p:nvPr/>
+      </p:nvGrpSpPr>
+      <p:grpSpPr>
+        <a:xfrm>
+          <a:off x="0" y="0"/>
+          <a:ext cx="0" cy="0"/>
+          <a:chOff x="0" y="0"/>
+          <a:chExt cx="0" cy="0"/>
+        </a:xfrm>
+      </p:grpSpPr>
+      <p:pic>
+        <p:nvPicPr>
+          <p:cNvPr id="3" name="Picture 2">
+            <a:extLst>
+              <a:ext uri="{FF2B5EF4-FFF2-40B4-BE49-F238E27FC236}">
+                <a16:creationId xmlns:a16="http://schemas.microsoft.com/office/drawing/2014/main" id="{942BBC62-B2A2-5678-45FC-B05CF305251D}"/>
+              </a:ext>
+            </a:extLst>
+          </p:cNvPr>
+          <p:cNvPicPr>
+            <a:picLocks noChangeAspect="1"/>
+          </p:cNvPicPr>
+          <p:nvPr/>
+        </p:nvPicPr>
+        <p:blipFill>
+          <a:blip r:embed="rId2">
+            <a:extLst>
+              <a:ext uri="{28A0092B-C50C-407E-A947-70E740481C1C}">
+                <a14:useLocalDpi xmlns:a14="http://schemas.microsoft.com/office/drawing/2010/main" val="0"/>
+              </a:ext>
+            </a:extLst>
+          </a:blip>
+          <a:stretch>
+            <a:fillRect/>
+          </a:stretch>
+        </p:blipFill>
+        <p:spPr>
+          <a:xfrm>
+            <a:off x="0" y="0"/>
+            <a:ext cx="12192000" cy="6858000"/>
+          </a:xfrm>
+          <a:prstGeom prst="rect">
+            <a:avLst/>
+          </a:prstGeom>
+        </p:spPr>
+      </p:pic>
+    </p:spTree>
+    <p:extLst>
+      <p:ext uri="{BB962C8B-B14F-4D97-AF65-F5344CB8AC3E}">
+        <p14:creationId xmlns:p14="http://schemas.microsoft.com/office/powerpoint/2010/main" val="4073124422"/>
+      </p:ext>
+    </p:extLst>
+  </p:cSld>
+  <p:clrMapOvr>
+    <a:masterClrMapping/>
+  </p:clrMapOvr>
+</p:sld>
+</file>
+
+<file path=ppt/slides/slide23.xml><?xml version="1.0" encoding="utf-8"?>
+<p:sld xmlns:a="http://schemas.openxmlformats.org/drawingml/2006/main" xmlns:r="http://schemas.openxmlformats.org/officeDocument/2006/relationships" xmlns:p="http://schemas.openxmlformats.org/presentationml/2006/main">
+  <p:cSld>
+    <p:spTree>
+      <p:nvGrpSpPr>
+        <p:cNvPr id="1" name="">
+          <a:extLst>
+            <a:ext uri="{FF2B5EF4-FFF2-40B4-BE49-F238E27FC236}">
+              <a16:creationId xmlns:a16="http://schemas.microsoft.com/office/drawing/2014/main" id="{B9CED073-6E6F-257F-B9D4-98DB583D1AA8}"/>
+            </a:ext>
+          </a:extLst>
+        </p:cNvPr>
+        <p:cNvGrpSpPr/>
+        <p:nvPr/>
+      </p:nvGrpSpPr>
+      <p:grpSpPr>
+        <a:xfrm>
+          <a:off x="0" y="0"/>
+          <a:ext cx="0" cy="0"/>
+          <a:chOff x="0" y="0"/>
+          <a:chExt cx="0" cy="0"/>
+        </a:xfrm>
+      </p:grpSpPr>
+      <p:pic>
+        <p:nvPicPr>
+          <p:cNvPr id="3" name="Picture 2">
+            <a:extLst>
+              <a:ext uri="{FF2B5EF4-FFF2-40B4-BE49-F238E27FC236}">
+                <a16:creationId xmlns:a16="http://schemas.microsoft.com/office/drawing/2014/main" id="{040523D1-D0A1-BCEB-63DE-7E4A361DEB64}"/>
+              </a:ext>
+            </a:extLst>
+          </p:cNvPr>
+          <p:cNvPicPr>
+            <a:picLocks noChangeAspect="1"/>
+          </p:cNvPicPr>
+          <p:nvPr/>
+        </p:nvPicPr>
+        <p:blipFill>
+          <a:blip r:embed="rId2">
+            <a:extLst>
+              <a:ext uri="{28A0092B-C50C-407E-A947-70E740481C1C}">
+                <a14:useLocalDpi xmlns:a14="http://schemas.microsoft.com/office/drawing/2010/main" val="0"/>
+              </a:ext>
+            </a:extLst>
+          </a:blip>
+          <a:stretch>
+            <a:fillRect/>
+          </a:stretch>
+        </p:blipFill>
+        <p:spPr>
+          <a:xfrm>
+            <a:off x="0" y="0"/>
+            <a:ext cx="12192000" cy="6858000"/>
+          </a:xfrm>
+          <a:prstGeom prst="rect">
+            <a:avLst/>
+          </a:prstGeom>
+        </p:spPr>
+      </p:pic>
+      <p:sp>
+        <p:nvSpPr>
+          <p:cNvPr id="2" name="TextBox 1">
+            <a:extLst>
+              <a:ext uri="{FF2B5EF4-FFF2-40B4-BE49-F238E27FC236}">
+                <a16:creationId xmlns:a16="http://schemas.microsoft.com/office/drawing/2014/main" id="{6AC89C10-75BE-938B-5DA9-AD026AB79BBC}"/>
+              </a:ext>
+            </a:extLst>
+          </p:cNvPr>
+          <p:cNvSpPr txBox="1"/>
+          <p:nvPr/>
+        </p:nvSpPr>
+        <p:spPr>
+          <a:xfrm>
+            <a:off x="6532221" y="2921168"/>
+            <a:ext cx="3571549" cy="1015663"/>
+          </a:xfrm>
+          <a:prstGeom prst="rect">
+            <a:avLst/>
+          </a:prstGeom>
+          <a:noFill/>
+        </p:spPr>
+        <p:txBody>
+          <a:bodyPr wrap="square" rtlCol="0">
+            <a:spAutoFit/>
+          </a:bodyPr>
+          <a:lstStyle/>
+          <a:p>
+            <a:r>
+              <a:rPr lang="en-IN" sz="6000" dirty="0">
+                <a:solidFill>
+                  <a:schemeClr val="bg1"/>
+                </a:solidFill>
+              </a:rPr>
+              <a:t>Conclusion</a:t>
+            </a:r>
+          </a:p>
+        </p:txBody>
+      </p:sp>
+      <p:sp>
+        <p:nvSpPr>
+          <p:cNvPr id="4" name="Flowchart: Connector 3">
+            <a:extLst>
+              <a:ext uri="{FF2B5EF4-FFF2-40B4-BE49-F238E27FC236}">
+                <a16:creationId xmlns:a16="http://schemas.microsoft.com/office/drawing/2014/main" id="{30119855-C3F2-140A-F86D-A3B12B8B0E08}"/>
+              </a:ext>
+            </a:extLst>
+          </p:cNvPr>
+          <p:cNvSpPr/>
+          <p:nvPr/>
+        </p:nvSpPr>
+        <p:spPr>
+          <a:xfrm>
+            <a:off x="7777995" y="1736856"/>
+            <a:ext cx="1080000" cy="1080000"/>
+          </a:xfrm>
+          <a:prstGeom prst="flowChartConnector">
+            <a:avLst/>
+          </a:prstGeom>
+          <a:noFill/>
+          <a:ln>
+            <a:solidFill>
+              <a:schemeClr val="accent4"/>
+            </a:solidFill>
+          </a:ln>
+        </p:spPr>
+        <p:style>
+          <a:lnRef idx="2">
+            <a:schemeClr val="accent1">
+              <a:shade val="15000"/>
+            </a:schemeClr>
+          </a:lnRef>
+          <a:fillRef idx="1">
+            <a:schemeClr val="accent1"/>
+          </a:fillRef>
+          <a:effectRef idx="0">
+            <a:schemeClr val="accent1"/>
+          </a:effectRef>
+          <a:fontRef idx="minor">
+            <a:schemeClr val="lt1"/>
+          </a:fontRef>
+        </p:style>
+        <p:txBody>
+          <a:bodyPr rtlCol="0" anchor="ctr"/>
+          <a:lstStyle/>
+          <a:p>
+            <a:pPr algn="ctr"/>
+            <a:r>
+              <a:rPr lang="en-IN" sz="3600" dirty="0">
+                <a:solidFill>
+                  <a:schemeClr val="accent4"/>
+                </a:solidFill>
+                <a:effectLst>
+                  <a:outerShdw blurRad="50800" dist="38100" dir="2700000" algn="tl" rotWithShape="0">
+                    <a:prstClr val="black">
+                      <a:alpha val="40000"/>
+                    </a:prstClr>
+                  </a:outerShdw>
+                </a:effectLst>
+                <a:latin typeface="Bookman Old Style" panose="02050604050505020204" pitchFamily="18" charset="0"/>
+              </a:rPr>
+              <a:t>08</a:t>
+            </a:r>
+          </a:p>
+        </p:txBody>
+      </p:sp>
+    </p:spTree>
+    <p:extLst>
+      <p:ext uri="{BB962C8B-B14F-4D97-AF65-F5344CB8AC3E}">
+        <p14:creationId xmlns:p14="http://schemas.microsoft.com/office/powerpoint/2010/main" val="192779967"/>
+      </p:ext>
+    </p:extLst>
+  </p:cSld>
+  <p:clrMapOvr>
+    <a:masterClrMapping/>
+  </p:clrMapOvr>
+</p:sld>
+</file>
+
+<file path=ppt/slides/slide24.xml><?xml version="1.0" encoding="utf-8"?>
+<p:sld xmlns:a="http://schemas.openxmlformats.org/drawingml/2006/main" xmlns:r="http://schemas.openxmlformats.org/officeDocument/2006/relationships" xmlns:p="http://schemas.openxmlformats.org/presentationml/2006/main">
+  <p:cSld>
+    <p:spTree>
+      <p:nvGrpSpPr>
+        <p:cNvPr id="1" name="">
+          <a:extLst>
+            <a:ext uri="{FF2B5EF4-FFF2-40B4-BE49-F238E27FC236}">
+              <a16:creationId xmlns:a16="http://schemas.microsoft.com/office/drawing/2014/main" id="{C03E4991-7D9B-1741-4130-A4297AD804C3}"/>
+            </a:ext>
+          </a:extLst>
+        </p:cNvPr>
+        <p:cNvGrpSpPr/>
+        <p:nvPr/>
+      </p:nvGrpSpPr>
+      <p:grpSpPr>
+        <a:xfrm>
+          <a:off x="0" y="0"/>
+          <a:ext cx="0" cy="0"/>
+          <a:chOff x="0" y="0"/>
+          <a:chExt cx="0" cy="0"/>
+        </a:xfrm>
+      </p:grpSpPr>
+      <p:pic>
+        <p:nvPicPr>
+          <p:cNvPr id="3" name="Picture 2">
+            <a:extLst>
+              <a:ext uri="{FF2B5EF4-FFF2-40B4-BE49-F238E27FC236}">
+                <a16:creationId xmlns:a16="http://schemas.microsoft.com/office/drawing/2014/main" id="{6E7F428B-3A37-7553-AE95-536C0772590F}"/>
+              </a:ext>
+            </a:extLst>
+          </p:cNvPr>
+          <p:cNvPicPr>
+            <a:picLocks noChangeAspect="1"/>
+          </p:cNvPicPr>
+          <p:nvPr/>
+        </p:nvPicPr>
+        <p:blipFill>
+          <a:blip r:embed="rId2">
+            <a:extLst>
+              <a:ext uri="{28A0092B-C50C-407E-A947-70E740481C1C}">
+                <a14:useLocalDpi xmlns:a14="http://schemas.microsoft.com/office/drawing/2010/main" val="0"/>
+              </a:ext>
+            </a:extLst>
+          </a:blip>
+          <a:stretch>
+            <a:fillRect/>
+          </a:stretch>
+        </p:blipFill>
+        <p:spPr>
+          <a:xfrm>
+            <a:off x="0" y="0"/>
+            <a:ext cx="12192000" cy="6858000"/>
+          </a:xfrm>
+          <a:prstGeom prst="rect">
+            <a:avLst/>
+          </a:prstGeom>
+        </p:spPr>
+      </p:pic>
+    </p:spTree>
+    <p:extLst>
+      <p:ext uri="{BB962C8B-B14F-4D97-AF65-F5344CB8AC3E}">
+        <p14:creationId xmlns:p14="http://schemas.microsoft.com/office/powerpoint/2010/main" val="998394805"/>
+      </p:ext>
+    </p:extLst>
+  </p:cSld>
+  <p:clrMapOvr>
+    <a:masterClrMapping/>
+  </p:clrMapOvr>
+</p:sld>
+</file>
+
+<file path=ppt/slides/slide25.xml><?xml version="1.0" encoding="utf-8"?>
+<p:sld xmlns:a="http://schemas.openxmlformats.org/drawingml/2006/main" xmlns:r="http://schemas.openxmlformats.org/officeDocument/2006/relationships" xmlns:p="http://schemas.openxmlformats.org/presentationml/2006/main">
+  <p:cSld>
+    <p:spTree>
+      <p:nvGrpSpPr>
+        <p:cNvPr id="1" name="">
+          <a:extLst>
+            <a:ext uri="{FF2B5EF4-FFF2-40B4-BE49-F238E27FC236}">
+              <a16:creationId xmlns:a16="http://schemas.microsoft.com/office/drawing/2014/main" id="{BF028008-297D-7E91-057A-6AB959109C16}"/>
+            </a:ext>
+          </a:extLst>
+        </p:cNvPr>
+        <p:cNvGrpSpPr/>
+        <p:nvPr/>
+      </p:nvGrpSpPr>
+      <p:grpSpPr>
+        <a:xfrm>
+          <a:off x="0" y="0"/>
+          <a:ext cx="0" cy="0"/>
+          <a:chOff x="0" y="0"/>
+          <a:chExt cx="0" cy="0"/>
+        </a:xfrm>
+      </p:grpSpPr>
+      <p:pic>
+        <p:nvPicPr>
+          <p:cNvPr id="3" name="Picture 2">
+            <a:extLst>
+              <a:ext uri="{FF2B5EF4-FFF2-40B4-BE49-F238E27FC236}">
+                <a16:creationId xmlns:a16="http://schemas.microsoft.com/office/drawing/2014/main" id="{E039F219-BEC2-A7AC-FBBF-72E0AC79A319}"/>
+              </a:ext>
+            </a:extLst>
+          </p:cNvPr>
+          <p:cNvPicPr>
+            <a:picLocks noChangeAspect="1"/>
+          </p:cNvPicPr>
+          <p:nvPr/>
+        </p:nvPicPr>
+        <p:blipFill>
+          <a:blip r:embed="rId2">
+            <a:extLst>
+              <a:ext uri="{28A0092B-C50C-407E-A947-70E740481C1C}">
+                <a14:useLocalDpi xmlns:a14="http://schemas.microsoft.com/office/drawing/2010/main" val="0"/>
+              </a:ext>
+            </a:extLst>
+          </a:blip>
+          <a:stretch>
+            <a:fillRect/>
+          </a:stretch>
+        </p:blipFill>
+        <p:spPr>
+          <a:xfrm>
+            <a:off x="0" y="0"/>
+            <a:ext cx="12192000" cy="6858000"/>
+          </a:xfrm>
+          <a:prstGeom prst="rect">
+            <a:avLst/>
+          </a:prstGeom>
+        </p:spPr>
+      </p:pic>
+    </p:spTree>
+    <p:extLst>
+      <p:ext uri="{BB962C8B-B14F-4D97-AF65-F5344CB8AC3E}">
+        <p14:creationId xmlns:p14="http://schemas.microsoft.com/office/powerpoint/2010/main" val="390437541"/>
       </p:ext>
     </p:extLst>
   </p:cSld>
@@ -6118,9 +7754,9 @@
         <p:grpSpPr>
           <a:xfrm>
             <a:off x="1702688" y="2207195"/>
-            <a:ext cx="8786622" cy="3775449"/>
+            <a:ext cx="8786622" cy="3683115"/>
             <a:chOff x="1307591" y="2079179"/>
-            <a:chExt cx="8786622" cy="3775449"/>
+            <a:chExt cx="8786622" cy="3683115"/>
           </a:xfrm>
         </p:grpSpPr>
         <p:grpSp>
@@ -6137,10 +7773,10 @@
           </p:nvGrpSpPr>
           <p:grpSpPr>
             <a:xfrm>
-              <a:off x="2097785" y="2079179"/>
-              <a:ext cx="7996428" cy="3775449"/>
-              <a:chOff x="1577340" y="2181955"/>
-              <a:chExt cx="9027333" cy="3775449"/>
+              <a:off x="2097784" y="2079179"/>
+              <a:ext cx="7996429" cy="3683114"/>
+              <a:chOff x="1577339" y="2181955"/>
+              <a:chExt cx="9027334" cy="3683114"/>
             </a:xfrm>
           </p:grpSpPr>
           <p:sp>
@@ -6425,7 +8061,7 @@
             </p:nvSpPr>
             <p:spPr>
               <a:xfrm>
-                <a:off x="1577340" y="5495739"/>
+                <a:off x="1577339" y="5403404"/>
                 <a:ext cx="2514600" cy="461665"/>
               </a:xfrm>
               <a:prstGeom prst="rect">
@@ -6472,7 +8108,7 @@
             </p:nvSpPr>
             <p:spPr>
               <a:xfrm>
-                <a:off x="6690360" y="5495739"/>
+                <a:off x="6690360" y="5403404"/>
                 <a:ext cx="2514600" cy="461665"/>
               </a:xfrm>
               <a:prstGeom prst="rect">
@@ -6520,7 +8156,7 @@
           </p:nvSpPr>
           <p:spPr>
             <a:xfrm>
-              <a:off x="1307592" y="2171511"/>
+              <a:off x="1307591" y="2269391"/>
               <a:ext cx="790193" cy="461665"/>
             </a:xfrm>
             <a:prstGeom prst="rect">
@@ -6560,7 +8196,7 @@
           </p:nvSpPr>
           <p:spPr>
             <a:xfrm>
-              <a:off x="1307591" y="3296100"/>
+              <a:off x="1307591" y="3388916"/>
               <a:ext cx="790193" cy="461665"/>
             </a:xfrm>
             <a:prstGeom prst="rect">
@@ -6640,7 +8276,7 @@
           </p:nvSpPr>
           <p:spPr>
             <a:xfrm>
-              <a:off x="1307591" y="4389591"/>
+              <a:off x="1307591" y="4508441"/>
               <a:ext cx="790193" cy="461665"/>
             </a:xfrm>
             <a:prstGeom prst="rect">
@@ -6720,7 +8356,7 @@
           </p:nvSpPr>
           <p:spPr>
             <a:xfrm>
-              <a:off x="5827015" y="4389591"/>
+              <a:off x="5836713" y="4508441"/>
               <a:ext cx="790193" cy="461665"/>
             </a:xfrm>
             <a:prstGeom prst="rect">
@@ -6760,7 +8396,7 @@
           </p:nvSpPr>
           <p:spPr>
             <a:xfrm>
-              <a:off x="5827015" y="3301494"/>
+              <a:off x="5836714" y="3388916"/>
               <a:ext cx="790193" cy="461665"/>
             </a:xfrm>
             <a:prstGeom prst="rect">
@@ -6800,7 +8436,7 @@
           </p:nvSpPr>
           <p:spPr>
             <a:xfrm>
-              <a:off x="5827015" y="2166218"/>
+              <a:off x="5836714" y="2287067"/>
               <a:ext cx="790193" cy="461665"/>
             </a:xfrm>
             <a:prstGeom prst="rect">

</xml_diff>

<commit_message>
Complete EDA & Data Transformation Section in PPT
</commit_message>
<xml_diff>
--- a/Report/Amazon Sales Report.pptx
+++ b/Report/Amazon Sales Report.pptx
@@ -14,22 +14,24 @@
     <p:sldId id="261" r:id="rId8"/>
     <p:sldId id="263" r:id="rId9"/>
     <p:sldId id="265" r:id="rId10"/>
-    <p:sldId id="266" r:id="rId11"/>
-    <p:sldId id="268" r:id="rId12"/>
-    <p:sldId id="267" r:id="rId13"/>
-    <p:sldId id="269" r:id="rId14"/>
-    <p:sldId id="270" r:id="rId15"/>
-    <p:sldId id="271" r:id="rId16"/>
-    <p:sldId id="272" r:id="rId17"/>
-    <p:sldId id="273" r:id="rId18"/>
-    <p:sldId id="274" r:id="rId19"/>
-    <p:sldId id="275" r:id="rId20"/>
-    <p:sldId id="276" r:id="rId21"/>
-    <p:sldId id="277" r:id="rId22"/>
-    <p:sldId id="278" r:id="rId23"/>
-    <p:sldId id="279" r:id="rId24"/>
-    <p:sldId id="280" r:id="rId25"/>
-    <p:sldId id="281" r:id="rId26"/>
+    <p:sldId id="269" r:id="rId11"/>
+    <p:sldId id="270" r:id="rId12"/>
+    <p:sldId id="282" r:id="rId13"/>
+    <p:sldId id="266" r:id="rId14"/>
+    <p:sldId id="268" r:id="rId15"/>
+    <p:sldId id="267" r:id="rId16"/>
+    <p:sldId id="283" r:id="rId17"/>
+    <p:sldId id="271" r:id="rId18"/>
+    <p:sldId id="272" r:id="rId19"/>
+    <p:sldId id="273" r:id="rId20"/>
+    <p:sldId id="274" r:id="rId21"/>
+    <p:sldId id="275" r:id="rId22"/>
+    <p:sldId id="276" r:id="rId23"/>
+    <p:sldId id="277" r:id="rId24"/>
+    <p:sldId id="278" r:id="rId25"/>
+    <p:sldId id="279" r:id="rId26"/>
+    <p:sldId id="280" r:id="rId27"/>
+    <p:sldId id="281" r:id="rId28"/>
   </p:sldIdLst>
   <p:sldSz cx="12192000" cy="6858000"/>
   <p:notesSz cx="6858000" cy="9144000"/>
@@ -3555,6 +3557,1667 @@
         <p:cNvPr id="1" name="">
           <a:extLst>
             <a:ext uri="{FF2B5EF4-FFF2-40B4-BE49-F238E27FC236}">
+              <a16:creationId xmlns:a16="http://schemas.microsoft.com/office/drawing/2014/main" id="{F2D74E86-DBDB-127A-0BCE-B036AED9E85A}"/>
+            </a:ext>
+          </a:extLst>
+        </p:cNvPr>
+        <p:cNvGrpSpPr/>
+        <p:nvPr/>
+      </p:nvGrpSpPr>
+      <p:grpSpPr>
+        <a:xfrm>
+          <a:off x="0" y="0"/>
+          <a:ext cx="0" cy="0"/>
+          <a:chOff x="0" y="0"/>
+          <a:chExt cx="0" cy="0"/>
+        </a:xfrm>
+      </p:grpSpPr>
+      <p:pic>
+        <p:nvPicPr>
+          <p:cNvPr id="4" name="Picture 3">
+            <a:extLst>
+              <a:ext uri="{FF2B5EF4-FFF2-40B4-BE49-F238E27FC236}">
+                <a16:creationId xmlns:a16="http://schemas.microsoft.com/office/drawing/2014/main" id="{72D27382-C293-AF6B-97F1-7C9E4FFBED6C}"/>
+              </a:ext>
+            </a:extLst>
+          </p:cNvPr>
+          <p:cNvPicPr>
+            <a:picLocks noChangeAspect="1"/>
+          </p:cNvPicPr>
+          <p:nvPr/>
+        </p:nvPicPr>
+        <p:blipFill>
+          <a:blip r:embed="rId2">
+            <a:extLst>
+              <a:ext uri="{28A0092B-C50C-407E-A947-70E740481C1C}">
+                <a14:useLocalDpi xmlns:a14="http://schemas.microsoft.com/office/drawing/2010/main" val="0"/>
+              </a:ext>
+            </a:extLst>
+          </a:blip>
+          <a:stretch>
+            <a:fillRect/>
+          </a:stretch>
+        </p:blipFill>
+        <p:spPr>
+          <a:xfrm>
+            <a:off x="0" y="0"/>
+            <a:ext cx="12192000" cy="6858000"/>
+          </a:xfrm>
+          <a:prstGeom prst="rect">
+            <a:avLst/>
+          </a:prstGeom>
+          <a:ln>
+            <a:noFill/>
+          </a:ln>
+          <a:effectLst>
+            <a:softEdge rad="112500"/>
+          </a:effectLst>
+        </p:spPr>
+      </p:pic>
+      <p:sp>
+        <p:nvSpPr>
+          <p:cNvPr id="5" name="TextBox 4">
+            <a:extLst>
+              <a:ext uri="{FF2B5EF4-FFF2-40B4-BE49-F238E27FC236}">
+                <a16:creationId xmlns:a16="http://schemas.microsoft.com/office/drawing/2014/main" id="{3D3BB38B-68D9-AAF3-6DBC-5454B031426F}"/>
+              </a:ext>
+            </a:extLst>
+          </p:cNvPr>
+          <p:cNvSpPr txBox="1"/>
+          <p:nvPr/>
+        </p:nvSpPr>
+        <p:spPr>
+          <a:xfrm>
+            <a:off x="5286447" y="2459504"/>
+            <a:ext cx="6619041" cy="1938992"/>
+          </a:xfrm>
+          <a:prstGeom prst="rect">
+            <a:avLst/>
+          </a:prstGeom>
+          <a:noFill/>
+        </p:spPr>
+        <p:txBody>
+          <a:bodyPr wrap="square" rtlCol="0">
+            <a:spAutoFit/>
+          </a:bodyPr>
+          <a:lstStyle/>
+          <a:p>
+            <a:r>
+              <a:rPr lang="en-IN" sz="6000" dirty="0">
+                <a:solidFill>
+                  <a:schemeClr val="bg1"/>
+                </a:solidFill>
+                <a:latin typeface="Bookman Old Style" panose="02050604050505020204" pitchFamily="18" charset="0"/>
+              </a:rPr>
+              <a:t>Data Cleaning &amp; Transformation</a:t>
+            </a:r>
+          </a:p>
+        </p:txBody>
+      </p:sp>
+      <p:sp>
+        <p:nvSpPr>
+          <p:cNvPr id="7" name="Flowchart: Connector 6">
+            <a:extLst>
+              <a:ext uri="{FF2B5EF4-FFF2-40B4-BE49-F238E27FC236}">
+                <a16:creationId xmlns:a16="http://schemas.microsoft.com/office/drawing/2014/main" id="{2780D173-A3D4-9BAF-8B9F-36656E12F418}"/>
+              </a:ext>
+            </a:extLst>
+          </p:cNvPr>
+          <p:cNvSpPr/>
+          <p:nvPr/>
+        </p:nvSpPr>
+        <p:spPr>
+          <a:xfrm>
+            <a:off x="7777996" y="1224792"/>
+            <a:ext cx="1080000" cy="1080000"/>
+          </a:xfrm>
+          <a:prstGeom prst="flowChartConnector">
+            <a:avLst/>
+          </a:prstGeom>
+          <a:noFill/>
+          <a:ln>
+            <a:solidFill>
+              <a:schemeClr val="accent4"/>
+            </a:solidFill>
+          </a:ln>
+        </p:spPr>
+        <p:style>
+          <a:lnRef idx="2">
+            <a:schemeClr val="accent1">
+              <a:shade val="15000"/>
+            </a:schemeClr>
+          </a:lnRef>
+          <a:fillRef idx="1">
+            <a:schemeClr val="accent1"/>
+          </a:fillRef>
+          <a:effectRef idx="0">
+            <a:schemeClr val="accent1"/>
+          </a:effectRef>
+          <a:fontRef idx="minor">
+            <a:schemeClr val="lt1"/>
+          </a:fontRef>
+        </p:style>
+        <p:txBody>
+          <a:bodyPr rtlCol="0" anchor="ctr"/>
+          <a:lstStyle/>
+          <a:p>
+            <a:pPr algn="ctr"/>
+            <a:r>
+              <a:rPr lang="en-IN" sz="3600" dirty="0">
+                <a:solidFill>
+                  <a:schemeClr val="accent4"/>
+                </a:solidFill>
+                <a:effectLst>
+                  <a:outerShdw blurRad="50800" dist="38100" dir="2700000" algn="tl" rotWithShape="0">
+                    <a:prstClr val="black">
+                      <a:alpha val="40000"/>
+                    </a:prstClr>
+                  </a:outerShdw>
+                </a:effectLst>
+                <a:latin typeface="Bookman Old Style" panose="02050604050505020204" pitchFamily="18" charset="0"/>
+              </a:rPr>
+              <a:t>02</a:t>
+            </a:r>
+          </a:p>
+        </p:txBody>
+      </p:sp>
+      <p:pic>
+        <p:nvPicPr>
+          <p:cNvPr id="6" name="Picture 5">
+            <a:extLst>
+              <a:ext uri="{FF2B5EF4-FFF2-40B4-BE49-F238E27FC236}">
+                <a16:creationId xmlns:a16="http://schemas.microsoft.com/office/drawing/2014/main" id="{2C8161A4-DC5E-14EA-69C5-80ACA57E7EB0}"/>
+              </a:ext>
+            </a:extLst>
+          </p:cNvPr>
+          <p:cNvPicPr>
+            <a:picLocks noChangeAspect="1"/>
+          </p:cNvPicPr>
+          <p:nvPr/>
+        </p:nvPicPr>
+        <p:blipFill>
+          <a:blip r:embed="rId3">
+            <a:extLst>
+              <a:ext uri="{28A0092B-C50C-407E-A947-70E740481C1C}">
+                <a14:useLocalDpi xmlns:a14="http://schemas.microsoft.com/office/drawing/2010/main" val="0"/>
+              </a:ext>
+            </a:extLst>
+          </a:blip>
+          <a:srcRect/>
+          <a:stretch/>
+        </p:blipFill>
+        <p:spPr>
+          <a:xfrm>
+            <a:off x="1035133" y="2189527"/>
+            <a:ext cx="3719747" cy="2478946"/>
+          </a:xfrm>
+          <a:prstGeom prst="rect">
+            <a:avLst/>
+          </a:prstGeom>
+          <a:solidFill>
+            <a:srgbClr val="FFFFFF">
+              <a:shade val="85000"/>
+            </a:srgbClr>
+          </a:solidFill>
+          <a:ln w="190500" cap="sq">
+            <a:solidFill>
+              <a:schemeClr val="bg1">
+                <a:lumMod val="95000"/>
+              </a:schemeClr>
+            </a:solidFill>
+            <a:miter lim="800000"/>
+          </a:ln>
+          <a:effectLst>
+            <a:outerShdw blurRad="65000" dist="50800" dir="12900000" kx="195000" ky="145000" algn="tl" rotWithShape="0">
+              <a:srgbClr val="000000">
+                <a:alpha val="30000"/>
+              </a:srgbClr>
+            </a:outerShdw>
+          </a:effectLst>
+          <a:scene3d>
+            <a:camera prst="orthographicFront">
+              <a:rot lat="0" lon="0" rev="360000"/>
+            </a:camera>
+            <a:lightRig rig="twoPt" dir="t">
+              <a:rot lat="0" lon="0" rev="7200000"/>
+            </a:lightRig>
+          </a:scene3d>
+          <a:sp3d contourW="12700">
+            <a:bevelT w="25400" h="19050"/>
+            <a:contourClr>
+              <a:srgbClr val="969696"/>
+            </a:contourClr>
+          </a:sp3d>
+        </p:spPr>
+      </p:pic>
+    </p:spTree>
+    <p:extLst>
+      <p:ext uri="{BB962C8B-B14F-4D97-AF65-F5344CB8AC3E}">
+        <p14:creationId xmlns:p14="http://schemas.microsoft.com/office/powerpoint/2010/main" val="3064719254"/>
+      </p:ext>
+    </p:extLst>
+  </p:cSld>
+  <p:clrMapOvr>
+    <a:masterClrMapping/>
+  </p:clrMapOvr>
+</p:sld>
+</file>
+
+<file path=ppt/slides/slide11.xml><?xml version="1.0" encoding="utf-8"?>
+<p:sld xmlns:a="http://schemas.openxmlformats.org/drawingml/2006/main" xmlns:r="http://schemas.openxmlformats.org/officeDocument/2006/relationships" xmlns:p="http://schemas.openxmlformats.org/presentationml/2006/main">
+  <p:cSld>
+    <p:spTree>
+      <p:nvGrpSpPr>
+        <p:cNvPr id="1" name=""/>
+        <p:cNvGrpSpPr/>
+        <p:nvPr/>
+      </p:nvGrpSpPr>
+      <p:grpSpPr>
+        <a:xfrm>
+          <a:off x="0" y="0"/>
+          <a:ext cx="0" cy="0"/>
+          <a:chOff x="0" y="0"/>
+          <a:chExt cx="0" cy="0"/>
+        </a:xfrm>
+      </p:grpSpPr>
+      <p:pic>
+        <p:nvPicPr>
+          <p:cNvPr id="3" name="Picture 2">
+            <a:extLst>
+              <a:ext uri="{FF2B5EF4-FFF2-40B4-BE49-F238E27FC236}">
+                <a16:creationId xmlns:a16="http://schemas.microsoft.com/office/drawing/2014/main" id="{79E2B8DF-5074-C0AA-0770-79D8A671192A}"/>
+              </a:ext>
+            </a:extLst>
+          </p:cNvPr>
+          <p:cNvPicPr>
+            <a:picLocks noChangeAspect="1"/>
+          </p:cNvPicPr>
+          <p:nvPr/>
+        </p:nvPicPr>
+        <p:blipFill>
+          <a:blip r:embed="rId2">
+            <a:extLst>
+              <a:ext uri="{28A0092B-C50C-407E-A947-70E740481C1C}">
+                <a14:useLocalDpi xmlns:a14="http://schemas.microsoft.com/office/drawing/2010/main" val="0"/>
+              </a:ext>
+            </a:extLst>
+          </a:blip>
+          <a:stretch>
+            <a:fillRect/>
+          </a:stretch>
+        </p:blipFill>
+        <p:spPr>
+          <a:xfrm>
+            <a:off x="0" y="0"/>
+            <a:ext cx="12192000" cy="6858000"/>
+          </a:xfrm>
+          <a:prstGeom prst="rect">
+            <a:avLst/>
+          </a:prstGeom>
+          <a:ln>
+            <a:noFill/>
+          </a:ln>
+          <a:effectLst>
+            <a:softEdge rad="112500"/>
+          </a:effectLst>
+        </p:spPr>
+      </p:pic>
+      <p:sp>
+        <p:nvSpPr>
+          <p:cNvPr id="4" name="TextBox 3">
+            <a:extLst>
+              <a:ext uri="{FF2B5EF4-FFF2-40B4-BE49-F238E27FC236}">
+                <a16:creationId xmlns:a16="http://schemas.microsoft.com/office/drawing/2014/main" id="{3767478F-4CFE-ED12-CB18-53805324BB7B}"/>
+              </a:ext>
+            </a:extLst>
+          </p:cNvPr>
+          <p:cNvSpPr txBox="1"/>
+          <p:nvPr/>
+        </p:nvSpPr>
+        <p:spPr>
+          <a:xfrm>
+            <a:off x="498348" y="751011"/>
+            <a:ext cx="11195304" cy="1631216"/>
+          </a:xfrm>
+          <a:prstGeom prst="rect">
+            <a:avLst/>
+          </a:prstGeom>
+          <a:noFill/>
+        </p:spPr>
+        <p:txBody>
+          <a:bodyPr wrap="square">
+            <a:spAutoFit/>
+          </a:bodyPr>
+          <a:lstStyle/>
+          <a:p>
+            <a:r>
+              <a:rPr lang="en-US" sz="2000" dirty="0">
+                <a:solidFill>
+                  <a:schemeClr val="bg1"/>
+                </a:solidFill>
+                <a:latin typeface="Bookman Old Style" panose="02050604050505020204" pitchFamily="18" charset="0"/>
+              </a:rPr>
+              <a:t>The raw Amazon sales dataset underwent multiple </a:t>
+            </a:r>
+            <a:r>
+              <a:rPr lang="en-US" sz="2000" b="1" dirty="0">
+                <a:solidFill>
+                  <a:schemeClr val="bg1"/>
+                </a:solidFill>
+                <a:latin typeface="Bookman Old Style" panose="02050604050505020204" pitchFamily="18" charset="0"/>
+              </a:rPr>
+              <a:t>cleaning and transformation steps</a:t>
+            </a:r>
+            <a:r>
+              <a:rPr lang="en-US" sz="2000" dirty="0">
+                <a:solidFill>
+                  <a:schemeClr val="bg1"/>
+                </a:solidFill>
+                <a:latin typeface="Bookman Old Style" panose="02050604050505020204" pitchFamily="18" charset="0"/>
+              </a:rPr>
+              <a:t> in </a:t>
+            </a:r>
+            <a:r>
+              <a:rPr lang="en-US" sz="2000" b="1" dirty="0">
+                <a:solidFill>
+                  <a:schemeClr val="bg1"/>
+                </a:solidFill>
+                <a:latin typeface="Bookman Old Style" panose="02050604050505020204" pitchFamily="18" charset="0"/>
+              </a:rPr>
+              <a:t>Power Query Editor</a:t>
+            </a:r>
+            <a:r>
+              <a:rPr lang="en-US" sz="2000" dirty="0">
+                <a:solidFill>
+                  <a:schemeClr val="bg1"/>
+                </a:solidFill>
+                <a:latin typeface="Bookman Old Style" panose="02050604050505020204" pitchFamily="18" charset="0"/>
+              </a:rPr>
+              <a:t> to ensure data accuracy, consistency, and readiness for analysis.</a:t>
+            </a:r>
+            <a:br>
+              <a:rPr lang="en-US" sz="2000" dirty="0">
+                <a:solidFill>
+                  <a:schemeClr val="bg1"/>
+                </a:solidFill>
+                <a:latin typeface="Bookman Old Style" panose="02050604050505020204" pitchFamily="18" charset="0"/>
+              </a:rPr>
+            </a:br>
+            <a:r>
+              <a:rPr lang="en-US" sz="2000" dirty="0">
+                <a:solidFill>
+                  <a:schemeClr val="bg1"/>
+                </a:solidFill>
+                <a:latin typeface="Bookman Old Style" panose="02050604050505020204" pitchFamily="18" charset="0"/>
+              </a:rPr>
+              <a:t>Each step was carefully applied to remove unnecessary data, fix quality issues, and enhance analytical usability.</a:t>
+            </a:r>
+            <a:endParaRPr lang="en-IN" sz="2000" dirty="0">
+              <a:solidFill>
+                <a:schemeClr val="bg1"/>
+              </a:solidFill>
+              <a:latin typeface="Bookman Old Style" panose="02050604050505020204" pitchFamily="18" charset="0"/>
+            </a:endParaRPr>
+          </a:p>
+        </p:txBody>
+      </p:sp>
+      <p:sp>
+        <p:nvSpPr>
+          <p:cNvPr id="6" name="TextBox 5">
+            <a:extLst>
+              <a:ext uri="{FF2B5EF4-FFF2-40B4-BE49-F238E27FC236}">
+                <a16:creationId xmlns:a16="http://schemas.microsoft.com/office/drawing/2014/main" id="{3C0777C2-E910-F809-26CF-DF6A0F7FB250}"/>
+              </a:ext>
+            </a:extLst>
+          </p:cNvPr>
+          <p:cNvSpPr txBox="1"/>
+          <p:nvPr/>
+        </p:nvSpPr>
+        <p:spPr>
+          <a:xfrm>
+            <a:off x="498348" y="2670298"/>
+            <a:ext cx="3662172" cy="461665"/>
+          </a:xfrm>
+          <a:prstGeom prst="rect">
+            <a:avLst/>
+          </a:prstGeom>
+          <a:noFill/>
+        </p:spPr>
+        <p:txBody>
+          <a:bodyPr wrap="square">
+            <a:spAutoFit/>
+          </a:bodyPr>
+          <a:lstStyle/>
+          <a:p>
+            <a:r>
+              <a:rPr lang="en-IN" sz="2400" b="1" dirty="0">
+                <a:solidFill>
+                  <a:schemeClr val="bg1"/>
+                </a:solidFill>
+                <a:latin typeface="Bookman Old Style" panose="02050604050505020204" pitchFamily="18" charset="0"/>
+              </a:rPr>
+              <a:t>Key Cleaning Steps:</a:t>
+            </a:r>
+          </a:p>
+        </p:txBody>
+      </p:sp>
+      <p:sp>
+        <p:nvSpPr>
+          <p:cNvPr id="8" name="TextBox 7">
+            <a:extLst>
+              <a:ext uri="{FF2B5EF4-FFF2-40B4-BE49-F238E27FC236}">
+                <a16:creationId xmlns:a16="http://schemas.microsoft.com/office/drawing/2014/main" id="{3CB3E613-BB1C-B99D-0131-9C9AD2D9EE0E}"/>
+              </a:ext>
+            </a:extLst>
+          </p:cNvPr>
+          <p:cNvSpPr txBox="1"/>
+          <p:nvPr/>
+        </p:nvSpPr>
+        <p:spPr>
+          <a:xfrm>
+            <a:off x="1520190" y="3282696"/>
+            <a:ext cx="5785866" cy="1077218"/>
+          </a:xfrm>
+          <a:prstGeom prst="rect">
+            <a:avLst/>
+          </a:prstGeom>
+          <a:noFill/>
+        </p:spPr>
+        <p:txBody>
+          <a:bodyPr wrap="square">
+            <a:spAutoFit/>
+          </a:bodyPr>
+          <a:lstStyle/>
+          <a:p>
+            <a:r>
+              <a:rPr lang="en-IN" sz="2400" b="1" dirty="0">
+                <a:solidFill>
+                  <a:schemeClr val="accent4"/>
+                </a:solidFill>
+                <a:latin typeface="Bookman Old Style" panose="02050604050505020204" pitchFamily="18" charset="0"/>
+              </a:rPr>
+              <a:t>Loaded Raw Data:</a:t>
+            </a:r>
+          </a:p>
+          <a:p>
+            <a:r>
+              <a:rPr lang="en-US" sz="2000" dirty="0">
+                <a:solidFill>
+                  <a:schemeClr val="bg1"/>
+                </a:solidFill>
+                <a:latin typeface="Bookman Old Style" panose="02050604050505020204" pitchFamily="18" charset="0"/>
+              </a:rPr>
+              <a:t>Imported the CSV file containing 1,28,975 rows and 24 columns.</a:t>
+            </a:r>
+            <a:endParaRPr lang="en-IN" sz="2000" dirty="0">
+              <a:solidFill>
+                <a:schemeClr val="bg1"/>
+              </a:solidFill>
+              <a:latin typeface="Bookman Old Style" panose="02050604050505020204" pitchFamily="18" charset="0"/>
+            </a:endParaRPr>
+          </a:p>
+        </p:txBody>
+      </p:sp>
+      <p:sp>
+        <p:nvSpPr>
+          <p:cNvPr id="10" name="TextBox 9">
+            <a:extLst>
+              <a:ext uri="{FF2B5EF4-FFF2-40B4-BE49-F238E27FC236}">
+                <a16:creationId xmlns:a16="http://schemas.microsoft.com/office/drawing/2014/main" id="{F8065F09-B4B6-D396-59AC-F3501250DA37}"/>
+              </a:ext>
+            </a:extLst>
+          </p:cNvPr>
+          <p:cNvSpPr txBox="1"/>
+          <p:nvPr/>
+        </p:nvSpPr>
+        <p:spPr>
+          <a:xfrm>
+            <a:off x="1520190" y="4468082"/>
+            <a:ext cx="6094476" cy="1692771"/>
+          </a:xfrm>
+          <a:prstGeom prst="rect">
+            <a:avLst/>
+          </a:prstGeom>
+          <a:noFill/>
+        </p:spPr>
+        <p:txBody>
+          <a:bodyPr wrap="square">
+            <a:spAutoFit/>
+          </a:bodyPr>
+          <a:lstStyle/>
+          <a:p>
+            <a:r>
+              <a:rPr lang="en-US" sz="2400" b="1" dirty="0">
+                <a:solidFill>
+                  <a:schemeClr val="accent4"/>
+                </a:solidFill>
+                <a:latin typeface="Bookman Old Style" panose="02050604050505020204" pitchFamily="18" charset="0"/>
+              </a:rPr>
+              <a:t>Removed Unnecessary Columns:</a:t>
+            </a:r>
+            <a:br>
+              <a:rPr lang="en-US" sz="2000" dirty="0">
+                <a:solidFill>
+                  <a:srgbClr val="E89D06"/>
+                </a:solidFill>
+                <a:latin typeface="Bookman Old Style" panose="02050604050505020204" pitchFamily="18" charset="0"/>
+              </a:rPr>
+            </a:br>
+            <a:r>
+              <a:rPr lang="en-US" sz="2000" dirty="0">
+                <a:solidFill>
+                  <a:schemeClr val="bg1"/>
+                </a:solidFill>
+                <a:latin typeface="Bookman Old Style" panose="02050604050505020204" pitchFamily="18" charset="0"/>
+              </a:rPr>
+              <a:t>Dropped irrelevant fields such as index, Style, ASIN, ship-postal-code, Unnamed: 22, Sales Channel, Currency, and Country to keep only relevant business attributes.</a:t>
+            </a:r>
+            <a:endParaRPr lang="en-IN" sz="2000" dirty="0">
+              <a:solidFill>
+                <a:schemeClr val="bg1"/>
+              </a:solidFill>
+              <a:latin typeface="Bookman Old Style" panose="02050604050505020204" pitchFamily="18" charset="0"/>
+            </a:endParaRPr>
+          </a:p>
+        </p:txBody>
+      </p:sp>
+      <p:sp>
+        <p:nvSpPr>
+          <p:cNvPr id="11" name="TextBox 10">
+            <a:extLst>
+              <a:ext uri="{FF2B5EF4-FFF2-40B4-BE49-F238E27FC236}">
+                <a16:creationId xmlns:a16="http://schemas.microsoft.com/office/drawing/2014/main" id="{F49C0A64-CF67-F558-A1AB-B8600F77826B}"/>
+              </a:ext>
+            </a:extLst>
+          </p:cNvPr>
+          <p:cNvSpPr txBox="1"/>
+          <p:nvPr/>
+        </p:nvSpPr>
+        <p:spPr>
+          <a:xfrm>
+            <a:off x="905256" y="3279542"/>
+            <a:ext cx="593217" cy="461665"/>
+          </a:xfrm>
+          <a:prstGeom prst="rect">
+            <a:avLst/>
+          </a:prstGeom>
+          <a:noFill/>
+        </p:spPr>
+        <p:txBody>
+          <a:bodyPr wrap="square" rtlCol="0">
+            <a:spAutoFit/>
+          </a:bodyPr>
+          <a:lstStyle/>
+          <a:p>
+            <a:r>
+              <a:rPr lang="en-IN" sz="2400" b="1" dirty="0">
+                <a:solidFill>
+                  <a:schemeClr val="accent4"/>
+                </a:solidFill>
+                <a:latin typeface="Bookman Old Style" panose="02050604050505020204" pitchFamily="18" charset="0"/>
+              </a:rPr>
+              <a:t>01</a:t>
+            </a:r>
+          </a:p>
+        </p:txBody>
+      </p:sp>
+      <p:sp>
+        <p:nvSpPr>
+          <p:cNvPr id="12" name="TextBox 11">
+            <a:extLst>
+              <a:ext uri="{FF2B5EF4-FFF2-40B4-BE49-F238E27FC236}">
+                <a16:creationId xmlns:a16="http://schemas.microsoft.com/office/drawing/2014/main" id="{15CF6001-64FF-A88E-FF5E-C4A4945EAA96}"/>
+              </a:ext>
+            </a:extLst>
+          </p:cNvPr>
+          <p:cNvSpPr txBox="1"/>
+          <p:nvPr/>
+        </p:nvSpPr>
+        <p:spPr>
+          <a:xfrm>
+            <a:off x="905256" y="4473184"/>
+            <a:ext cx="593217" cy="461665"/>
+          </a:xfrm>
+          <a:prstGeom prst="rect">
+            <a:avLst/>
+          </a:prstGeom>
+          <a:noFill/>
+        </p:spPr>
+        <p:txBody>
+          <a:bodyPr wrap="square" rtlCol="0">
+            <a:spAutoFit/>
+          </a:bodyPr>
+          <a:lstStyle/>
+          <a:p>
+            <a:r>
+              <a:rPr lang="en-IN" sz="2400" b="1" dirty="0">
+                <a:solidFill>
+                  <a:schemeClr val="accent4"/>
+                </a:solidFill>
+                <a:latin typeface="Bookman Old Style" panose="02050604050505020204" pitchFamily="18" charset="0"/>
+              </a:rPr>
+              <a:t>02</a:t>
+            </a:r>
+          </a:p>
+        </p:txBody>
+      </p:sp>
+      <p:pic>
+        <p:nvPicPr>
+          <p:cNvPr id="14" name="Picture 13">
+            <a:extLst>
+              <a:ext uri="{FF2B5EF4-FFF2-40B4-BE49-F238E27FC236}">
+                <a16:creationId xmlns:a16="http://schemas.microsoft.com/office/drawing/2014/main" id="{0996FF04-35C5-B818-A24A-E69F2F51955A}"/>
+              </a:ext>
+            </a:extLst>
+          </p:cNvPr>
+          <p:cNvPicPr>
+            <a:picLocks noChangeAspect="1"/>
+          </p:cNvPicPr>
+          <p:nvPr/>
+        </p:nvPicPr>
+        <p:blipFill>
+          <a:blip r:embed="rId3">
+            <a:extLst>
+              <a:ext uri="{28A0092B-C50C-407E-A947-70E740481C1C}">
+                <a14:useLocalDpi xmlns:a14="http://schemas.microsoft.com/office/drawing/2010/main" val="0"/>
+              </a:ext>
+            </a:extLst>
+          </a:blip>
+          <a:stretch>
+            <a:fillRect/>
+          </a:stretch>
+        </p:blipFill>
+        <p:spPr>
+          <a:xfrm>
+            <a:off x="7887087" y="3279542"/>
+            <a:ext cx="3723882" cy="2504262"/>
+          </a:xfrm>
+          <a:prstGeom prst="roundRect">
+            <a:avLst>
+              <a:gd name="adj" fmla="val 16667"/>
+            </a:avLst>
+          </a:prstGeom>
+          <a:ln>
+            <a:noFill/>
+          </a:ln>
+          <a:effectLst>
+            <a:outerShdw blurRad="152400" dist="12000" dir="900000" sy="98000" kx="110000" ky="200000" algn="tl" rotWithShape="0">
+              <a:srgbClr val="000000">
+                <a:alpha val="30000"/>
+              </a:srgbClr>
+            </a:outerShdw>
+          </a:effectLst>
+          <a:scene3d>
+            <a:camera prst="perspectiveRelaxed">
+              <a:rot lat="19800000" lon="1200000" rev="20820000"/>
+            </a:camera>
+            <a:lightRig rig="threePt" dir="t"/>
+          </a:scene3d>
+          <a:sp3d contourW="6350" prstMaterial="matte">
+            <a:bevelT w="101600" h="101600"/>
+            <a:contourClr>
+              <a:srgbClr val="969696"/>
+            </a:contourClr>
+          </a:sp3d>
+        </p:spPr>
+      </p:pic>
+    </p:spTree>
+    <p:extLst>
+      <p:ext uri="{BB962C8B-B14F-4D97-AF65-F5344CB8AC3E}">
+        <p14:creationId xmlns:p14="http://schemas.microsoft.com/office/powerpoint/2010/main" val="1624174513"/>
+      </p:ext>
+    </p:extLst>
+  </p:cSld>
+  <p:clrMapOvr>
+    <a:masterClrMapping/>
+  </p:clrMapOvr>
+</p:sld>
+</file>
+
+<file path=ppt/slides/slide12.xml><?xml version="1.0" encoding="utf-8"?>
+<p:sld xmlns:a="http://schemas.openxmlformats.org/drawingml/2006/main" xmlns:r="http://schemas.openxmlformats.org/officeDocument/2006/relationships" xmlns:p="http://schemas.openxmlformats.org/presentationml/2006/main">
+  <p:cSld>
+    <p:spTree>
+      <p:nvGrpSpPr>
+        <p:cNvPr id="1" name=""/>
+        <p:cNvGrpSpPr/>
+        <p:nvPr/>
+      </p:nvGrpSpPr>
+      <p:grpSpPr>
+        <a:xfrm>
+          <a:off x="0" y="0"/>
+          <a:ext cx="0" cy="0"/>
+          <a:chOff x="0" y="0"/>
+          <a:chExt cx="0" cy="0"/>
+        </a:xfrm>
+      </p:grpSpPr>
+      <p:pic>
+        <p:nvPicPr>
+          <p:cNvPr id="3" name="Picture 2">
+            <a:extLst>
+              <a:ext uri="{FF2B5EF4-FFF2-40B4-BE49-F238E27FC236}">
+                <a16:creationId xmlns:a16="http://schemas.microsoft.com/office/drawing/2014/main" id="{94000A30-AB3E-923D-1E99-3866455C6A38}"/>
+              </a:ext>
+            </a:extLst>
+          </p:cNvPr>
+          <p:cNvPicPr>
+            <a:picLocks noChangeAspect="1"/>
+          </p:cNvPicPr>
+          <p:nvPr/>
+        </p:nvPicPr>
+        <p:blipFill>
+          <a:blip r:embed="rId2">
+            <a:extLst>
+              <a:ext uri="{28A0092B-C50C-407E-A947-70E740481C1C}">
+                <a14:useLocalDpi xmlns:a14="http://schemas.microsoft.com/office/drawing/2010/main" val="0"/>
+              </a:ext>
+            </a:extLst>
+          </a:blip>
+          <a:stretch>
+            <a:fillRect/>
+          </a:stretch>
+        </p:blipFill>
+        <p:spPr>
+          <a:xfrm>
+            <a:off x="0" y="0"/>
+            <a:ext cx="12192000" cy="6858000"/>
+          </a:xfrm>
+          <a:prstGeom prst="rect">
+            <a:avLst/>
+          </a:prstGeom>
+          <a:ln>
+            <a:noFill/>
+          </a:ln>
+          <a:effectLst>
+            <a:softEdge rad="112500"/>
+          </a:effectLst>
+        </p:spPr>
+      </p:pic>
+      <p:pic>
+        <p:nvPicPr>
+          <p:cNvPr id="21" name="Picture 20">
+            <a:extLst>
+              <a:ext uri="{FF2B5EF4-FFF2-40B4-BE49-F238E27FC236}">
+                <a16:creationId xmlns:a16="http://schemas.microsoft.com/office/drawing/2014/main" id="{CB6B05D3-91C1-4BAA-937A-DF1256F8E257}"/>
+              </a:ext>
+            </a:extLst>
+          </p:cNvPr>
+          <p:cNvPicPr>
+            <a:picLocks noChangeAspect="1"/>
+          </p:cNvPicPr>
+          <p:nvPr/>
+        </p:nvPicPr>
+        <p:blipFill>
+          <a:blip r:embed="rId3">
+            <a:extLst>
+              <a:ext uri="{28A0092B-C50C-407E-A947-70E740481C1C}">
+                <a14:useLocalDpi xmlns:a14="http://schemas.microsoft.com/office/drawing/2010/main" val="0"/>
+              </a:ext>
+            </a:extLst>
+          </a:blip>
+          <a:stretch>
+            <a:fillRect/>
+          </a:stretch>
+        </p:blipFill>
+        <p:spPr>
+          <a:xfrm>
+            <a:off x="6413813" y="2921227"/>
+            <a:ext cx="5041392" cy="3603859"/>
+          </a:xfrm>
+          <a:prstGeom prst="rect">
+            <a:avLst/>
+          </a:prstGeom>
+          <a:effectLst>
+            <a:softEdge rad="635000"/>
+          </a:effectLst>
+        </p:spPr>
+      </p:pic>
+      <p:grpSp>
+        <p:nvGrpSpPr>
+          <p:cNvPr id="12" name="Group 11">
+            <a:extLst>
+              <a:ext uri="{FF2B5EF4-FFF2-40B4-BE49-F238E27FC236}">
+                <a16:creationId xmlns:a16="http://schemas.microsoft.com/office/drawing/2014/main" id="{85FFCDB9-90CD-E141-7FE6-1C3890937AC7}"/>
+              </a:ext>
+            </a:extLst>
+          </p:cNvPr>
+          <p:cNvGrpSpPr/>
+          <p:nvPr/>
+        </p:nvGrpSpPr>
+        <p:grpSpPr>
+          <a:xfrm>
+            <a:off x="763643" y="1987387"/>
+            <a:ext cx="5059261" cy="1938992"/>
+            <a:chOff x="931651" y="3429000"/>
+            <a:chExt cx="5501704" cy="1938992"/>
+          </a:xfrm>
+        </p:grpSpPr>
+        <p:sp>
+          <p:nvSpPr>
+            <p:cNvPr id="6" name="TextBox 5">
+              <a:extLst>
+                <a:ext uri="{FF2B5EF4-FFF2-40B4-BE49-F238E27FC236}">
+                  <a16:creationId xmlns:a16="http://schemas.microsoft.com/office/drawing/2014/main" id="{3C607A2C-BE22-4DEB-29B7-A56FB7F1AF80}"/>
+                </a:ext>
+              </a:extLst>
+            </p:cNvPr>
+            <p:cNvSpPr txBox="1"/>
+            <p:nvPr/>
+          </p:nvSpPr>
+          <p:spPr>
+            <a:xfrm>
+              <a:off x="1575054" y="3429000"/>
+              <a:ext cx="4858301" cy="1938992"/>
+            </a:xfrm>
+            <a:prstGeom prst="rect">
+              <a:avLst/>
+            </a:prstGeom>
+            <a:noFill/>
+          </p:spPr>
+          <p:txBody>
+            <a:bodyPr wrap="square">
+              <a:spAutoFit/>
+            </a:bodyPr>
+            <a:lstStyle/>
+            <a:p>
+              <a:r>
+                <a:rPr lang="en-US" sz="2000" b="1" dirty="0">
+                  <a:solidFill>
+                    <a:srgbClr val="FFC000"/>
+                  </a:solidFill>
+                  <a:latin typeface="Bookman Old Style" panose="02050604050505020204" pitchFamily="18" charset="0"/>
+                </a:rPr>
+                <a:t>Quantity &amp; Amount Handling:</a:t>
+              </a:r>
+            </a:p>
+            <a:p>
+              <a:pPr marL="342900" indent="-342900">
+                <a:buClr>
+                  <a:schemeClr val="accent4"/>
+                </a:buClr>
+                <a:buFont typeface="Bookman Old Style" panose="02050604050505020204" pitchFamily="18" charset="0"/>
+                <a:buChar char="→"/>
+              </a:pPr>
+              <a:r>
+                <a:rPr lang="en-US" sz="1600" dirty="0">
+                  <a:solidFill>
+                    <a:schemeClr val="bg1"/>
+                  </a:solidFill>
+                  <a:latin typeface="Bookman Old Style" panose="02050604050505020204" pitchFamily="18" charset="0"/>
+                </a:rPr>
+                <a:t>Managed rows with missing or zero Qty values and recalculated totals.</a:t>
+              </a:r>
+            </a:p>
+            <a:p>
+              <a:pPr marL="342900" indent="-342900">
+                <a:buClr>
+                  <a:schemeClr val="accent4"/>
+                </a:buClr>
+                <a:buFont typeface="Bookman Old Style" panose="02050604050505020204" pitchFamily="18" charset="0"/>
+                <a:buChar char="→"/>
+              </a:pPr>
+              <a:r>
+                <a:rPr lang="en-US" sz="1600" dirty="0">
+                  <a:solidFill>
+                    <a:schemeClr val="bg1"/>
+                  </a:solidFill>
+                  <a:latin typeface="Bookman Old Style" panose="02050604050505020204" pitchFamily="18" charset="0"/>
+                </a:rPr>
+                <a:t>Added a new calculated column </a:t>
+              </a:r>
+              <a:r>
+                <a:rPr lang="en-US" sz="1600" b="1" dirty="0">
+                  <a:solidFill>
+                    <a:schemeClr val="bg1"/>
+                  </a:solidFill>
+                  <a:latin typeface="Bookman Old Style" panose="02050604050505020204" pitchFamily="18" charset="0"/>
+                </a:rPr>
+                <a:t>Total Amount</a:t>
+              </a:r>
+              <a:r>
+                <a:rPr lang="en-US" sz="1600" dirty="0">
+                  <a:solidFill>
+                    <a:schemeClr val="bg1"/>
+                  </a:solidFill>
+                  <a:latin typeface="Bookman Old Style" panose="02050604050505020204" pitchFamily="18" charset="0"/>
+                </a:rPr>
+                <a:t> (Qty * Item Price).</a:t>
+              </a:r>
+            </a:p>
+            <a:p>
+              <a:pPr marL="342900" indent="-342900">
+                <a:buClr>
+                  <a:schemeClr val="accent4"/>
+                </a:buClr>
+                <a:buFont typeface="Bookman Old Style" panose="02050604050505020204" pitchFamily="18" charset="0"/>
+                <a:buChar char="→"/>
+              </a:pPr>
+              <a:r>
+                <a:rPr lang="en-US" sz="1600" dirty="0">
+                  <a:solidFill>
+                    <a:schemeClr val="bg1"/>
+                  </a:solidFill>
+                  <a:latin typeface="Bookman Old Style" panose="02050604050505020204" pitchFamily="18" charset="0"/>
+                </a:rPr>
+                <a:t>Removed null and zero-value errors, resulting in </a:t>
+              </a:r>
+              <a:r>
+                <a:rPr lang="en-US" sz="1600" b="1" dirty="0">
+                  <a:solidFill>
+                    <a:schemeClr val="bg1"/>
+                  </a:solidFill>
+                  <a:latin typeface="Bookman Old Style" panose="02050604050505020204" pitchFamily="18" charset="0"/>
+                </a:rPr>
+                <a:t>1,13,698 clean records.</a:t>
+              </a:r>
+              <a:endParaRPr lang="en-US" sz="1600" dirty="0">
+                <a:solidFill>
+                  <a:schemeClr val="bg1"/>
+                </a:solidFill>
+                <a:latin typeface="Bookman Old Style" panose="02050604050505020204" pitchFamily="18" charset="0"/>
+              </a:endParaRPr>
+            </a:p>
+          </p:txBody>
+        </p:sp>
+        <p:sp>
+          <p:nvSpPr>
+            <p:cNvPr id="9" name="TextBox 8">
+              <a:extLst>
+                <a:ext uri="{FF2B5EF4-FFF2-40B4-BE49-F238E27FC236}">
+                  <a16:creationId xmlns:a16="http://schemas.microsoft.com/office/drawing/2014/main" id="{CA23DDF9-FE5F-6731-F9FB-8EE3DDB5B00D}"/>
+                </a:ext>
+              </a:extLst>
+            </p:cNvPr>
+            <p:cNvSpPr txBox="1"/>
+            <p:nvPr/>
+          </p:nvSpPr>
+          <p:spPr>
+            <a:xfrm>
+              <a:off x="931651" y="3474157"/>
+              <a:ext cx="593217" cy="400110"/>
+            </a:xfrm>
+            <a:prstGeom prst="rect">
+              <a:avLst/>
+            </a:prstGeom>
+            <a:noFill/>
+          </p:spPr>
+          <p:txBody>
+            <a:bodyPr wrap="square" rtlCol="0">
+              <a:spAutoFit/>
+            </a:bodyPr>
+            <a:lstStyle/>
+            <a:p>
+              <a:r>
+                <a:rPr lang="en-IN" sz="2000" b="1" dirty="0">
+                  <a:solidFill>
+                    <a:srgbClr val="FFC000"/>
+                  </a:solidFill>
+                  <a:latin typeface="Bookman Old Style" panose="02050604050505020204" pitchFamily="18" charset="0"/>
+                </a:rPr>
+                <a:t>04</a:t>
+              </a:r>
+            </a:p>
+          </p:txBody>
+        </p:sp>
+      </p:grpSp>
+      <p:grpSp>
+        <p:nvGrpSpPr>
+          <p:cNvPr id="11" name="Group 10">
+            <a:extLst>
+              <a:ext uri="{FF2B5EF4-FFF2-40B4-BE49-F238E27FC236}">
+                <a16:creationId xmlns:a16="http://schemas.microsoft.com/office/drawing/2014/main" id="{A2EFDFC8-DBE4-1283-D1E1-E3DA3D1258C6}"/>
+              </a:ext>
+            </a:extLst>
+          </p:cNvPr>
+          <p:cNvGrpSpPr/>
+          <p:nvPr/>
+        </p:nvGrpSpPr>
+        <p:grpSpPr>
+          <a:xfrm>
+            <a:off x="763643" y="491889"/>
+            <a:ext cx="4913376" cy="1384995"/>
+            <a:chOff x="929640" y="490425"/>
+            <a:chExt cx="4913376" cy="1384995"/>
+          </a:xfrm>
+        </p:grpSpPr>
+        <p:sp>
+          <p:nvSpPr>
+            <p:cNvPr id="5" name="TextBox 4">
+              <a:extLst>
+                <a:ext uri="{FF2B5EF4-FFF2-40B4-BE49-F238E27FC236}">
+                  <a16:creationId xmlns:a16="http://schemas.microsoft.com/office/drawing/2014/main" id="{F476F605-90EB-BEF4-186C-1108530E20B0}"/>
+                </a:ext>
+              </a:extLst>
+            </p:cNvPr>
+            <p:cNvSpPr txBox="1"/>
+            <p:nvPr/>
+          </p:nvSpPr>
+          <p:spPr>
+            <a:xfrm>
+              <a:off x="1374763" y="490425"/>
+              <a:ext cx="4468253" cy="1384995"/>
+            </a:xfrm>
+            <a:prstGeom prst="rect">
+              <a:avLst/>
+            </a:prstGeom>
+            <a:noFill/>
+          </p:spPr>
+          <p:txBody>
+            <a:bodyPr wrap="square">
+              <a:spAutoFit/>
+            </a:bodyPr>
+            <a:lstStyle/>
+            <a:p>
+              <a:pPr>
+                <a:buNone/>
+              </a:pPr>
+              <a:r>
+                <a:rPr lang="en-US" sz="2000" b="1" dirty="0">
+                  <a:solidFill>
+                    <a:srgbClr val="FFC000"/>
+                  </a:solidFill>
+                  <a:latin typeface="Bookman Old Style" panose="02050604050505020204" pitchFamily="18" charset="0"/>
+                </a:rPr>
+                <a:t>Error &amp; Blank Handling:</a:t>
+              </a:r>
+            </a:p>
+            <a:p>
+              <a:pPr marL="342900" indent="-342900">
+                <a:buClr>
+                  <a:schemeClr val="accent4"/>
+                </a:buClr>
+                <a:buFont typeface="Bookman Old Style" panose="02050604050505020204" pitchFamily="18" charset="0"/>
+                <a:buChar char="→"/>
+              </a:pPr>
+              <a:r>
+                <a:rPr lang="en-US" sz="1600" dirty="0">
+                  <a:solidFill>
+                    <a:schemeClr val="bg1"/>
+                  </a:solidFill>
+                  <a:latin typeface="Bookman Old Style" panose="02050604050505020204" pitchFamily="18" charset="0"/>
+                </a:rPr>
+                <a:t>Removed error values, blank rows, and duplicates to ensure data quality.</a:t>
+              </a:r>
+            </a:p>
+            <a:p>
+              <a:pPr marL="342900" indent="-342900">
+                <a:buClr>
+                  <a:schemeClr val="accent4"/>
+                </a:buClr>
+                <a:buFont typeface="Bookman Old Style" panose="02050604050505020204" pitchFamily="18" charset="0"/>
+                <a:buChar char="→"/>
+              </a:pPr>
+              <a:r>
+                <a:rPr lang="en-US" sz="1600" dirty="0">
+                  <a:solidFill>
+                    <a:schemeClr val="bg1"/>
+                  </a:solidFill>
+                  <a:latin typeface="Bookman Old Style" panose="02050604050505020204" pitchFamily="18" charset="0"/>
+                </a:rPr>
+                <a:t>Duplicates removed: </a:t>
+              </a:r>
+              <a:r>
+                <a:rPr lang="en-US" sz="1600" b="1" dirty="0">
+                  <a:solidFill>
+                    <a:schemeClr val="bg1"/>
+                  </a:solidFill>
+                  <a:latin typeface="Bookman Old Style" panose="02050604050505020204" pitchFamily="18" charset="0"/>
+                </a:rPr>
+                <a:t>6 rows</a:t>
+              </a:r>
+              <a:endParaRPr lang="en-US" sz="1600" dirty="0">
+                <a:solidFill>
+                  <a:schemeClr val="bg1"/>
+                </a:solidFill>
+                <a:latin typeface="Bookman Old Style" panose="02050604050505020204" pitchFamily="18" charset="0"/>
+              </a:endParaRPr>
+            </a:p>
+            <a:p>
+              <a:pPr marL="342900" indent="-342900">
+                <a:buClr>
+                  <a:schemeClr val="accent4"/>
+                </a:buClr>
+                <a:buFont typeface="Bookman Old Style" panose="02050604050505020204" pitchFamily="18" charset="0"/>
+                <a:buChar char="→"/>
+              </a:pPr>
+              <a:r>
+                <a:rPr lang="en-US" sz="1600" dirty="0">
+                  <a:solidFill>
+                    <a:schemeClr val="bg1"/>
+                  </a:solidFill>
+                  <a:latin typeface="Bookman Old Style" panose="02050604050505020204" pitchFamily="18" charset="0"/>
+                </a:rPr>
+                <a:t>Total rows after cleanup: </a:t>
+              </a:r>
+              <a:r>
+                <a:rPr lang="en-US" sz="1600" b="1" dirty="0">
+                  <a:solidFill>
+                    <a:schemeClr val="bg1"/>
+                  </a:solidFill>
+                  <a:latin typeface="Bookman Old Style" panose="02050604050505020204" pitchFamily="18" charset="0"/>
+                </a:rPr>
+                <a:t>1,16,165</a:t>
+              </a:r>
+              <a:endParaRPr lang="en-US" sz="1600" dirty="0">
+                <a:solidFill>
+                  <a:schemeClr val="bg1"/>
+                </a:solidFill>
+                <a:latin typeface="Bookman Old Style" panose="02050604050505020204" pitchFamily="18" charset="0"/>
+              </a:endParaRPr>
+            </a:p>
+          </p:txBody>
+        </p:sp>
+        <p:sp>
+          <p:nvSpPr>
+            <p:cNvPr id="10" name="TextBox 9">
+              <a:extLst>
+                <a:ext uri="{FF2B5EF4-FFF2-40B4-BE49-F238E27FC236}">
+                  <a16:creationId xmlns:a16="http://schemas.microsoft.com/office/drawing/2014/main" id="{D74ED2F7-D443-F17E-7238-927F451B0850}"/>
+                </a:ext>
+              </a:extLst>
+            </p:cNvPr>
+            <p:cNvSpPr txBox="1"/>
+            <p:nvPr/>
+          </p:nvSpPr>
+          <p:spPr>
+            <a:xfrm>
+              <a:off x="929640" y="490425"/>
+              <a:ext cx="593217" cy="400110"/>
+            </a:xfrm>
+            <a:prstGeom prst="rect">
+              <a:avLst/>
+            </a:prstGeom>
+            <a:noFill/>
+          </p:spPr>
+          <p:txBody>
+            <a:bodyPr wrap="square" rtlCol="0">
+              <a:spAutoFit/>
+            </a:bodyPr>
+            <a:lstStyle/>
+            <a:p>
+              <a:r>
+                <a:rPr lang="en-IN" sz="2000" b="1" dirty="0">
+                  <a:solidFill>
+                    <a:srgbClr val="FFC000"/>
+                  </a:solidFill>
+                  <a:latin typeface="Bookman Old Style" panose="02050604050505020204" pitchFamily="18" charset="0"/>
+                </a:rPr>
+                <a:t>03</a:t>
+              </a:r>
+            </a:p>
+          </p:txBody>
+        </p:sp>
+      </p:grpSp>
+      <p:grpSp>
+        <p:nvGrpSpPr>
+          <p:cNvPr id="17" name="Group 16">
+            <a:extLst>
+              <a:ext uri="{FF2B5EF4-FFF2-40B4-BE49-F238E27FC236}">
+                <a16:creationId xmlns:a16="http://schemas.microsoft.com/office/drawing/2014/main" id="{228E106C-45C0-897C-FBFB-97615813DCB9}"/>
+              </a:ext>
+            </a:extLst>
+          </p:cNvPr>
+          <p:cNvGrpSpPr/>
+          <p:nvPr/>
+        </p:nvGrpSpPr>
+        <p:grpSpPr>
+          <a:xfrm>
+            <a:off x="6096000" y="492239"/>
+            <a:ext cx="5332036" cy="892552"/>
+            <a:chOff x="6207929" y="4130868"/>
+            <a:chExt cx="6015429" cy="892552"/>
+          </a:xfrm>
+        </p:grpSpPr>
+        <p:sp>
+          <p:nvSpPr>
+            <p:cNvPr id="14" name="TextBox 13">
+              <a:extLst>
+                <a:ext uri="{FF2B5EF4-FFF2-40B4-BE49-F238E27FC236}">
+                  <a16:creationId xmlns:a16="http://schemas.microsoft.com/office/drawing/2014/main" id="{E1B53517-3257-FD8F-09CC-0AC5CE75675E}"/>
+                </a:ext>
+              </a:extLst>
+            </p:cNvPr>
+            <p:cNvSpPr txBox="1"/>
+            <p:nvPr/>
+          </p:nvSpPr>
+          <p:spPr>
+            <a:xfrm>
+              <a:off x="6823358" y="4130868"/>
+              <a:ext cx="5400000" cy="892552"/>
+            </a:xfrm>
+            <a:prstGeom prst="rect">
+              <a:avLst/>
+            </a:prstGeom>
+            <a:noFill/>
+          </p:spPr>
+          <p:txBody>
+            <a:bodyPr wrap="square">
+              <a:spAutoFit/>
+            </a:bodyPr>
+            <a:lstStyle/>
+            <a:p>
+              <a:r>
+                <a:rPr lang="en-US" sz="2000" b="1" dirty="0">
+                  <a:solidFill>
+                    <a:schemeClr val="accent4"/>
+                  </a:solidFill>
+                  <a:latin typeface="Bookman Old Style" panose="02050604050505020204" pitchFamily="18" charset="0"/>
+                </a:rPr>
+                <a:t>Date-Based Columns Added:</a:t>
+              </a:r>
+              <a:br>
+                <a:rPr lang="en-US" sz="2400" b="1" dirty="0">
+                  <a:solidFill>
+                    <a:schemeClr val="bg1"/>
+                  </a:solidFill>
+                  <a:latin typeface="Bookman Old Style" panose="02050604050505020204" pitchFamily="18" charset="0"/>
+                </a:rPr>
+              </a:br>
+              <a:r>
+                <a:rPr lang="en-US" sz="1600" dirty="0">
+                  <a:solidFill>
+                    <a:schemeClr val="bg1"/>
+                  </a:solidFill>
+                  <a:latin typeface="Bookman Old Style" panose="02050604050505020204" pitchFamily="18" charset="0"/>
+                </a:rPr>
+                <a:t>Extracted </a:t>
+              </a:r>
+              <a:r>
+                <a:rPr lang="en-US" sz="1600" b="1" dirty="0">
+                  <a:solidFill>
+                    <a:schemeClr val="bg1"/>
+                  </a:solidFill>
+                  <a:latin typeface="Bookman Old Style" panose="02050604050505020204" pitchFamily="18" charset="0"/>
+                </a:rPr>
+                <a:t>Year</a:t>
+              </a:r>
+              <a:r>
+                <a:rPr lang="en-US" sz="1600" dirty="0">
+                  <a:solidFill>
+                    <a:schemeClr val="bg1"/>
+                  </a:solidFill>
+                  <a:latin typeface="Bookman Old Style" panose="02050604050505020204" pitchFamily="18" charset="0"/>
+                </a:rPr>
+                <a:t>, </a:t>
+              </a:r>
+              <a:r>
+                <a:rPr lang="en-US" sz="1600" b="1" dirty="0">
+                  <a:solidFill>
+                    <a:schemeClr val="bg1"/>
+                  </a:solidFill>
+                  <a:latin typeface="Bookman Old Style" panose="02050604050505020204" pitchFamily="18" charset="0"/>
+                </a:rPr>
+                <a:t>Month</a:t>
+              </a:r>
+              <a:r>
+                <a:rPr lang="en-US" sz="1600" dirty="0">
+                  <a:solidFill>
+                    <a:schemeClr val="bg1"/>
+                  </a:solidFill>
+                  <a:latin typeface="Bookman Old Style" panose="02050604050505020204" pitchFamily="18" charset="0"/>
+                </a:rPr>
+                <a:t>, and </a:t>
+              </a:r>
+              <a:r>
+                <a:rPr lang="en-US" sz="1600" b="1" dirty="0">
+                  <a:solidFill>
+                    <a:schemeClr val="bg1"/>
+                  </a:solidFill>
+                  <a:latin typeface="Bookman Old Style" panose="02050604050505020204" pitchFamily="18" charset="0"/>
+                </a:rPr>
+                <a:t>Week</a:t>
+              </a:r>
+              <a:r>
+                <a:rPr lang="en-US" sz="1600" dirty="0">
+                  <a:solidFill>
+                    <a:schemeClr val="bg1"/>
+                  </a:solidFill>
+                  <a:latin typeface="Bookman Old Style" panose="02050604050505020204" pitchFamily="18" charset="0"/>
+                </a:rPr>
+                <a:t> from order date for time-series analysis.</a:t>
+              </a:r>
+              <a:endParaRPr lang="en-US" sz="2000" dirty="0">
+                <a:solidFill>
+                  <a:schemeClr val="bg1"/>
+                </a:solidFill>
+                <a:latin typeface="Bookman Old Style" panose="02050604050505020204" pitchFamily="18" charset="0"/>
+              </a:endParaRPr>
+            </a:p>
+          </p:txBody>
+        </p:sp>
+        <p:sp>
+          <p:nvSpPr>
+            <p:cNvPr id="15" name="TextBox 14">
+              <a:extLst>
+                <a:ext uri="{FF2B5EF4-FFF2-40B4-BE49-F238E27FC236}">
+                  <a16:creationId xmlns:a16="http://schemas.microsoft.com/office/drawing/2014/main" id="{53417BA2-1A6D-176A-F9D1-402324F90DF6}"/>
+                </a:ext>
+              </a:extLst>
+            </p:cNvPr>
+            <p:cNvSpPr txBox="1"/>
+            <p:nvPr/>
+          </p:nvSpPr>
+          <p:spPr>
+            <a:xfrm>
+              <a:off x="6207929" y="4151493"/>
+              <a:ext cx="617333" cy="400110"/>
+            </a:xfrm>
+            <a:prstGeom prst="rect">
+              <a:avLst/>
+            </a:prstGeom>
+            <a:noFill/>
+          </p:spPr>
+          <p:txBody>
+            <a:bodyPr wrap="square" rtlCol="0">
+              <a:spAutoFit/>
+            </a:bodyPr>
+            <a:lstStyle/>
+            <a:p>
+              <a:r>
+                <a:rPr lang="en-IN" sz="2000" b="1" dirty="0">
+                  <a:solidFill>
+                    <a:schemeClr val="accent4"/>
+                  </a:solidFill>
+                  <a:latin typeface="Bookman Old Style" panose="02050604050505020204" pitchFamily="18" charset="0"/>
+                </a:rPr>
+                <a:t>06</a:t>
+              </a:r>
+            </a:p>
+          </p:txBody>
+        </p:sp>
+      </p:grpSp>
+      <p:grpSp>
+        <p:nvGrpSpPr>
+          <p:cNvPr id="18" name="Group 17">
+            <a:extLst>
+              <a:ext uri="{FF2B5EF4-FFF2-40B4-BE49-F238E27FC236}">
+                <a16:creationId xmlns:a16="http://schemas.microsoft.com/office/drawing/2014/main" id="{F332CFC9-8CA4-8E76-CD74-58F444AC93DD}"/>
+              </a:ext>
+            </a:extLst>
+          </p:cNvPr>
+          <p:cNvGrpSpPr/>
+          <p:nvPr/>
+        </p:nvGrpSpPr>
+        <p:grpSpPr>
+          <a:xfrm>
+            <a:off x="763643" y="3960815"/>
+            <a:ext cx="4913376" cy="2431435"/>
+            <a:chOff x="929640" y="3734917"/>
+            <a:chExt cx="4913376" cy="2431435"/>
+          </a:xfrm>
+        </p:grpSpPr>
+        <p:sp>
+          <p:nvSpPr>
+            <p:cNvPr id="16" name="TextBox 15">
+              <a:extLst>
+                <a:ext uri="{FF2B5EF4-FFF2-40B4-BE49-F238E27FC236}">
+                  <a16:creationId xmlns:a16="http://schemas.microsoft.com/office/drawing/2014/main" id="{B4554DDB-17FD-66D6-01A5-E35185126867}"/>
+                </a:ext>
+              </a:extLst>
+            </p:cNvPr>
+            <p:cNvSpPr txBox="1"/>
+            <p:nvPr/>
+          </p:nvSpPr>
+          <p:spPr>
+            <a:xfrm>
+              <a:off x="929640" y="3734917"/>
+              <a:ext cx="593217" cy="400110"/>
+            </a:xfrm>
+            <a:prstGeom prst="rect">
+              <a:avLst/>
+            </a:prstGeom>
+            <a:noFill/>
+          </p:spPr>
+          <p:txBody>
+            <a:bodyPr wrap="square" rtlCol="0">
+              <a:spAutoFit/>
+            </a:bodyPr>
+            <a:lstStyle/>
+            <a:p>
+              <a:r>
+                <a:rPr lang="en-IN" sz="2000" b="1" dirty="0">
+                  <a:solidFill>
+                    <a:schemeClr val="accent4"/>
+                  </a:solidFill>
+                  <a:latin typeface="Bookman Old Style" panose="02050604050505020204" pitchFamily="18" charset="0"/>
+                </a:rPr>
+                <a:t>05</a:t>
+              </a:r>
+            </a:p>
+          </p:txBody>
+        </p:sp>
+        <p:sp>
+          <p:nvSpPr>
+            <p:cNvPr id="13" name="TextBox 12">
+              <a:extLst>
+                <a:ext uri="{FF2B5EF4-FFF2-40B4-BE49-F238E27FC236}">
+                  <a16:creationId xmlns:a16="http://schemas.microsoft.com/office/drawing/2014/main" id="{B62ACAD1-E7CD-0D49-AC71-DB806BF10718}"/>
+                </a:ext>
+              </a:extLst>
+            </p:cNvPr>
+            <p:cNvSpPr txBox="1"/>
+            <p:nvPr/>
+          </p:nvSpPr>
+          <p:spPr>
+            <a:xfrm>
+              <a:off x="1374763" y="3734917"/>
+              <a:ext cx="4468253" cy="2431435"/>
+            </a:xfrm>
+            <a:prstGeom prst="rect">
+              <a:avLst/>
+            </a:prstGeom>
+            <a:noFill/>
+          </p:spPr>
+          <p:txBody>
+            <a:bodyPr wrap="square">
+              <a:spAutoFit/>
+            </a:bodyPr>
+            <a:lstStyle/>
+            <a:p>
+              <a:r>
+                <a:rPr lang="en-US" sz="2000" b="1" dirty="0">
+                  <a:solidFill>
+                    <a:schemeClr val="accent4"/>
+                  </a:solidFill>
+                  <a:latin typeface="Bookman Old Style" panose="02050604050505020204" pitchFamily="18" charset="0"/>
+                </a:rPr>
+                <a:t>Categorization Columns Created:</a:t>
+              </a:r>
+            </a:p>
+            <a:p>
+              <a:pPr marL="285750" indent="-285750">
+                <a:buClr>
+                  <a:srgbClr val="FFC000"/>
+                </a:buClr>
+                <a:buFont typeface="Bookman Old Style" panose="02050604050505020204" pitchFamily="18" charset="0"/>
+                <a:buChar char="→"/>
+              </a:pPr>
+              <a:r>
+                <a:rPr lang="en-US" sz="1600" dirty="0">
+                  <a:solidFill>
+                    <a:schemeClr val="bg1"/>
+                  </a:solidFill>
+                  <a:latin typeface="Bookman Old Style" panose="02050604050505020204" pitchFamily="18" charset="0"/>
+                </a:rPr>
+                <a:t>Added </a:t>
+              </a:r>
+              <a:r>
+                <a:rPr lang="en-US" sz="1600" b="1" dirty="0">
+                  <a:solidFill>
+                    <a:schemeClr val="bg1"/>
+                  </a:solidFill>
+                  <a:latin typeface="Bookman Old Style" panose="02050604050505020204" pitchFamily="18" charset="0"/>
+                </a:rPr>
+                <a:t>Order Type</a:t>
+              </a:r>
+              <a:r>
+                <a:rPr lang="en-US" sz="1600" dirty="0">
+                  <a:solidFill>
+                    <a:schemeClr val="bg1"/>
+                  </a:solidFill>
+                  <a:latin typeface="Bookman Old Style" panose="02050604050505020204" pitchFamily="18" charset="0"/>
+                </a:rPr>
+                <a:t> (Amazon vs Merchant) for fulfilment classification.</a:t>
+              </a:r>
+            </a:p>
+            <a:p>
+              <a:pPr marL="285750" indent="-285750">
+                <a:buClr>
+                  <a:srgbClr val="FFC000"/>
+                </a:buClr>
+                <a:buFont typeface="Bookman Old Style" panose="02050604050505020204" pitchFamily="18" charset="0"/>
+                <a:buChar char="→"/>
+              </a:pPr>
+              <a:r>
+                <a:rPr lang="en-US" sz="1600" dirty="0">
+                  <a:solidFill>
+                    <a:schemeClr val="bg1"/>
+                  </a:solidFill>
+                  <a:latin typeface="Bookman Old Style" panose="02050604050505020204" pitchFamily="18" charset="0"/>
+                </a:rPr>
+                <a:t>Created </a:t>
+              </a:r>
+              <a:r>
+                <a:rPr lang="en-US" sz="1600" b="1" dirty="0">
+                  <a:solidFill>
+                    <a:schemeClr val="bg1"/>
+                  </a:solidFill>
+                  <a:latin typeface="Bookman Old Style" panose="02050604050505020204" pitchFamily="18" charset="0"/>
+                </a:rPr>
+                <a:t>Order Status Group</a:t>
+              </a:r>
+              <a:r>
+                <a:rPr lang="en-US" sz="1600" dirty="0">
+                  <a:solidFill>
+                    <a:schemeClr val="bg1"/>
+                  </a:solidFill>
+                  <a:latin typeface="Bookman Old Style" panose="02050604050505020204" pitchFamily="18" charset="0"/>
+                </a:rPr>
+                <a:t> to group order outcomes (Shipped, Cancelled, Returned).</a:t>
+              </a:r>
+            </a:p>
+            <a:p>
+              <a:pPr marL="285750" indent="-285750">
+                <a:buClr>
+                  <a:srgbClr val="FFC000"/>
+                </a:buClr>
+                <a:buFont typeface="Bookman Old Style" panose="02050604050505020204" pitchFamily="18" charset="0"/>
+                <a:buChar char="→"/>
+              </a:pPr>
+              <a:r>
+                <a:rPr lang="en-US" sz="1600" dirty="0">
+                  <a:solidFill>
+                    <a:schemeClr val="bg1"/>
+                  </a:solidFill>
+                  <a:latin typeface="Bookman Old Style" panose="02050604050505020204" pitchFamily="18" charset="0"/>
+                </a:rPr>
+                <a:t>Added </a:t>
+              </a:r>
+              <a:r>
+                <a:rPr lang="en-US" sz="1600" b="1" dirty="0">
+                  <a:solidFill>
+                    <a:schemeClr val="bg1"/>
+                  </a:solidFill>
+                  <a:latin typeface="Bookman Old Style" panose="02050604050505020204" pitchFamily="18" charset="0"/>
+                </a:rPr>
+                <a:t>Promotion Type</a:t>
+              </a:r>
+              <a:r>
+                <a:rPr lang="en-US" sz="1600" dirty="0">
+                  <a:solidFill>
+                    <a:schemeClr val="bg1"/>
+                  </a:solidFill>
+                  <a:latin typeface="Bookman Old Style" panose="02050604050505020204" pitchFamily="18" charset="0"/>
+                </a:rPr>
+                <a:t> to differentiate promotional vs non-promotional sales.</a:t>
+              </a:r>
+            </a:p>
+          </p:txBody>
+        </p:sp>
+      </p:grpSp>
+      <p:sp>
+        <p:nvSpPr>
+          <p:cNvPr id="23" name="TextBox 22">
+            <a:extLst>
+              <a:ext uri="{FF2B5EF4-FFF2-40B4-BE49-F238E27FC236}">
+                <a16:creationId xmlns:a16="http://schemas.microsoft.com/office/drawing/2014/main" id="{EA55F5EE-AFEC-FB01-9CB1-8F4C7834A82A}"/>
+              </a:ext>
+            </a:extLst>
+          </p:cNvPr>
+          <p:cNvSpPr txBox="1"/>
+          <p:nvPr/>
+        </p:nvSpPr>
+        <p:spPr>
+          <a:xfrm>
+            <a:off x="6641512" y="1693990"/>
+            <a:ext cx="5041392" cy="1077218"/>
+          </a:xfrm>
+          <a:prstGeom prst="rect">
+            <a:avLst/>
+          </a:prstGeom>
+          <a:noFill/>
+        </p:spPr>
+        <p:txBody>
+          <a:bodyPr wrap="square">
+            <a:spAutoFit/>
+          </a:bodyPr>
+          <a:lstStyle/>
+          <a:p>
+            <a:pPr marL="285750" indent="-285750">
+              <a:buClr>
+                <a:srgbClr val="069822"/>
+              </a:buClr>
+              <a:buFont typeface="Wingdings" panose="05000000000000000000" pitchFamily="2" charset="2"/>
+              <a:buChar char="ü"/>
+            </a:pPr>
+            <a:r>
+              <a:rPr lang="en-US" sz="1600" i="1" dirty="0">
+                <a:solidFill>
+                  <a:schemeClr val="bg1"/>
+                </a:solidFill>
+                <a:latin typeface="Bookman Old Style" panose="02050604050505020204" pitchFamily="18" charset="0"/>
+              </a:rPr>
+              <a:t>Final dataset is fully structured, clean, and optimized for Power BI reporting — supporting accurate KPI calculations, visualizations, and forecasting analysis</a:t>
+            </a:r>
+            <a:r>
+              <a:rPr lang="en-US" sz="1600" i="1" dirty="0">
+                <a:solidFill>
+                  <a:srgbClr val="069822"/>
+                </a:solidFill>
+                <a:latin typeface="Bookman Old Style" panose="02050604050505020204" pitchFamily="18" charset="0"/>
+              </a:rPr>
+              <a:t>.</a:t>
+            </a:r>
+            <a:endParaRPr lang="en-IN" sz="1600" i="1" dirty="0">
+              <a:solidFill>
+                <a:srgbClr val="069822"/>
+              </a:solidFill>
+              <a:latin typeface="Bookman Old Style" panose="02050604050505020204" pitchFamily="18" charset="0"/>
+            </a:endParaRPr>
+          </a:p>
+        </p:txBody>
+      </p:sp>
+    </p:spTree>
+    <p:extLst>
+      <p:ext uri="{BB962C8B-B14F-4D97-AF65-F5344CB8AC3E}">
+        <p14:creationId xmlns:p14="http://schemas.microsoft.com/office/powerpoint/2010/main" val="3470620057"/>
+      </p:ext>
+    </p:extLst>
+  </p:cSld>
+  <p:clrMapOvr>
+    <a:masterClrMapping/>
+  </p:clrMapOvr>
+</p:sld>
+</file>
+
+<file path=ppt/slides/slide13.xml><?xml version="1.0" encoding="utf-8"?>
+<p:sld xmlns:a="http://schemas.openxmlformats.org/drawingml/2006/main" xmlns:r="http://schemas.openxmlformats.org/officeDocument/2006/relationships" xmlns:p="http://schemas.openxmlformats.org/presentationml/2006/main">
+  <p:cSld>
+    <p:spTree>
+      <p:nvGrpSpPr>
+        <p:cNvPr id="1" name="">
+          <a:extLst>
+            <a:ext uri="{FF2B5EF4-FFF2-40B4-BE49-F238E27FC236}">
               <a16:creationId xmlns:a16="http://schemas.microsoft.com/office/drawing/2014/main" id="{50FF9B61-0403-6A12-5DDD-0610BA4CADB5}"/>
             </a:ext>
           </a:extLst>
@@ -3714,7 +5377,7 @@
                 </a:effectLst>
                 <a:latin typeface="Bookman Old Style" panose="02050604050505020204" pitchFamily="18" charset="0"/>
               </a:rPr>
-              <a:t>02</a:t>
+              <a:t>03</a:t>
             </a:r>
           </a:p>
         </p:txBody>
@@ -3793,7 +5456,7 @@
 </p:sld>
 </file>
 
-<file path=ppt/slides/slide11.xml><?xml version="1.0" encoding="utf-8"?>
+<file path=ppt/slides/slide14.xml><?xml version="1.0" encoding="utf-8"?>
 <p:sld xmlns:a="http://schemas.openxmlformats.org/drawingml/2006/main" xmlns:r="http://schemas.openxmlformats.org/officeDocument/2006/relationships" xmlns:p="http://schemas.openxmlformats.org/presentationml/2006/main">
   <p:cSld>
     <p:bg>
@@ -3916,7 +5579,7 @@
         <p:spPr>
           <a:xfrm>
             <a:off x="348234" y="780961"/>
-            <a:ext cx="6245352" cy="1323439"/>
+            <a:ext cx="6245352" cy="2554545"/>
           </a:xfrm>
           <a:prstGeom prst="rect">
             <a:avLst/>
@@ -3936,7 +5599,16 @@
                 </a:solidFill>
                 <a:latin typeface="Bookman Old Style" panose="02050604050505020204" pitchFamily="18" charset="0"/>
               </a:rPr>
-              <a:t>The EDA phase focused on understanding, cleaning, and preparing the Amazon sales data for visualization and insights.</a:t>
+              <a:t>After cleaning the dataset, Exploratory Data Analysis was performed to understand </a:t>
+            </a:r>
+            <a:r>
+              <a:rPr lang="en-US" sz="2000" b="1" dirty="0">
+                <a:solidFill>
+                  <a:schemeClr val="bg1"/>
+                </a:solidFill>
+                <a:latin typeface="Bookman Old Style" panose="02050604050505020204" pitchFamily="18" charset="0"/>
+              </a:rPr>
+              <a:t>sales patterns, customer behavior, and key business insights.</a:t>
             </a:r>
             <a:br>
               <a:rPr lang="en-US" sz="2000" dirty="0">
@@ -3953,7 +5625,18 @@
                 </a:solidFill>
                 <a:latin typeface="Bookman Old Style" panose="02050604050505020204" pitchFamily="18" charset="0"/>
               </a:rPr>
-              <a:t>Key steps performed:</a:t>
+              <a:t>This step helped in identifying the most important trends and performance indicators before visualization.</a:t>
+            </a:r>
+          </a:p>
+          <a:p>
+            <a:r>
+              <a:rPr lang="en-US" sz="2000" dirty="0">
+                <a:solidFill>
+                  <a:schemeClr val="bg1"/>
+                </a:solidFill>
+                <a:latin typeface="Bookman Old Style" panose="02050604050505020204" pitchFamily="18" charset="0"/>
+              </a:rPr>
+              <a:t>Key analysis performed:</a:t>
             </a:r>
           </a:p>
         </p:txBody>
@@ -3972,8 +5655,8 @@
         </p:nvSpPr>
         <p:spPr>
           <a:xfrm>
-            <a:off x="422910" y="2259848"/>
-            <a:ext cx="6096000" cy="3477875"/>
+            <a:off x="642366" y="3417802"/>
+            <a:ext cx="5453634" cy="2554545"/>
           </a:xfrm>
           <a:prstGeom prst="rect">
             <a:avLst/>
@@ -3986,28 +5669,48 @@
           </a:bodyPr>
           <a:lstStyle/>
           <a:p>
-            <a:pPr marL="285750" indent="-285750">
+            <a:pPr marL="342900" indent="-342900">
               <a:buClr>
-                <a:schemeClr val="bg1"/>
+                <a:schemeClr val="accent4"/>
               </a:buClr>
               <a:buFont typeface="Wingdings" panose="05000000000000000000" pitchFamily="2" charset="2"/>
               <a:buChar char="v"/>
             </a:pPr>
             <a:r>
+              <a:rPr lang="en-US" sz="2000" b="1" dirty="0">
+                <a:solidFill>
+                  <a:schemeClr val="accent4"/>
+                </a:solidFill>
+                <a:latin typeface="Bookman Old Style" panose="02050604050505020204" pitchFamily="18" charset="0"/>
+              </a:rPr>
+              <a:t>Sales Distribution Analysis:</a:t>
+            </a:r>
+            <a:r>
               <a:rPr lang="en-US" sz="2000" dirty="0">
                 <a:solidFill>
+                  <a:schemeClr val="accent4"/>
+                </a:solidFill>
+                <a:latin typeface="Bookman Old Style" panose="02050604050505020204" pitchFamily="18" charset="0"/>
+              </a:rPr>
+              <a:t> </a:t>
+            </a:r>
+            <a:r>
+              <a:rPr lang="en-US" sz="2000" dirty="0">
+                <a:solidFill>
                   <a:schemeClr val="bg1"/>
                 </a:solidFill>
                 <a:latin typeface="Bookman Old Style" panose="02050604050505020204" pitchFamily="18" charset="0"/>
               </a:rPr>
-              <a:t>Data Profiling: Checked data types, null values, duplicates, and inconsistent entries.</a:t>
-            </a:r>
-          </a:p>
-          <a:p>
-            <a:pPr>
+              <a:t>Checked total sales, average order value, and quantity sold to understand overall business performance.</a:t>
+            </a:r>
+          </a:p>
+          <a:p>
+            <a:pPr marL="342900" indent="-342900">
               <a:buClr>
-                <a:schemeClr val="bg1"/>
+                <a:schemeClr val="accent4"/>
               </a:buClr>
+              <a:buFont typeface="Wingdings" panose="05000000000000000000" pitchFamily="2" charset="2"/>
+              <a:buChar char="v"/>
             </a:pPr>
             <a:endParaRPr lang="en-US" sz="2000" dirty="0">
               <a:solidFill>
@@ -4017,52 +5720,39 @@
             </a:endParaRPr>
           </a:p>
           <a:p>
-            <a:pPr marL="285750" indent="-285750">
+            <a:pPr marL="342900" indent="-342900">
               <a:buClr>
-                <a:schemeClr val="bg1"/>
+                <a:schemeClr val="accent4"/>
               </a:buClr>
               <a:buFont typeface="Wingdings" panose="05000000000000000000" pitchFamily="2" charset="2"/>
               <a:buChar char="v"/>
             </a:pPr>
             <a:r>
+              <a:rPr lang="en-US" sz="2000" b="1" dirty="0">
+                <a:solidFill>
+                  <a:schemeClr val="accent4"/>
+                </a:solidFill>
+                <a:latin typeface="Bookman Old Style" panose="02050604050505020204" pitchFamily="18" charset="0"/>
+              </a:rPr>
+              <a:t>Category-Level Analysis:</a:t>
+            </a:r>
+            <a:r>
               <a:rPr lang="en-US" sz="2000" dirty="0">
                 <a:solidFill>
+                  <a:schemeClr val="accent4"/>
+                </a:solidFill>
+                <a:latin typeface="Bookman Old Style" panose="02050604050505020204" pitchFamily="18" charset="0"/>
+              </a:rPr>
+              <a:t> </a:t>
+            </a:r>
+            <a:r>
+              <a:rPr lang="en-US" sz="2000" dirty="0">
+                <a:solidFill>
                   <a:schemeClr val="bg1"/>
                 </a:solidFill>
                 <a:latin typeface="Bookman Old Style" panose="02050604050505020204" pitchFamily="18" charset="0"/>
               </a:rPr>
-              <a:t>Column Standardization: Renamed and formatted columns for better readability (e.g., Order Date, Total Amount, Fulfilment Type).</a:t>
-            </a:r>
-          </a:p>
-          <a:p>
-            <a:pPr>
-              <a:buClr>
-                <a:schemeClr val="bg1"/>
-              </a:buClr>
-            </a:pPr>
-            <a:endParaRPr lang="en-US" sz="2000" dirty="0">
-              <a:solidFill>
-                <a:schemeClr val="bg1"/>
-              </a:solidFill>
-              <a:latin typeface="Bookman Old Style" panose="02050604050505020204" pitchFamily="18" charset="0"/>
-            </a:endParaRPr>
-          </a:p>
-          <a:p>
-            <a:pPr marL="285750" indent="-285750">
-              <a:buClr>
-                <a:schemeClr val="bg1"/>
-              </a:buClr>
-              <a:buFont typeface="Wingdings" panose="05000000000000000000" pitchFamily="2" charset="2"/>
-              <a:buChar char="v"/>
-            </a:pPr>
-            <a:r>
-              <a:rPr lang="en-US" sz="2000" dirty="0">
-                <a:solidFill>
-                  <a:schemeClr val="bg1"/>
-                </a:solidFill>
-                <a:latin typeface="Bookman Old Style" panose="02050604050505020204" pitchFamily="18" charset="0"/>
-              </a:rPr>
-              <a:t>Missing Value Handling: Cleaned or replaced missing and invalid entries (like blank cities or order statuses).</a:t>
+              <a:t>Examined which product categories drive maximum revenue and orders.</a:t>
             </a:r>
           </a:p>
         </p:txBody>
@@ -4080,7 +5770,7 @@
 </p:sld>
 </file>
 
-<file path=ppt/slides/slide12.xml><?xml version="1.0" encoding="utf-8"?>
+<file path=ppt/slides/slide15.xml><?xml version="1.0" encoding="utf-8"?>
 <p:sld xmlns:a="http://schemas.openxmlformats.org/drawingml/2006/main" xmlns:r="http://schemas.openxmlformats.org/officeDocument/2006/relationships" xmlns:p="http://schemas.openxmlformats.org/presentationml/2006/main">
   <p:cSld>
     <p:spTree>
@@ -4153,8 +5843,8 @@
         </p:nvSpPr>
         <p:spPr>
           <a:xfrm>
-            <a:off x="5953125" y="766732"/>
-            <a:ext cx="5751946" cy="5324535"/>
+            <a:off x="5895012" y="612842"/>
+            <a:ext cx="5751946" cy="5632311"/>
           </a:xfrm>
           <a:prstGeom prst="rect">
             <a:avLst/>
@@ -4167,6 +5857,204 @@
           </a:bodyPr>
           <a:lstStyle/>
           <a:p>
+            <a:pPr marL="342900" indent="-342900">
+              <a:buClr>
+                <a:schemeClr val="accent4"/>
+              </a:buClr>
+              <a:buFont typeface="Wingdings" panose="05000000000000000000" pitchFamily="2" charset="2"/>
+              <a:buChar char="v"/>
+            </a:pPr>
+            <a:r>
+              <a:rPr lang="en-US" sz="2000" b="1" dirty="0">
+                <a:solidFill>
+                  <a:schemeClr val="accent4"/>
+                </a:solidFill>
+                <a:latin typeface="Bookman Old Style" panose="02050604050505020204" pitchFamily="18" charset="0"/>
+              </a:rPr>
+              <a:t>Fulfilment Comparison:</a:t>
+            </a:r>
+            <a:r>
+              <a:rPr lang="en-US" sz="2000" dirty="0">
+                <a:solidFill>
+                  <a:schemeClr val="accent4"/>
+                </a:solidFill>
+                <a:latin typeface="Bookman Old Style" panose="02050604050505020204" pitchFamily="18" charset="0"/>
+              </a:rPr>
+              <a:t> </a:t>
+            </a:r>
+            <a:r>
+              <a:rPr lang="en-US" sz="2000" dirty="0">
+                <a:solidFill>
+                  <a:schemeClr val="bg1"/>
+                </a:solidFill>
+                <a:latin typeface="Bookman Old Style" panose="02050604050505020204" pitchFamily="18" charset="0"/>
+              </a:rPr>
+              <a:t>Compared </a:t>
+            </a:r>
+            <a:r>
+              <a:rPr lang="en-US" sz="2000" b="1" dirty="0">
+                <a:solidFill>
+                  <a:schemeClr val="bg1"/>
+                </a:solidFill>
+                <a:latin typeface="Bookman Old Style" panose="02050604050505020204" pitchFamily="18" charset="0"/>
+              </a:rPr>
+              <a:t>Amazon (FBA)</a:t>
+            </a:r>
+            <a:r>
+              <a:rPr lang="en-US" sz="2000" dirty="0">
+                <a:solidFill>
+                  <a:schemeClr val="bg1"/>
+                </a:solidFill>
+                <a:latin typeface="Bookman Old Style" panose="02050604050505020204" pitchFamily="18" charset="0"/>
+              </a:rPr>
+              <a:t> vs </a:t>
+            </a:r>
+            <a:r>
+              <a:rPr lang="en-US" sz="2000" b="1" dirty="0">
+                <a:solidFill>
+                  <a:schemeClr val="bg1"/>
+                </a:solidFill>
+                <a:latin typeface="Bookman Old Style" panose="02050604050505020204" pitchFamily="18" charset="0"/>
+              </a:rPr>
+              <a:t>Merchant (FBM)</a:t>
+            </a:r>
+            <a:r>
+              <a:rPr lang="en-US" sz="2000" dirty="0">
+                <a:solidFill>
+                  <a:schemeClr val="bg1"/>
+                </a:solidFill>
+                <a:latin typeface="Bookman Old Style" panose="02050604050505020204" pitchFamily="18" charset="0"/>
+              </a:rPr>
+              <a:t> fulfilment to find which performs better.</a:t>
+            </a:r>
+          </a:p>
+          <a:p>
+            <a:pPr marL="342900" indent="-342900">
+              <a:buClr>
+                <a:schemeClr val="accent4"/>
+              </a:buClr>
+              <a:buFont typeface="Wingdings" panose="05000000000000000000" pitchFamily="2" charset="2"/>
+              <a:buChar char="v"/>
+            </a:pPr>
+            <a:endParaRPr lang="en-US" sz="2000" dirty="0">
+              <a:solidFill>
+                <a:schemeClr val="bg1"/>
+              </a:solidFill>
+              <a:latin typeface="Bookman Old Style" panose="02050604050505020204" pitchFamily="18" charset="0"/>
+            </a:endParaRPr>
+          </a:p>
+          <a:p>
+            <a:pPr marL="342900" indent="-342900">
+              <a:buClr>
+                <a:schemeClr val="accent4"/>
+              </a:buClr>
+              <a:buFont typeface="Wingdings" panose="05000000000000000000" pitchFamily="2" charset="2"/>
+              <a:buChar char="v"/>
+            </a:pPr>
+            <a:r>
+              <a:rPr lang="en-US" sz="2000" b="1" dirty="0">
+                <a:solidFill>
+                  <a:schemeClr val="bg1"/>
+                </a:solidFill>
+                <a:latin typeface="Bookman Old Style" panose="02050604050505020204" pitchFamily="18" charset="0"/>
+              </a:rPr>
+              <a:t>Regional Insights: </a:t>
+            </a:r>
+            <a:r>
+              <a:rPr lang="en-US" sz="2000" dirty="0">
+                <a:solidFill>
+                  <a:schemeClr val="bg1"/>
+                </a:solidFill>
+                <a:latin typeface="Bookman Old Style" panose="02050604050505020204" pitchFamily="18" charset="0"/>
+              </a:rPr>
+              <a:t>Explored state-wise and city-wise sales to identify top and low-performing regions.</a:t>
+            </a:r>
+          </a:p>
+          <a:p>
+            <a:pPr marL="342900" indent="-342900">
+              <a:buClr>
+                <a:schemeClr val="accent4"/>
+              </a:buClr>
+              <a:buFont typeface="Wingdings" panose="05000000000000000000" pitchFamily="2" charset="2"/>
+              <a:buChar char="v"/>
+            </a:pPr>
+            <a:endParaRPr lang="en-US" sz="2000" dirty="0">
+              <a:solidFill>
+                <a:schemeClr val="bg1"/>
+              </a:solidFill>
+              <a:latin typeface="Bookman Old Style" panose="02050604050505020204" pitchFamily="18" charset="0"/>
+            </a:endParaRPr>
+          </a:p>
+          <a:p>
+            <a:pPr marL="342900" indent="-342900">
+              <a:buClr>
+                <a:schemeClr val="accent4"/>
+              </a:buClr>
+              <a:buFont typeface="Wingdings" panose="05000000000000000000" pitchFamily="2" charset="2"/>
+              <a:buChar char="v"/>
+            </a:pPr>
+            <a:r>
+              <a:rPr lang="en-US" sz="2000" b="1" dirty="0">
+                <a:solidFill>
+                  <a:schemeClr val="accent4"/>
+                </a:solidFill>
+                <a:latin typeface="Bookman Old Style" panose="02050604050505020204" pitchFamily="18" charset="0"/>
+              </a:rPr>
+              <a:t>Time Trend Analysis: </a:t>
+            </a:r>
+            <a:r>
+              <a:rPr lang="en-US" sz="2000" dirty="0">
+                <a:solidFill>
+                  <a:schemeClr val="bg1"/>
+                </a:solidFill>
+                <a:latin typeface="Bookman Old Style" panose="02050604050505020204" pitchFamily="18" charset="0"/>
+              </a:rPr>
+              <a:t>Studied month-wise and seasonal patterns to detect high-demand periods.</a:t>
+            </a:r>
+          </a:p>
+          <a:p>
+            <a:pPr marL="342900" indent="-342900">
+              <a:buClr>
+                <a:schemeClr val="accent4"/>
+              </a:buClr>
+              <a:buFont typeface="Wingdings" panose="05000000000000000000" pitchFamily="2" charset="2"/>
+              <a:buChar char="v"/>
+            </a:pPr>
+            <a:endParaRPr lang="en-US" sz="2000" dirty="0">
+              <a:solidFill>
+                <a:schemeClr val="bg1"/>
+              </a:solidFill>
+              <a:latin typeface="Bookman Old Style" panose="02050604050505020204" pitchFamily="18" charset="0"/>
+            </a:endParaRPr>
+          </a:p>
+          <a:p>
+            <a:pPr marL="342900" indent="-342900">
+              <a:buClr>
+                <a:schemeClr val="accent4"/>
+              </a:buClr>
+              <a:buFont typeface="Wingdings" panose="05000000000000000000" pitchFamily="2" charset="2"/>
+              <a:buChar char="v"/>
+            </a:pPr>
+            <a:r>
+              <a:rPr lang="en-US" sz="2000" b="1" dirty="0">
+                <a:solidFill>
+                  <a:schemeClr val="accent4"/>
+                </a:solidFill>
+                <a:latin typeface="Bookman Old Style" panose="02050604050505020204" pitchFamily="18" charset="0"/>
+              </a:rPr>
+              <a:t>Customer Segment Study: </a:t>
+            </a:r>
+            <a:r>
+              <a:rPr lang="en-US" sz="2000" dirty="0">
+                <a:solidFill>
+                  <a:schemeClr val="bg1"/>
+                </a:solidFill>
+                <a:latin typeface="Bookman Old Style" panose="02050604050505020204" pitchFamily="18" charset="0"/>
+              </a:rPr>
+              <a:t>Analyzed B2B vs B2C contribution to total revenue.</a:t>
+            </a:r>
+          </a:p>
+          <a:p>
             <a:pPr>
               <a:buClr>
                 <a:schemeClr val="bg1"/>
@@ -4180,99 +6068,6 @@
             </a:endParaRPr>
           </a:p>
           <a:p>
-            <a:pPr marL="285750" indent="-285750">
-              <a:buClr>
-                <a:schemeClr val="bg1"/>
-              </a:buClr>
-              <a:buFont typeface="Wingdings" panose="05000000000000000000" pitchFamily="2" charset="2"/>
-              <a:buChar char="v"/>
-            </a:pPr>
-            <a:r>
-              <a:rPr lang="en-US" sz="2000" dirty="0">
-                <a:solidFill>
-                  <a:schemeClr val="bg1"/>
-                </a:solidFill>
-                <a:latin typeface="Bookman Old Style" panose="02050604050505020204" pitchFamily="18" charset="0"/>
-              </a:rPr>
-              <a:t>Outlier Detection: Identified unusual sales values or quantities to ensure accurate analysis.</a:t>
-            </a:r>
-          </a:p>
-          <a:p>
-            <a:pPr>
-              <a:buClr>
-                <a:schemeClr val="bg1"/>
-              </a:buClr>
-            </a:pPr>
-            <a:endParaRPr lang="en-US" sz="2000" dirty="0">
-              <a:solidFill>
-                <a:schemeClr val="bg1"/>
-              </a:solidFill>
-              <a:latin typeface="Bookman Old Style" panose="02050604050505020204" pitchFamily="18" charset="0"/>
-            </a:endParaRPr>
-          </a:p>
-          <a:p>
-            <a:pPr marL="285750" indent="-285750">
-              <a:buClr>
-                <a:schemeClr val="bg1"/>
-              </a:buClr>
-              <a:buFont typeface="Wingdings" panose="05000000000000000000" pitchFamily="2" charset="2"/>
-              <a:buChar char="v"/>
-            </a:pPr>
-            <a:r>
-              <a:rPr lang="en-US" sz="2000" dirty="0">
-                <a:solidFill>
-                  <a:schemeClr val="bg1"/>
-                </a:solidFill>
-                <a:latin typeface="Bookman Old Style" panose="02050604050505020204" pitchFamily="18" charset="0"/>
-              </a:rPr>
-              <a:t>Derived Columns Creation: Added new columns such as Month, Year, Category Group, Order Status Group, and B2B flag for trend analysis.</a:t>
-            </a:r>
-          </a:p>
-          <a:p>
-            <a:pPr>
-              <a:buClr>
-                <a:schemeClr val="bg1"/>
-              </a:buClr>
-            </a:pPr>
-            <a:endParaRPr lang="en-US" sz="2000" dirty="0">
-              <a:solidFill>
-                <a:schemeClr val="bg1"/>
-              </a:solidFill>
-              <a:latin typeface="Bookman Old Style" panose="02050604050505020204" pitchFamily="18" charset="0"/>
-            </a:endParaRPr>
-          </a:p>
-          <a:p>
-            <a:pPr marL="285750" indent="-285750">
-              <a:buClr>
-                <a:schemeClr val="bg1"/>
-              </a:buClr>
-              <a:buFont typeface="Wingdings" panose="05000000000000000000" pitchFamily="2" charset="2"/>
-              <a:buChar char="v"/>
-            </a:pPr>
-            <a:r>
-              <a:rPr lang="en-US" sz="2000" dirty="0">
-                <a:solidFill>
-                  <a:schemeClr val="bg1"/>
-                </a:solidFill>
-                <a:latin typeface="Bookman Old Style" panose="02050604050505020204" pitchFamily="18" charset="0"/>
-              </a:rPr>
-              <a:t>Data Validation: Verified total order counts, total sales, and category totals to ensure data consistency.</a:t>
-            </a:r>
-          </a:p>
-          <a:p>
-            <a:pPr>
-              <a:buClr>
-                <a:schemeClr val="bg1"/>
-              </a:buClr>
-            </a:pPr>
-            <a:endParaRPr lang="en-US" sz="2000" dirty="0">
-              <a:solidFill>
-                <a:schemeClr val="bg1"/>
-              </a:solidFill>
-              <a:latin typeface="Bookman Old Style" panose="02050604050505020204" pitchFamily="18" charset="0"/>
-            </a:endParaRPr>
-          </a:p>
-          <a:p>
             <a:pPr marL="342900" indent="-342900">
               <a:buClr>
                 <a:schemeClr val="accent6"/>
@@ -4287,7 +6082,7 @@
                 </a:solidFill>
                 <a:latin typeface="Bookman Old Style" panose="02050604050505020204" pitchFamily="18" charset="0"/>
               </a:rPr>
-              <a:t>All transformations were performed within Power Query Editor before loading data into Power BI for reporting.</a:t>
+              <a:t>These findings laid the foundation for creating meaningful and insight-driven Power BI dashboards.</a:t>
             </a:r>
             <a:endParaRPr lang="en-IN" sz="2000" dirty="0">
               <a:solidFill>
@@ -4380,7 +6175,7 @@
 </p:sld>
 </file>
 
-<file path=ppt/slides/slide13.xml><?xml version="1.0" encoding="utf-8"?>
+<file path=ppt/slides/slide16.xml><?xml version="1.0" encoding="utf-8"?>
 <p:sld xmlns:a="http://schemas.openxmlformats.org/drawingml/2006/main" xmlns:r="http://schemas.openxmlformats.org/officeDocument/2006/relationships" xmlns:p="http://schemas.openxmlformats.org/presentationml/2006/main">
   <p:cSld>
     <p:spTree>
@@ -4388,7 +6183,7 @@
         <p:cNvPr id="1" name="">
           <a:extLst>
             <a:ext uri="{FF2B5EF4-FFF2-40B4-BE49-F238E27FC236}">
-              <a16:creationId xmlns:a16="http://schemas.microsoft.com/office/drawing/2014/main" id="{F2D74E86-DBDB-127A-0BCE-B036AED9E85A}"/>
+              <a16:creationId xmlns:a16="http://schemas.microsoft.com/office/drawing/2014/main" id="{0D7178A5-3354-C6C9-19A9-E2F6A86E2CBF}"/>
             </a:ext>
           </a:extLst>
         </p:cNvPr>
@@ -4405,10 +6200,10 @@
       </p:grpSpPr>
       <p:pic>
         <p:nvPicPr>
-          <p:cNvPr id="4" name="Picture 3">
-            <a:extLst>
-              <a:ext uri="{FF2B5EF4-FFF2-40B4-BE49-F238E27FC236}">
-                <a16:creationId xmlns:a16="http://schemas.microsoft.com/office/drawing/2014/main" id="{72D27382-C293-AF6B-97F1-7C9E4FFBED6C}"/>
+          <p:cNvPr id="3" name="Picture 2">
+            <a:extLst>
+              <a:ext uri="{FF2B5EF4-FFF2-40B4-BE49-F238E27FC236}">
+                <a16:creationId xmlns:a16="http://schemas.microsoft.com/office/drawing/2014/main" id="{E32FD868-0538-E569-19D9-44E4F63695A7}"/>
               </a:ext>
             </a:extLst>
           </p:cNvPr>
@@ -4437,20 +6232,86 @@
           <a:prstGeom prst="rect">
             <a:avLst/>
           </a:prstGeom>
-          <a:ln>
-            <a:noFill/>
-          </a:ln>
-          <a:effectLst>
-            <a:softEdge rad="112500"/>
-          </a:effectLst>
+        </p:spPr>
+      </p:pic>
+    </p:spTree>
+    <p:extLst>
+      <p:ext uri="{BB962C8B-B14F-4D97-AF65-F5344CB8AC3E}">
+        <p14:creationId xmlns:p14="http://schemas.microsoft.com/office/powerpoint/2010/main" val="3930331853"/>
+      </p:ext>
+    </p:extLst>
+  </p:cSld>
+  <p:clrMapOvr>
+    <a:masterClrMapping/>
+  </p:clrMapOvr>
+</p:sld>
+</file>
+
+<file path=ppt/slides/slide17.xml><?xml version="1.0" encoding="utf-8"?>
+<p:sld xmlns:a="http://schemas.openxmlformats.org/drawingml/2006/main" xmlns:r="http://schemas.openxmlformats.org/officeDocument/2006/relationships" xmlns:p="http://schemas.openxmlformats.org/presentationml/2006/main">
+  <p:cSld>
+    <p:spTree>
+      <p:nvGrpSpPr>
+        <p:cNvPr id="1" name="">
+          <a:extLst>
+            <a:ext uri="{FF2B5EF4-FFF2-40B4-BE49-F238E27FC236}">
+              <a16:creationId xmlns:a16="http://schemas.microsoft.com/office/drawing/2014/main" id="{6AFB7336-B8EC-0FEC-C582-4102CBC4719B}"/>
+            </a:ext>
+          </a:extLst>
+        </p:cNvPr>
+        <p:cNvGrpSpPr/>
+        <p:nvPr/>
+      </p:nvGrpSpPr>
+      <p:grpSpPr>
+        <a:xfrm>
+          <a:off x="0" y="0"/>
+          <a:ext cx="0" cy="0"/>
+          <a:chOff x="0" y="0"/>
+          <a:chExt cx="0" cy="0"/>
+        </a:xfrm>
+      </p:grpSpPr>
+      <p:pic>
+        <p:nvPicPr>
+          <p:cNvPr id="3" name="Picture 2">
+            <a:extLst>
+              <a:ext uri="{FF2B5EF4-FFF2-40B4-BE49-F238E27FC236}">
+                <a16:creationId xmlns:a16="http://schemas.microsoft.com/office/drawing/2014/main" id="{2AB8E0D5-7B93-9963-C55F-30E1129E1E6C}"/>
+              </a:ext>
+            </a:extLst>
+          </p:cNvPr>
+          <p:cNvPicPr>
+            <a:picLocks noChangeAspect="1"/>
+          </p:cNvPicPr>
+          <p:nvPr/>
+        </p:nvPicPr>
+        <p:blipFill>
+          <a:blip r:embed="rId2">
+            <a:extLst>
+              <a:ext uri="{28A0092B-C50C-407E-A947-70E740481C1C}">
+                <a14:useLocalDpi xmlns:a14="http://schemas.microsoft.com/office/drawing/2010/main" val="0"/>
+              </a:ext>
+            </a:extLst>
+          </a:blip>
+          <a:stretch>
+            <a:fillRect/>
+          </a:stretch>
+        </p:blipFill>
+        <p:spPr>
+          <a:xfrm>
+            <a:off x="0" y="0"/>
+            <a:ext cx="12192000" cy="6858000"/>
+          </a:xfrm>
+          <a:prstGeom prst="rect">
+            <a:avLst/>
+          </a:prstGeom>
         </p:spPr>
       </p:pic>
       <p:sp>
         <p:nvSpPr>
-          <p:cNvPr id="5" name="TextBox 4">
-            <a:extLst>
-              <a:ext uri="{FF2B5EF4-FFF2-40B4-BE49-F238E27FC236}">
-                <a16:creationId xmlns:a16="http://schemas.microsoft.com/office/drawing/2014/main" id="{3D3BB38B-68D9-AAF3-6DBC-5454B031426F}"/>
+          <p:cNvPr id="2" name="TextBox 1">
+            <a:extLst>
+              <a:ext uri="{FF2B5EF4-FFF2-40B4-BE49-F238E27FC236}">
+                <a16:creationId xmlns:a16="http://schemas.microsoft.com/office/drawing/2014/main" id="{D5933D58-6360-F66B-A3B3-A6F2B7E2BD23}"/>
               </a:ext>
             </a:extLst>
           </p:cNvPr>
@@ -4478,19 +6339,18 @@
                 <a:solidFill>
                   <a:schemeClr val="bg1"/>
                 </a:solidFill>
-                <a:latin typeface="Bookman Old Style" panose="02050604050505020204" pitchFamily="18" charset="0"/>
-              </a:rPr>
-              <a:t>Data Cleaning &amp; Transformation</a:t>
+              </a:rPr>
+              <a:t>Dashboard Design &amp; Visualization</a:t>
             </a:r>
           </a:p>
         </p:txBody>
       </p:sp>
       <p:sp>
         <p:nvSpPr>
-          <p:cNvPr id="7" name="Flowchart: Connector 6">
-            <a:extLst>
-              <a:ext uri="{FF2B5EF4-FFF2-40B4-BE49-F238E27FC236}">
-                <a16:creationId xmlns:a16="http://schemas.microsoft.com/office/drawing/2014/main" id="{2780D173-A3D4-9BAF-8B9F-36656E12F418}"/>
+          <p:cNvPr id="4" name="Flowchart: Connector 3">
+            <a:extLst>
+              <a:ext uri="{FF2B5EF4-FFF2-40B4-BE49-F238E27FC236}">
+                <a16:creationId xmlns:a16="http://schemas.microsoft.com/office/drawing/2014/main" id="{63B5D596-1F52-6A34-9D12-CE45CEECF4C2}"/>
               </a:ext>
             </a:extLst>
           </p:cNvPr>
@@ -4547,64 +6407,15 @@
                 </a:effectLst>
                 <a:latin typeface="Bookman Old Style" panose="02050604050505020204" pitchFamily="18" charset="0"/>
               </a:rPr>
-              <a:t>03</a:t>
+              <a:t>04</a:t>
             </a:r>
           </a:p>
         </p:txBody>
       </p:sp>
-      <p:pic>
-        <p:nvPicPr>
-          <p:cNvPr id="11" name="Picture 10">
-            <a:extLst>
-              <a:ext uri="{FF2B5EF4-FFF2-40B4-BE49-F238E27FC236}">
-                <a16:creationId xmlns:a16="http://schemas.microsoft.com/office/drawing/2014/main" id="{2C8161A4-DC5E-14EA-69C5-80ACA57E7EB0}"/>
-              </a:ext>
-            </a:extLst>
-          </p:cNvPr>
-          <p:cNvPicPr>
-            <a:picLocks noChangeAspect="1"/>
-          </p:cNvPicPr>
-          <p:nvPr/>
-        </p:nvPicPr>
-        <p:blipFill>
-          <a:blip r:embed="rId3">
-            <a:extLst>
-              <a:ext uri="{28A0092B-C50C-407E-A947-70E740481C1C}">
-                <a14:useLocalDpi xmlns:a14="http://schemas.microsoft.com/office/drawing/2010/main" val="0"/>
-              </a:ext>
-            </a:extLst>
-          </a:blip>
-          <a:stretch>
-            <a:fillRect/>
-          </a:stretch>
-        </p:blipFill>
-        <p:spPr>
-          <a:xfrm>
-            <a:off x="154567" y="1425960"/>
-            <a:ext cx="7397947" cy="5230872"/>
-          </a:xfrm>
-          <a:prstGeom prst="rect">
-            <a:avLst/>
-          </a:prstGeom>
-          <a:effectLst>
-            <a:glow rad="101600">
-              <a:schemeClr val="accent3">
-                <a:satMod val="175000"/>
-                <a:alpha val="40000"/>
-              </a:schemeClr>
-            </a:glow>
-            <a:outerShdw blurRad="76200" dir="18900000" sy="23000" kx="-1200000" algn="bl" rotWithShape="0">
-              <a:prstClr val="black">
-                <a:alpha val="20000"/>
-              </a:prstClr>
-            </a:outerShdw>
-          </a:effectLst>
-        </p:spPr>
-      </p:pic>
     </p:spTree>
     <p:extLst>
       <p:ext uri="{BB962C8B-B14F-4D97-AF65-F5344CB8AC3E}">
-        <p14:creationId xmlns:p14="http://schemas.microsoft.com/office/powerpoint/2010/main" val="3064719254"/>
+        <p14:creationId xmlns:p14="http://schemas.microsoft.com/office/powerpoint/2010/main" val="3157404389"/>
       </p:ext>
     </p:extLst>
   </p:cSld>
@@ -4614,12 +6425,18 @@
 </p:sld>
 </file>
 
-<file path=ppt/slides/slide14.xml><?xml version="1.0" encoding="utf-8"?>
+<file path=ppt/slides/slide18.xml><?xml version="1.0" encoding="utf-8"?>
 <p:sld xmlns:a="http://schemas.openxmlformats.org/drawingml/2006/main" xmlns:r="http://schemas.openxmlformats.org/officeDocument/2006/relationships" xmlns:p="http://schemas.openxmlformats.org/presentationml/2006/main">
   <p:cSld>
     <p:spTree>
       <p:nvGrpSpPr>
-        <p:cNvPr id="1" name=""/>
+        <p:cNvPr id="1" name="">
+          <a:extLst>
+            <a:ext uri="{FF2B5EF4-FFF2-40B4-BE49-F238E27FC236}">
+              <a16:creationId xmlns:a16="http://schemas.microsoft.com/office/drawing/2014/main" id="{3D8FC0AB-144D-BA5A-E91C-897BCC1E107B}"/>
+            </a:ext>
+          </a:extLst>
+        </p:cNvPr>
         <p:cNvGrpSpPr/>
         <p:nvPr/>
       </p:nvGrpSpPr>
@@ -4636,7 +6453,7 @@
           <p:cNvPr id="3" name="Picture 2">
             <a:extLst>
               <a:ext uri="{FF2B5EF4-FFF2-40B4-BE49-F238E27FC236}">
-                <a16:creationId xmlns:a16="http://schemas.microsoft.com/office/drawing/2014/main" id="{79E2B8DF-5074-C0AA-0770-79D8A671192A}"/>
+                <a16:creationId xmlns:a16="http://schemas.microsoft.com/office/drawing/2014/main" id="{F28942E7-F9D5-E172-6FDA-B98CD4E60B65}"/>
               </a:ext>
             </a:extLst>
           </p:cNvPr>
@@ -4670,7 +6487,7 @@
     </p:spTree>
     <p:extLst>
       <p:ext uri="{BB962C8B-B14F-4D97-AF65-F5344CB8AC3E}">
-        <p14:creationId xmlns:p14="http://schemas.microsoft.com/office/powerpoint/2010/main" val="1624174513"/>
+        <p14:creationId xmlns:p14="http://schemas.microsoft.com/office/powerpoint/2010/main" val="3393959080"/>
       </p:ext>
     </p:extLst>
   </p:cSld>
@@ -4680,7 +6497,7 @@
 </p:sld>
 </file>
 
-<file path=ppt/slides/slide15.xml><?xml version="1.0" encoding="utf-8"?>
+<file path=ppt/slides/slide19.xml><?xml version="1.0" encoding="utf-8"?>
 <p:sld xmlns:a="http://schemas.openxmlformats.org/drawingml/2006/main" xmlns:r="http://schemas.openxmlformats.org/officeDocument/2006/relationships" xmlns:p="http://schemas.openxmlformats.org/presentationml/2006/main">
   <p:cSld>
     <p:spTree>
@@ -4688,7 +6505,7 @@
         <p:cNvPr id="1" name="">
           <a:extLst>
             <a:ext uri="{FF2B5EF4-FFF2-40B4-BE49-F238E27FC236}">
-              <a16:creationId xmlns:a16="http://schemas.microsoft.com/office/drawing/2014/main" id="{6AFB7336-B8EC-0FEC-C582-4102CBC4719B}"/>
+              <a16:creationId xmlns:a16="http://schemas.microsoft.com/office/drawing/2014/main" id="{9094FF13-A281-2D32-6962-A7D066308266}"/>
             </a:ext>
           </a:extLst>
         </p:cNvPr>
@@ -4708,7 +6525,7 @@
           <p:cNvPr id="3" name="Picture 2">
             <a:extLst>
               <a:ext uri="{FF2B5EF4-FFF2-40B4-BE49-F238E27FC236}">
-                <a16:creationId xmlns:a16="http://schemas.microsoft.com/office/drawing/2014/main" id="{2AB8E0D5-7B93-9963-C55F-30E1129E1E6C}"/>
+                <a16:creationId xmlns:a16="http://schemas.microsoft.com/office/drawing/2014/main" id="{41F61AB8-4F67-AA2F-E9A2-FDAA0EA8039E}"/>
               </a:ext>
             </a:extLst>
           </p:cNvPr>
@@ -4744,7 +6561,7 @@
           <p:cNvPr id="2" name="TextBox 1">
             <a:extLst>
               <a:ext uri="{FF2B5EF4-FFF2-40B4-BE49-F238E27FC236}">
-                <a16:creationId xmlns:a16="http://schemas.microsoft.com/office/drawing/2014/main" id="{D5933D58-6360-F66B-A3B3-A6F2B7E2BD23}"/>
+                <a16:creationId xmlns:a16="http://schemas.microsoft.com/office/drawing/2014/main" id="{D8F10DCE-971B-BC1C-1DA8-B04641021FC1}"/>
               </a:ext>
             </a:extLst>
           </p:cNvPr>
@@ -4772,8 +6589,9 @@
                 <a:solidFill>
                   <a:schemeClr val="bg1"/>
                 </a:solidFill>
-              </a:rPr>
-              <a:t>Dashboard Design &amp; Visualization</a:t>
+                <a:latin typeface="Bookman Old Style" panose="02050604050505020204" pitchFamily="18" charset="0"/>
+              </a:rPr>
+              <a:t>Key Insights &amp; Findings</a:t>
             </a:r>
           </a:p>
         </p:txBody>
@@ -4783,7 +6601,7 @@
           <p:cNvPr id="4" name="Flowchart: Connector 3">
             <a:extLst>
               <a:ext uri="{FF2B5EF4-FFF2-40B4-BE49-F238E27FC236}">
-                <a16:creationId xmlns:a16="http://schemas.microsoft.com/office/drawing/2014/main" id="{63B5D596-1F52-6A34-9D12-CE45CEECF4C2}"/>
+                <a16:creationId xmlns:a16="http://schemas.microsoft.com/office/drawing/2014/main" id="{E9FC07DD-8E27-EBC5-2BC3-8F66E97BD75B}"/>
               </a:ext>
             </a:extLst>
           </p:cNvPr>
@@ -4840,7 +6658,7 @@
                 </a:effectLst>
                 <a:latin typeface="Bookman Old Style" panose="02050604050505020204" pitchFamily="18" charset="0"/>
               </a:rPr>
-              <a:t>04</a:t>
+              <a:t>05</a:t>
             </a:r>
           </a:p>
         </p:txBody>
@@ -4848,7 +6666,7 @@
     </p:spTree>
     <p:extLst>
       <p:ext uri="{BB962C8B-B14F-4D97-AF65-F5344CB8AC3E}">
-        <p14:creationId xmlns:p14="http://schemas.microsoft.com/office/powerpoint/2010/main" val="3157404389"/>
+        <p14:creationId xmlns:p14="http://schemas.microsoft.com/office/powerpoint/2010/main" val="101803682"/>
       </p:ext>
     </p:extLst>
   </p:cSld>
@@ -4858,7 +6676,285 @@
 </p:sld>
 </file>
 
-<file path=ppt/slides/slide16.xml><?xml version="1.0" encoding="utf-8"?>
+<file path=ppt/slides/slide2.xml><?xml version="1.0" encoding="utf-8"?>
+<p:sld xmlns:a="http://schemas.openxmlformats.org/drawingml/2006/main" xmlns:r="http://schemas.openxmlformats.org/officeDocument/2006/relationships" xmlns:p="http://schemas.openxmlformats.org/presentationml/2006/main">
+  <p:cSld>
+    <p:spTree>
+      <p:nvGrpSpPr>
+        <p:cNvPr id="1" name=""/>
+        <p:cNvGrpSpPr/>
+        <p:nvPr/>
+      </p:nvGrpSpPr>
+      <p:grpSpPr>
+        <a:xfrm>
+          <a:off x="0" y="0"/>
+          <a:ext cx="0" cy="0"/>
+          <a:chOff x="0" y="0"/>
+          <a:chExt cx="0" cy="0"/>
+        </a:xfrm>
+      </p:grpSpPr>
+      <p:pic>
+        <p:nvPicPr>
+          <p:cNvPr id="4" name="Picture 3">
+            <a:extLst>
+              <a:ext uri="{FF2B5EF4-FFF2-40B4-BE49-F238E27FC236}">
+                <a16:creationId xmlns:a16="http://schemas.microsoft.com/office/drawing/2014/main" id="{1B86986A-FBEE-87DB-FF12-E5EF9541EA24}"/>
+              </a:ext>
+            </a:extLst>
+          </p:cNvPr>
+          <p:cNvPicPr>
+            <a:picLocks noChangeAspect="1"/>
+          </p:cNvPicPr>
+          <p:nvPr/>
+        </p:nvPicPr>
+        <p:blipFill>
+          <a:blip r:embed="rId2">
+            <a:extLst>
+              <a:ext uri="{28A0092B-C50C-407E-A947-70E740481C1C}">
+                <a14:useLocalDpi xmlns:a14="http://schemas.microsoft.com/office/drawing/2010/main" val="0"/>
+              </a:ext>
+            </a:extLst>
+          </a:blip>
+          <a:stretch>
+            <a:fillRect/>
+          </a:stretch>
+        </p:blipFill>
+        <p:spPr>
+          <a:xfrm>
+            <a:off x="0" y="0"/>
+            <a:ext cx="12192000" cy="6858000"/>
+          </a:xfrm>
+          <a:prstGeom prst="rect">
+            <a:avLst/>
+          </a:prstGeom>
+          <a:ln>
+            <a:noFill/>
+          </a:ln>
+          <a:effectLst>
+            <a:softEdge rad="112500"/>
+          </a:effectLst>
+        </p:spPr>
+      </p:pic>
+      <p:sp>
+        <p:nvSpPr>
+          <p:cNvPr id="5" name="TextBox 4">
+            <a:extLst>
+              <a:ext uri="{FF2B5EF4-FFF2-40B4-BE49-F238E27FC236}">
+                <a16:creationId xmlns:a16="http://schemas.microsoft.com/office/drawing/2014/main" id="{9EE76205-8F05-395F-A74B-C70F58E444C7}"/>
+              </a:ext>
+            </a:extLst>
+          </p:cNvPr>
+          <p:cNvSpPr txBox="1"/>
+          <p:nvPr/>
+        </p:nvSpPr>
+        <p:spPr>
+          <a:xfrm>
+            <a:off x="3706749" y="118872"/>
+            <a:ext cx="4778502" cy="1938992"/>
+          </a:xfrm>
+          <a:prstGeom prst="rect">
+            <a:avLst/>
+          </a:prstGeom>
+          <a:noFill/>
+        </p:spPr>
+        <p:txBody>
+          <a:bodyPr wrap="square" rtlCol="0">
+            <a:spAutoFit/>
+          </a:bodyPr>
+          <a:lstStyle/>
+          <a:p>
+            <a:pPr algn="ctr"/>
+            <a:r>
+              <a:rPr lang="en-IN" sz="6000" dirty="0">
+                <a:solidFill>
+                  <a:schemeClr val="bg1"/>
+                </a:solidFill>
+                <a:latin typeface="Book Antiqua" panose="02040602050305030304" pitchFamily="18" charset="0"/>
+              </a:rPr>
+              <a:t>Project</a:t>
+            </a:r>
+          </a:p>
+          <a:p>
+            <a:pPr algn="ctr"/>
+            <a:r>
+              <a:rPr lang="en-IN" sz="6000" dirty="0">
+                <a:solidFill>
+                  <a:schemeClr val="accent4"/>
+                </a:solidFill>
+                <a:latin typeface="Book Antiqua" panose="02040602050305030304" pitchFamily="18" charset="0"/>
+              </a:rPr>
+              <a:t>Introduction</a:t>
+            </a:r>
+          </a:p>
+        </p:txBody>
+      </p:sp>
+      <p:sp>
+        <p:nvSpPr>
+          <p:cNvPr id="7" name="TextBox 6">
+            <a:extLst>
+              <a:ext uri="{FF2B5EF4-FFF2-40B4-BE49-F238E27FC236}">
+                <a16:creationId xmlns:a16="http://schemas.microsoft.com/office/drawing/2014/main" id="{A277F230-8C14-89D3-748C-E57B9B8E29AF}"/>
+              </a:ext>
+            </a:extLst>
+          </p:cNvPr>
+          <p:cNvSpPr txBox="1"/>
+          <p:nvPr/>
+        </p:nvSpPr>
+        <p:spPr>
+          <a:xfrm>
+            <a:off x="1879854" y="2252311"/>
+            <a:ext cx="8432292" cy="2554545"/>
+          </a:xfrm>
+          <a:prstGeom prst="rect">
+            <a:avLst/>
+          </a:prstGeom>
+          <a:noFill/>
+        </p:spPr>
+        <p:txBody>
+          <a:bodyPr wrap="square">
+            <a:spAutoFit/>
+          </a:bodyPr>
+          <a:lstStyle/>
+          <a:p>
+            <a:pPr algn="ctr"/>
+            <a:r>
+              <a:rPr lang="en-US" sz="2000" dirty="0">
+                <a:solidFill>
+                  <a:schemeClr val="bg1"/>
+                </a:solidFill>
+                <a:latin typeface="Bookman Old Style" panose="02050604050505020204" pitchFamily="18" charset="0"/>
+              </a:rPr>
+              <a:t>The </a:t>
+            </a:r>
+            <a:r>
+              <a:rPr lang="en-US" sz="2000" b="1" dirty="0">
+                <a:solidFill>
+                  <a:schemeClr val="bg1"/>
+                </a:solidFill>
+                <a:latin typeface="Bookman Old Style" panose="02050604050505020204" pitchFamily="18" charset="0"/>
+              </a:rPr>
+              <a:t>Amazon Sales Dashboard</a:t>
+            </a:r>
+            <a:r>
+              <a:rPr lang="en-US" sz="2000" dirty="0">
+                <a:solidFill>
+                  <a:schemeClr val="bg1"/>
+                </a:solidFill>
+                <a:latin typeface="Bookman Old Style" panose="02050604050505020204" pitchFamily="18" charset="0"/>
+              </a:rPr>
+              <a:t> is an interactive Power BI project designed to analyze and visualize e-commerce sales data.</a:t>
+            </a:r>
+            <a:br>
+              <a:rPr lang="en-US" sz="2000" dirty="0">
+                <a:solidFill>
+                  <a:schemeClr val="bg1"/>
+                </a:solidFill>
+                <a:latin typeface="Bookman Old Style" panose="02050604050505020204" pitchFamily="18" charset="0"/>
+              </a:rPr>
+            </a:br>
+            <a:r>
+              <a:rPr lang="en-US" sz="2000" dirty="0">
+                <a:solidFill>
+                  <a:schemeClr val="bg1"/>
+                </a:solidFill>
+                <a:latin typeface="Bookman Old Style" panose="02050604050505020204" pitchFamily="18" charset="0"/>
+              </a:rPr>
+              <a:t>It helps businesses monitor key metrics like sales, orders, quantity, fulfilment, and promotions — all in one place.</a:t>
+            </a:r>
+            <a:br>
+              <a:rPr lang="en-US" sz="2000" dirty="0">
+                <a:solidFill>
+                  <a:schemeClr val="bg1"/>
+                </a:solidFill>
+                <a:latin typeface="Bookman Old Style" panose="02050604050505020204" pitchFamily="18" charset="0"/>
+              </a:rPr>
+            </a:br>
+            <a:r>
+              <a:rPr lang="en-US" sz="2000" dirty="0">
+                <a:solidFill>
+                  <a:schemeClr val="bg1"/>
+                </a:solidFill>
+                <a:latin typeface="Bookman Old Style" panose="02050604050505020204" pitchFamily="18" charset="0"/>
+              </a:rPr>
+              <a:t>With real-time insights, this dashboard supports </a:t>
+            </a:r>
+            <a:r>
+              <a:rPr lang="en-US" sz="2000" b="1" dirty="0">
+                <a:solidFill>
+                  <a:schemeClr val="bg1"/>
+                </a:solidFill>
+                <a:latin typeface="Bookman Old Style" panose="02050604050505020204" pitchFamily="18" charset="0"/>
+              </a:rPr>
+              <a:t>data-driven decision-making</a:t>
+            </a:r>
+            <a:r>
+              <a:rPr lang="en-US" sz="2000" dirty="0">
+                <a:solidFill>
+                  <a:schemeClr val="bg1"/>
+                </a:solidFill>
+                <a:latin typeface="Bookman Old Style" panose="02050604050505020204" pitchFamily="18" charset="0"/>
+              </a:rPr>
+              <a:t>, improves </a:t>
+            </a:r>
+            <a:r>
+              <a:rPr lang="en-US" sz="2000" b="1" dirty="0">
+                <a:solidFill>
+                  <a:schemeClr val="bg1"/>
+                </a:solidFill>
+                <a:latin typeface="Bookman Old Style" panose="02050604050505020204" pitchFamily="18" charset="0"/>
+              </a:rPr>
+              <a:t>operational efficiency</a:t>
+            </a:r>
+            <a:r>
+              <a:rPr lang="en-US" sz="2000" dirty="0">
+                <a:solidFill>
+                  <a:schemeClr val="bg1"/>
+                </a:solidFill>
+                <a:latin typeface="Bookman Old Style" panose="02050604050505020204" pitchFamily="18" charset="0"/>
+              </a:rPr>
+              <a:t>, and helps identify </a:t>
+            </a:r>
+            <a:r>
+              <a:rPr lang="en-US" sz="2000" b="1" dirty="0">
+                <a:solidFill>
+                  <a:schemeClr val="bg1"/>
+                </a:solidFill>
+                <a:latin typeface="Bookman Old Style" panose="02050604050505020204" pitchFamily="18" charset="0"/>
+              </a:rPr>
+              <a:t>growth opportunities</a:t>
+            </a:r>
+            <a:r>
+              <a:rPr lang="en-US" sz="2000" dirty="0">
+                <a:solidFill>
+                  <a:schemeClr val="bg1"/>
+                </a:solidFill>
+                <a:latin typeface="Bookman Old Style" panose="02050604050505020204" pitchFamily="18" charset="0"/>
+              </a:rPr>
+              <a:t> across regions and product categories.</a:t>
+            </a:r>
+            <a:endParaRPr lang="en-IN" sz="2000" dirty="0">
+              <a:solidFill>
+                <a:schemeClr val="bg1"/>
+              </a:solidFill>
+              <a:latin typeface="Bookman Old Style" panose="02050604050505020204" pitchFamily="18" charset="0"/>
+            </a:endParaRPr>
+          </a:p>
+        </p:txBody>
+      </p:sp>
+    </p:spTree>
+    <p:extLst>
+      <p:ext uri="{BB962C8B-B14F-4D97-AF65-F5344CB8AC3E}">
+        <p14:creationId xmlns:p14="http://schemas.microsoft.com/office/powerpoint/2010/main" val="177487879"/>
+      </p:ext>
+    </p:extLst>
+  </p:cSld>
+  <p:clrMapOvr>
+    <a:masterClrMapping/>
+  </p:clrMapOvr>
+</p:sld>
+</file>
+
+<file path=ppt/slides/slide20.xml><?xml version="1.0" encoding="utf-8"?>
 <p:sld xmlns:a="http://schemas.openxmlformats.org/drawingml/2006/main" xmlns:r="http://schemas.openxmlformats.org/officeDocument/2006/relationships" xmlns:p="http://schemas.openxmlformats.org/presentationml/2006/main">
   <p:cSld>
     <p:spTree>
@@ -4866,7 +6962,7 @@
         <p:cNvPr id="1" name="">
           <a:extLst>
             <a:ext uri="{FF2B5EF4-FFF2-40B4-BE49-F238E27FC236}">
-              <a16:creationId xmlns:a16="http://schemas.microsoft.com/office/drawing/2014/main" id="{3D8FC0AB-144D-BA5A-E91C-897BCC1E107B}"/>
+              <a16:creationId xmlns:a16="http://schemas.microsoft.com/office/drawing/2014/main" id="{A8D76B65-3565-5843-5FAA-4DD0549C075A}"/>
             </a:ext>
           </a:extLst>
         </p:cNvPr>
@@ -4886,7 +6982,7 @@
           <p:cNvPr id="3" name="Picture 2">
             <a:extLst>
               <a:ext uri="{FF2B5EF4-FFF2-40B4-BE49-F238E27FC236}">
-                <a16:creationId xmlns:a16="http://schemas.microsoft.com/office/drawing/2014/main" id="{F28942E7-F9D5-E172-6FDA-B98CD4E60B65}"/>
+                <a16:creationId xmlns:a16="http://schemas.microsoft.com/office/drawing/2014/main" id="{5B12D6E3-20BE-3532-99A4-F76EBD8893F4}"/>
               </a:ext>
             </a:extLst>
           </p:cNvPr>
@@ -4920,7 +7016,7 @@
     </p:spTree>
     <p:extLst>
       <p:ext uri="{BB962C8B-B14F-4D97-AF65-F5344CB8AC3E}">
-        <p14:creationId xmlns:p14="http://schemas.microsoft.com/office/powerpoint/2010/main" val="3393959080"/>
+        <p14:creationId xmlns:p14="http://schemas.microsoft.com/office/powerpoint/2010/main" val="317802434"/>
       </p:ext>
     </p:extLst>
   </p:cSld>
@@ -4930,7 +7026,7 @@
 </p:sld>
 </file>
 
-<file path=ppt/slides/slide17.xml><?xml version="1.0" encoding="utf-8"?>
+<file path=ppt/slides/slide21.xml><?xml version="1.0" encoding="utf-8"?>
 <p:sld xmlns:a="http://schemas.openxmlformats.org/drawingml/2006/main" xmlns:r="http://schemas.openxmlformats.org/officeDocument/2006/relationships" xmlns:p="http://schemas.openxmlformats.org/presentationml/2006/main">
   <p:cSld>
     <p:spTree>
@@ -4938,7 +7034,7 @@
         <p:cNvPr id="1" name="">
           <a:extLst>
             <a:ext uri="{FF2B5EF4-FFF2-40B4-BE49-F238E27FC236}">
-              <a16:creationId xmlns:a16="http://schemas.microsoft.com/office/drawing/2014/main" id="{9094FF13-A281-2D32-6962-A7D066308266}"/>
+              <a16:creationId xmlns:a16="http://schemas.microsoft.com/office/drawing/2014/main" id="{FBF880B8-3D42-B523-C0F5-E4DA1A561094}"/>
             </a:ext>
           </a:extLst>
         </p:cNvPr>
@@ -4958,7 +7054,7 @@
           <p:cNvPr id="3" name="Picture 2">
             <a:extLst>
               <a:ext uri="{FF2B5EF4-FFF2-40B4-BE49-F238E27FC236}">
-                <a16:creationId xmlns:a16="http://schemas.microsoft.com/office/drawing/2014/main" id="{41F61AB8-4F67-AA2F-E9A2-FDAA0EA8039E}"/>
+                <a16:creationId xmlns:a16="http://schemas.microsoft.com/office/drawing/2014/main" id="{D70E622A-1412-CB91-236F-6FB894189718}"/>
               </a:ext>
             </a:extLst>
           </p:cNvPr>
@@ -4994,7 +7090,7 @@
           <p:cNvPr id="2" name="TextBox 1">
             <a:extLst>
               <a:ext uri="{FF2B5EF4-FFF2-40B4-BE49-F238E27FC236}">
-                <a16:creationId xmlns:a16="http://schemas.microsoft.com/office/drawing/2014/main" id="{D8F10DCE-971B-BC1C-1DA8-B04641021FC1}"/>
+                <a16:creationId xmlns:a16="http://schemas.microsoft.com/office/drawing/2014/main" id="{674C2F60-C38A-EAD9-54CA-BA822FEE44BA}"/>
               </a:ext>
             </a:extLst>
           </p:cNvPr>
@@ -5022,9 +7118,8 @@
                 <a:solidFill>
                   <a:schemeClr val="bg1"/>
                 </a:solidFill>
-                <a:latin typeface="Bookman Old Style" panose="02050604050505020204" pitchFamily="18" charset="0"/>
-              </a:rPr>
-              <a:t>Key Insights &amp; Findings</a:t>
+              </a:rPr>
+              <a:t>Tools &amp; Technologies Used</a:t>
             </a:r>
           </a:p>
         </p:txBody>
@@ -5034,7 +7129,7 @@
           <p:cNvPr id="4" name="Flowchart: Connector 3">
             <a:extLst>
               <a:ext uri="{FF2B5EF4-FFF2-40B4-BE49-F238E27FC236}">
-                <a16:creationId xmlns:a16="http://schemas.microsoft.com/office/drawing/2014/main" id="{E9FC07DD-8E27-EBC5-2BC3-8F66E97BD75B}"/>
+                <a16:creationId xmlns:a16="http://schemas.microsoft.com/office/drawing/2014/main" id="{B9EB6B21-BE5D-EC3D-495B-4124D5D990EF}"/>
               </a:ext>
             </a:extLst>
           </p:cNvPr>
@@ -5091,256 +7186,6 @@
                 </a:effectLst>
                 <a:latin typeface="Bookman Old Style" panose="02050604050505020204" pitchFamily="18" charset="0"/>
               </a:rPr>
-              <a:t>05</a:t>
-            </a:r>
-          </a:p>
-        </p:txBody>
-      </p:sp>
-    </p:spTree>
-    <p:extLst>
-      <p:ext uri="{BB962C8B-B14F-4D97-AF65-F5344CB8AC3E}">
-        <p14:creationId xmlns:p14="http://schemas.microsoft.com/office/powerpoint/2010/main" val="101803682"/>
-      </p:ext>
-    </p:extLst>
-  </p:cSld>
-  <p:clrMapOvr>
-    <a:masterClrMapping/>
-  </p:clrMapOvr>
-</p:sld>
-</file>
-
-<file path=ppt/slides/slide18.xml><?xml version="1.0" encoding="utf-8"?>
-<p:sld xmlns:a="http://schemas.openxmlformats.org/drawingml/2006/main" xmlns:r="http://schemas.openxmlformats.org/officeDocument/2006/relationships" xmlns:p="http://schemas.openxmlformats.org/presentationml/2006/main">
-  <p:cSld>
-    <p:spTree>
-      <p:nvGrpSpPr>
-        <p:cNvPr id="1" name="">
-          <a:extLst>
-            <a:ext uri="{FF2B5EF4-FFF2-40B4-BE49-F238E27FC236}">
-              <a16:creationId xmlns:a16="http://schemas.microsoft.com/office/drawing/2014/main" id="{A8D76B65-3565-5843-5FAA-4DD0549C075A}"/>
-            </a:ext>
-          </a:extLst>
-        </p:cNvPr>
-        <p:cNvGrpSpPr/>
-        <p:nvPr/>
-      </p:nvGrpSpPr>
-      <p:grpSpPr>
-        <a:xfrm>
-          <a:off x="0" y="0"/>
-          <a:ext cx="0" cy="0"/>
-          <a:chOff x="0" y="0"/>
-          <a:chExt cx="0" cy="0"/>
-        </a:xfrm>
-      </p:grpSpPr>
-      <p:pic>
-        <p:nvPicPr>
-          <p:cNvPr id="3" name="Picture 2">
-            <a:extLst>
-              <a:ext uri="{FF2B5EF4-FFF2-40B4-BE49-F238E27FC236}">
-                <a16:creationId xmlns:a16="http://schemas.microsoft.com/office/drawing/2014/main" id="{5B12D6E3-20BE-3532-99A4-F76EBD8893F4}"/>
-              </a:ext>
-            </a:extLst>
-          </p:cNvPr>
-          <p:cNvPicPr>
-            <a:picLocks noChangeAspect="1"/>
-          </p:cNvPicPr>
-          <p:nvPr/>
-        </p:nvPicPr>
-        <p:blipFill>
-          <a:blip r:embed="rId2">
-            <a:extLst>
-              <a:ext uri="{28A0092B-C50C-407E-A947-70E740481C1C}">
-                <a14:useLocalDpi xmlns:a14="http://schemas.microsoft.com/office/drawing/2010/main" val="0"/>
-              </a:ext>
-            </a:extLst>
-          </a:blip>
-          <a:stretch>
-            <a:fillRect/>
-          </a:stretch>
-        </p:blipFill>
-        <p:spPr>
-          <a:xfrm>
-            <a:off x="0" y="0"/>
-            <a:ext cx="12192000" cy="6858000"/>
-          </a:xfrm>
-          <a:prstGeom prst="rect">
-            <a:avLst/>
-          </a:prstGeom>
-        </p:spPr>
-      </p:pic>
-    </p:spTree>
-    <p:extLst>
-      <p:ext uri="{BB962C8B-B14F-4D97-AF65-F5344CB8AC3E}">
-        <p14:creationId xmlns:p14="http://schemas.microsoft.com/office/powerpoint/2010/main" val="317802434"/>
-      </p:ext>
-    </p:extLst>
-  </p:cSld>
-  <p:clrMapOvr>
-    <a:masterClrMapping/>
-  </p:clrMapOvr>
-</p:sld>
-</file>
-
-<file path=ppt/slides/slide19.xml><?xml version="1.0" encoding="utf-8"?>
-<p:sld xmlns:a="http://schemas.openxmlformats.org/drawingml/2006/main" xmlns:r="http://schemas.openxmlformats.org/officeDocument/2006/relationships" xmlns:p="http://schemas.openxmlformats.org/presentationml/2006/main">
-  <p:cSld>
-    <p:spTree>
-      <p:nvGrpSpPr>
-        <p:cNvPr id="1" name="">
-          <a:extLst>
-            <a:ext uri="{FF2B5EF4-FFF2-40B4-BE49-F238E27FC236}">
-              <a16:creationId xmlns:a16="http://schemas.microsoft.com/office/drawing/2014/main" id="{FBF880B8-3D42-B523-C0F5-E4DA1A561094}"/>
-            </a:ext>
-          </a:extLst>
-        </p:cNvPr>
-        <p:cNvGrpSpPr/>
-        <p:nvPr/>
-      </p:nvGrpSpPr>
-      <p:grpSpPr>
-        <a:xfrm>
-          <a:off x="0" y="0"/>
-          <a:ext cx="0" cy="0"/>
-          <a:chOff x="0" y="0"/>
-          <a:chExt cx="0" cy="0"/>
-        </a:xfrm>
-      </p:grpSpPr>
-      <p:pic>
-        <p:nvPicPr>
-          <p:cNvPr id="3" name="Picture 2">
-            <a:extLst>
-              <a:ext uri="{FF2B5EF4-FFF2-40B4-BE49-F238E27FC236}">
-                <a16:creationId xmlns:a16="http://schemas.microsoft.com/office/drawing/2014/main" id="{D70E622A-1412-CB91-236F-6FB894189718}"/>
-              </a:ext>
-            </a:extLst>
-          </p:cNvPr>
-          <p:cNvPicPr>
-            <a:picLocks noChangeAspect="1"/>
-          </p:cNvPicPr>
-          <p:nvPr/>
-        </p:nvPicPr>
-        <p:blipFill>
-          <a:blip r:embed="rId2">
-            <a:extLst>
-              <a:ext uri="{28A0092B-C50C-407E-A947-70E740481C1C}">
-                <a14:useLocalDpi xmlns:a14="http://schemas.microsoft.com/office/drawing/2010/main" val="0"/>
-              </a:ext>
-            </a:extLst>
-          </a:blip>
-          <a:stretch>
-            <a:fillRect/>
-          </a:stretch>
-        </p:blipFill>
-        <p:spPr>
-          <a:xfrm>
-            <a:off x="0" y="0"/>
-            <a:ext cx="12192000" cy="6858000"/>
-          </a:xfrm>
-          <a:prstGeom prst="rect">
-            <a:avLst/>
-          </a:prstGeom>
-        </p:spPr>
-      </p:pic>
-      <p:sp>
-        <p:nvSpPr>
-          <p:cNvPr id="2" name="TextBox 1">
-            <a:extLst>
-              <a:ext uri="{FF2B5EF4-FFF2-40B4-BE49-F238E27FC236}">
-                <a16:creationId xmlns:a16="http://schemas.microsoft.com/office/drawing/2014/main" id="{674C2F60-C38A-EAD9-54CA-BA822FEE44BA}"/>
-              </a:ext>
-            </a:extLst>
-          </p:cNvPr>
-          <p:cNvSpPr txBox="1"/>
-          <p:nvPr/>
-        </p:nvSpPr>
-        <p:spPr>
-          <a:xfrm>
-            <a:off x="5286447" y="2459504"/>
-            <a:ext cx="6619041" cy="1938992"/>
-          </a:xfrm>
-          <a:prstGeom prst="rect">
-            <a:avLst/>
-          </a:prstGeom>
-          <a:noFill/>
-        </p:spPr>
-        <p:txBody>
-          <a:bodyPr wrap="square" rtlCol="0">
-            <a:spAutoFit/>
-          </a:bodyPr>
-          <a:lstStyle/>
-          <a:p>
-            <a:r>
-              <a:rPr lang="en-IN" sz="6000" dirty="0">
-                <a:solidFill>
-                  <a:schemeClr val="bg1"/>
-                </a:solidFill>
-              </a:rPr>
-              <a:t>Tools &amp; Technologies Used</a:t>
-            </a:r>
-          </a:p>
-        </p:txBody>
-      </p:sp>
-      <p:sp>
-        <p:nvSpPr>
-          <p:cNvPr id="4" name="Flowchart: Connector 3">
-            <a:extLst>
-              <a:ext uri="{FF2B5EF4-FFF2-40B4-BE49-F238E27FC236}">
-                <a16:creationId xmlns:a16="http://schemas.microsoft.com/office/drawing/2014/main" id="{B9EB6B21-BE5D-EC3D-495B-4124D5D990EF}"/>
-              </a:ext>
-            </a:extLst>
-          </p:cNvPr>
-          <p:cNvSpPr/>
-          <p:nvPr/>
-        </p:nvSpPr>
-        <p:spPr>
-          <a:xfrm>
-            <a:off x="7777996" y="1224792"/>
-            <a:ext cx="1080000" cy="1080000"/>
-          </a:xfrm>
-          <a:prstGeom prst="flowChartConnector">
-            <a:avLst/>
-          </a:prstGeom>
-          <a:noFill/>
-          <a:ln>
-            <a:solidFill>
-              <a:schemeClr val="accent4"/>
-            </a:solidFill>
-          </a:ln>
-        </p:spPr>
-        <p:style>
-          <a:lnRef idx="2">
-            <a:schemeClr val="accent1">
-              <a:shade val="15000"/>
-            </a:schemeClr>
-          </a:lnRef>
-          <a:fillRef idx="1">
-            <a:schemeClr val="accent1"/>
-          </a:fillRef>
-          <a:effectRef idx="0">
-            <a:schemeClr val="accent1"/>
-          </a:effectRef>
-          <a:fontRef idx="minor">
-            <a:schemeClr val="lt1"/>
-          </a:fontRef>
-        </p:style>
-        <p:txBody>
-          <a:bodyPr rtlCol="0" anchor="ctr"/>
-          <a:lstStyle/>
-          <a:p>
-            <a:pPr algn="ctr"/>
-            <a:r>
-              <a:rPr lang="en-IN" sz="3600" dirty="0">
-                <a:solidFill>
-                  <a:schemeClr val="accent4"/>
-                </a:solidFill>
-                <a:effectLst>
-                  <a:outerShdw blurRad="50800" dist="38100" dir="2700000" algn="tl" rotWithShape="0">
-                    <a:prstClr val="black">
-                      <a:alpha val="40000"/>
-                    </a:prstClr>
-                  </a:outerShdw>
-                </a:effectLst>
-                <a:latin typeface="Bookman Old Style" panose="02050604050505020204" pitchFamily="18" charset="0"/>
-              </a:rPr>
               <a:t>06</a:t>
             </a:r>
           </a:p>
@@ -5359,285 +7204,7 @@
 </p:sld>
 </file>
 
-<file path=ppt/slides/slide2.xml><?xml version="1.0" encoding="utf-8"?>
-<p:sld xmlns:a="http://schemas.openxmlformats.org/drawingml/2006/main" xmlns:r="http://schemas.openxmlformats.org/officeDocument/2006/relationships" xmlns:p="http://schemas.openxmlformats.org/presentationml/2006/main">
-  <p:cSld>
-    <p:spTree>
-      <p:nvGrpSpPr>
-        <p:cNvPr id="1" name=""/>
-        <p:cNvGrpSpPr/>
-        <p:nvPr/>
-      </p:nvGrpSpPr>
-      <p:grpSpPr>
-        <a:xfrm>
-          <a:off x="0" y="0"/>
-          <a:ext cx="0" cy="0"/>
-          <a:chOff x="0" y="0"/>
-          <a:chExt cx="0" cy="0"/>
-        </a:xfrm>
-      </p:grpSpPr>
-      <p:pic>
-        <p:nvPicPr>
-          <p:cNvPr id="4" name="Picture 3">
-            <a:extLst>
-              <a:ext uri="{FF2B5EF4-FFF2-40B4-BE49-F238E27FC236}">
-                <a16:creationId xmlns:a16="http://schemas.microsoft.com/office/drawing/2014/main" id="{1B86986A-FBEE-87DB-FF12-E5EF9541EA24}"/>
-              </a:ext>
-            </a:extLst>
-          </p:cNvPr>
-          <p:cNvPicPr>
-            <a:picLocks noChangeAspect="1"/>
-          </p:cNvPicPr>
-          <p:nvPr/>
-        </p:nvPicPr>
-        <p:blipFill>
-          <a:blip r:embed="rId2">
-            <a:extLst>
-              <a:ext uri="{28A0092B-C50C-407E-A947-70E740481C1C}">
-                <a14:useLocalDpi xmlns:a14="http://schemas.microsoft.com/office/drawing/2010/main" val="0"/>
-              </a:ext>
-            </a:extLst>
-          </a:blip>
-          <a:stretch>
-            <a:fillRect/>
-          </a:stretch>
-        </p:blipFill>
-        <p:spPr>
-          <a:xfrm>
-            <a:off x="0" y="0"/>
-            <a:ext cx="12192000" cy="6858000"/>
-          </a:xfrm>
-          <a:prstGeom prst="rect">
-            <a:avLst/>
-          </a:prstGeom>
-          <a:ln>
-            <a:noFill/>
-          </a:ln>
-          <a:effectLst>
-            <a:softEdge rad="112500"/>
-          </a:effectLst>
-        </p:spPr>
-      </p:pic>
-      <p:sp>
-        <p:nvSpPr>
-          <p:cNvPr id="5" name="TextBox 4">
-            <a:extLst>
-              <a:ext uri="{FF2B5EF4-FFF2-40B4-BE49-F238E27FC236}">
-                <a16:creationId xmlns:a16="http://schemas.microsoft.com/office/drawing/2014/main" id="{9EE76205-8F05-395F-A74B-C70F58E444C7}"/>
-              </a:ext>
-            </a:extLst>
-          </p:cNvPr>
-          <p:cNvSpPr txBox="1"/>
-          <p:nvPr/>
-        </p:nvSpPr>
-        <p:spPr>
-          <a:xfrm>
-            <a:off x="3706749" y="118872"/>
-            <a:ext cx="4778502" cy="1938992"/>
-          </a:xfrm>
-          <a:prstGeom prst="rect">
-            <a:avLst/>
-          </a:prstGeom>
-          <a:noFill/>
-        </p:spPr>
-        <p:txBody>
-          <a:bodyPr wrap="square" rtlCol="0">
-            <a:spAutoFit/>
-          </a:bodyPr>
-          <a:lstStyle/>
-          <a:p>
-            <a:pPr algn="ctr"/>
-            <a:r>
-              <a:rPr lang="en-IN" sz="6000" dirty="0">
-                <a:solidFill>
-                  <a:schemeClr val="bg1"/>
-                </a:solidFill>
-                <a:latin typeface="Book Antiqua" panose="02040602050305030304" pitchFamily="18" charset="0"/>
-              </a:rPr>
-              <a:t>Project</a:t>
-            </a:r>
-          </a:p>
-          <a:p>
-            <a:pPr algn="ctr"/>
-            <a:r>
-              <a:rPr lang="en-IN" sz="6000" dirty="0">
-                <a:solidFill>
-                  <a:schemeClr val="accent4"/>
-                </a:solidFill>
-                <a:latin typeface="Book Antiqua" panose="02040602050305030304" pitchFamily="18" charset="0"/>
-              </a:rPr>
-              <a:t>Introduction</a:t>
-            </a:r>
-          </a:p>
-        </p:txBody>
-      </p:sp>
-      <p:sp>
-        <p:nvSpPr>
-          <p:cNvPr id="7" name="TextBox 6">
-            <a:extLst>
-              <a:ext uri="{FF2B5EF4-FFF2-40B4-BE49-F238E27FC236}">
-                <a16:creationId xmlns:a16="http://schemas.microsoft.com/office/drawing/2014/main" id="{A277F230-8C14-89D3-748C-E57B9B8E29AF}"/>
-              </a:ext>
-            </a:extLst>
-          </p:cNvPr>
-          <p:cNvSpPr txBox="1"/>
-          <p:nvPr/>
-        </p:nvSpPr>
-        <p:spPr>
-          <a:xfrm>
-            <a:off x="1879854" y="2252311"/>
-            <a:ext cx="8432292" cy="2554545"/>
-          </a:xfrm>
-          <a:prstGeom prst="rect">
-            <a:avLst/>
-          </a:prstGeom>
-          <a:noFill/>
-        </p:spPr>
-        <p:txBody>
-          <a:bodyPr wrap="square">
-            <a:spAutoFit/>
-          </a:bodyPr>
-          <a:lstStyle/>
-          <a:p>
-            <a:pPr algn="ctr"/>
-            <a:r>
-              <a:rPr lang="en-US" sz="2000" dirty="0">
-                <a:solidFill>
-                  <a:schemeClr val="bg1"/>
-                </a:solidFill>
-                <a:latin typeface="Bookman Old Style" panose="02050604050505020204" pitchFamily="18" charset="0"/>
-              </a:rPr>
-              <a:t>The </a:t>
-            </a:r>
-            <a:r>
-              <a:rPr lang="en-US" sz="2000" b="1" dirty="0">
-                <a:solidFill>
-                  <a:schemeClr val="bg1"/>
-                </a:solidFill>
-                <a:latin typeface="Bookman Old Style" panose="02050604050505020204" pitchFamily="18" charset="0"/>
-              </a:rPr>
-              <a:t>Amazon Sales Dashboard</a:t>
-            </a:r>
-            <a:r>
-              <a:rPr lang="en-US" sz="2000" dirty="0">
-                <a:solidFill>
-                  <a:schemeClr val="bg1"/>
-                </a:solidFill>
-                <a:latin typeface="Bookman Old Style" panose="02050604050505020204" pitchFamily="18" charset="0"/>
-              </a:rPr>
-              <a:t> is an interactive Power BI project designed to analyze and visualize e-commerce sales data.</a:t>
-            </a:r>
-            <a:br>
-              <a:rPr lang="en-US" sz="2000" dirty="0">
-                <a:solidFill>
-                  <a:schemeClr val="bg1"/>
-                </a:solidFill>
-                <a:latin typeface="Bookman Old Style" panose="02050604050505020204" pitchFamily="18" charset="0"/>
-              </a:rPr>
-            </a:br>
-            <a:r>
-              <a:rPr lang="en-US" sz="2000" dirty="0">
-                <a:solidFill>
-                  <a:schemeClr val="bg1"/>
-                </a:solidFill>
-                <a:latin typeface="Bookman Old Style" panose="02050604050505020204" pitchFamily="18" charset="0"/>
-              </a:rPr>
-              <a:t>It helps businesses monitor key metrics like sales, orders, quantity, fulfilment, and promotions — all in one place.</a:t>
-            </a:r>
-            <a:br>
-              <a:rPr lang="en-US" sz="2000" dirty="0">
-                <a:solidFill>
-                  <a:schemeClr val="bg1"/>
-                </a:solidFill>
-                <a:latin typeface="Bookman Old Style" panose="02050604050505020204" pitchFamily="18" charset="0"/>
-              </a:rPr>
-            </a:br>
-            <a:r>
-              <a:rPr lang="en-US" sz="2000" dirty="0">
-                <a:solidFill>
-                  <a:schemeClr val="bg1"/>
-                </a:solidFill>
-                <a:latin typeface="Bookman Old Style" panose="02050604050505020204" pitchFamily="18" charset="0"/>
-              </a:rPr>
-              <a:t>With real-time insights, this dashboard supports </a:t>
-            </a:r>
-            <a:r>
-              <a:rPr lang="en-US" sz="2000" b="1" dirty="0">
-                <a:solidFill>
-                  <a:schemeClr val="bg1"/>
-                </a:solidFill>
-                <a:latin typeface="Bookman Old Style" panose="02050604050505020204" pitchFamily="18" charset="0"/>
-              </a:rPr>
-              <a:t>data-driven decision-making</a:t>
-            </a:r>
-            <a:r>
-              <a:rPr lang="en-US" sz="2000" dirty="0">
-                <a:solidFill>
-                  <a:schemeClr val="bg1"/>
-                </a:solidFill>
-                <a:latin typeface="Bookman Old Style" panose="02050604050505020204" pitchFamily="18" charset="0"/>
-              </a:rPr>
-              <a:t>, improves </a:t>
-            </a:r>
-            <a:r>
-              <a:rPr lang="en-US" sz="2000" b="1" dirty="0">
-                <a:solidFill>
-                  <a:schemeClr val="bg1"/>
-                </a:solidFill>
-                <a:latin typeface="Bookman Old Style" panose="02050604050505020204" pitchFamily="18" charset="0"/>
-              </a:rPr>
-              <a:t>operational efficiency</a:t>
-            </a:r>
-            <a:r>
-              <a:rPr lang="en-US" sz="2000" dirty="0">
-                <a:solidFill>
-                  <a:schemeClr val="bg1"/>
-                </a:solidFill>
-                <a:latin typeface="Bookman Old Style" panose="02050604050505020204" pitchFamily="18" charset="0"/>
-              </a:rPr>
-              <a:t>, and helps identify </a:t>
-            </a:r>
-            <a:r>
-              <a:rPr lang="en-US" sz="2000" b="1" dirty="0">
-                <a:solidFill>
-                  <a:schemeClr val="bg1"/>
-                </a:solidFill>
-                <a:latin typeface="Bookman Old Style" panose="02050604050505020204" pitchFamily="18" charset="0"/>
-              </a:rPr>
-              <a:t>growth opportunities</a:t>
-            </a:r>
-            <a:r>
-              <a:rPr lang="en-US" sz="2000" dirty="0">
-                <a:solidFill>
-                  <a:schemeClr val="bg1"/>
-                </a:solidFill>
-                <a:latin typeface="Bookman Old Style" panose="02050604050505020204" pitchFamily="18" charset="0"/>
-              </a:rPr>
-              <a:t> across regions and product categories.</a:t>
-            </a:r>
-            <a:endParaRPr lang="en-IN" sz="2000" dirty="0">
-              <a:solidFill>
-                <a:schemeClr val="bg1"/>
-              </a:solidFill>
-              <a:latin typeface="Bookman Old Style" panose="02050604050505020204" pitchFamily="18" charset="0"/>
-            </a:endParaRPr>
-          </a:p>
-        </p:txBody>
-      </p:sp>
-    </p:spTree>
-    <p:extLst>
-      <p:ext uri="{BB962C8B-B14F-4D97-AF65-F5344CB8AC3E}">
-        <p14:creationId xmlns:p14="http://schemas.microsoft.com/office/powerpoint/2010/main" val="177487879"/>
-      </p:ext>
-    </p:extLst>
-  </p:cSld>
-  <p:clrMapOvr>
-    <a:masterClrMapping/>
-  </p:clrMapOvr>
-</p:sld>
-</file>
-
-<file path=ppt/slides/slide20.xml><?xml version="1.0" encoding="utf-8"?>
+<file path=ppt/slides/slide22.xml><?xml version="1.0" encoding="utf-8"?>
 <p:sld xmlns:a="http://schemas.openxmlformats.org/drawingml/2006/main" xmlns:r="http://schemas.openxmlformats.org/officeDocument/2006/relationships" xmlns:p="http://schemas.openxmlformats.org/presentationml/2006/main">
   <p:cSld>
     <p:spTree>
@@ -5709,7 +7276,7 @@
 </p:sld>
 </file>
 
-<file path=ppt/slides/slide21.xml><?xml version="1.0" encoding="utf-8"?>
+<file path=ppt/slides/slide23.xml><?xml version="1.0" encoding="utf-8"?>
 <p:sld xmlns:a="http://schemas.openxmlformats.org/drawingml/2006/main" xmlns:r="http://schemas.openxmlformats.org/officeDocument/2006/relationships" xmlns:p="http://schemas.openxmlformats.org/presentationml/2006/main">
   <p:cSld>
     <p:spTree>
@@ -5887,7 +7454,7 @@
 </p:sld>
 </file>
 
-<file path=ppt/slides/slide22.xml><?xml version="1.0" encoding="utf-8"?>
+<file path=ppt/slides/slide24.xml><?xml version="1.0" encoding="utf-8"?>
 <p:sld xmlns:a="http://schemas.openxmlformats.org/drawingml/2006/main" xmlns:r="http://schemas.openxmlformats.org/officeDocument/2006/relationships" xmlns:p="http://schemas.openxmlformats.org/presentationml/2006/main">
   <p:cSld>
     <p:spTree>
@@ -5959,7 +7526,7 @@
 </p:sld>
 </file>
 
-<file path=ppt/slides/slide23.xml><?xml version="1.0" encoding="utf-8"?>
+<file path=ppt/slides/slide25.xml><?xml version="1.0" encoding="utf-8"?>
 <p:sld xmlns:a="http://schemas.openxmlformats.org/drawingml/2006/main" xmlns:r="http://schemas.openxmlformats.org/officeDocument/2006/relationships" xmlns:p="http://schemas.openxmlformats.org/presentationml/2006/main">
   <p:cSld>
     <p:spTree>
@@ -6137,7 +7704,7 @@
 </p:sld>
 </file>
 
-<file path=ppt/slides/slide24.xml><?xml version="1.0" encoding="utf-8"?>
+<file path=ppt/slides/slide26.xml><?xml version="1.0" encoding="utf-8"?>
 <p:sld xmlns:a="http://schemas.openxmlformats.org/drawingml/2006/main" xmlns:r="http://schemas.openxmlformats.org/officeDocument/2006/relationships" xmlns:p="http://schemas.openxmlformats.org/presentationml/2006/main">
   <p:cSld>
     <p:spTree>
@@ -6209,7 +7776,7 @@
 </p:sld>
 </file>
 
-<file path=ppt/slides/slide25.xml><?xml version="1.0" encoding="utf-8"?>
+<file path=ppt/slides/slide27.xml><?xml version="1.0" encoding="utf-8"?>
 <p:sld xmlns:a="http://schemas.openxmlformats.org/drawingml/2006/main" xmlns:r="http://schemas.openxmlformats.org/officeDocument/2006/relationships" xmlns:p="http://schemas.openxmlformats.org/presentationml/2006/main">
   <p:cSld>
     <p:spTree>
@@ -7921,7 +9488,7 @@
             <p:spPr>
               <a:xfrm>
                 <a:off x="6690360" y="2181955"/>
-                <a:ext cx="3550920" cy="830997"/>
+                <a:ext cx="3550919" cy="830997"/>
               </a:xfrm>
               <a:prstGeom prst="rect">
                 <a:avLst/>
@@ -7948,7 +9515,7 @@
               <a:p>
                 <a:r>
                   <a:rPr lang="en-IN" sz="2400" dirty="0"/>
-                  <a:t>Exploratory Data Analysis (EDA)</a:t>
+                  <a:t>Data Cleaning &amp; Transformation</a:t>
                 </a:r>
               </a:p>
             </p:txBody>
@@ -7995,7 +9562,7 @@
               <a:p>
                 <a:r>
                   <a:rPr lang="en-IN" sz="2400" dirty="0"/>
-                  <a:t>Data Cleaning &amp; Transformation</a:t>
+                  <a:t>Exploratory Data Analysis (EDA)</a:t>
                 </a:r>
               </a:p>
             </p:txBody>

</xml_diff>